<commit_message>
site: schema des 8 couches elargi a 860, libelles d'unites entierement a gauche de la fleche; slides: fond blanc aligne sur le site, filets et puces assombris pour rester lisibles
</commit_message>
<xml_diff>
--- a/slides/Genese-de-l-IA.pptx
+++ b/slides/Genese-de-l-IA.pptx
@@ -1302,7 +1302,7 @@
     <p:bg>
       <p:bgPr>
         <a:solidFill>
-          <a:srgbClr val="07295C"/>
+          <a:srgbClr val="FBFBFD"/>
         </a:solidFill>
       </p:bgPr>
     </p:bg>
@@ -1347,7 +1347,7 @@
             <a:r>
               <a:rPr lang="en-US" sz="1100" b="1" spc="300" kern="0" dirty="0">
                 <a:solidFill>
-                  <a:srgbClr val="6FB8FF"/>
+                  <a:srgbClr val="0071E3"/>
                 </a:solidFill>
                 <a:latin typeface="Calibri" pitchFamily="34" charset="0"/>
                 <a:ea typeface="Calibri" pitchFamily="34" charset="-122"/>
@@ -1389,7 +1389,7 @@
             <a:r>
               <a:rPr lang="en-US" sz="4200" b="1" dirty="0">
                 <a:solidFill>
-                  <a:srgbClr val="FFFFFF"/>
+                  <a:srgbClr val="1D1D1F"/>
                 </a:solidFill>
                 <a:latin typeface="Calibri" pitchFamily="34" charset="0"/>
                 <a:ea typeface="Calibri" pitchFamily="34" charset="-122"/>
@@ -1409,7 +1409,7 @@
             <a:r>
               <a:rPr lang="en-US" sz="4200" b="1" dirty="0">
                 <a:solidFill>
-                  <a:srgbClr val="FFFFFF"/>
+                  <a:srgbClr val="1D1D1F"/>
                 </a:solidFill>
                 <a:latin typeface="Calibri" pitchFamily="34" charset="0"/>
                 <a:ea typeface="Calibri" pitchFamily="34" charset="-122"/>
@@ -1448,7 +1448,7 @@
             <a:r>
               <a:rPr lang="en-US" sz="1500" dirty="0">
                 <a:solidFill>
-                  <a:srgbClr val="A9BFE0"/>
+                  <a:srgbClr val="6E6E73"/>
                 </a:solidFill>
                 <a:latin typeface="Calibri Light" pitchFamily="34" charset="0"/>
                 <a:ea typeface="Calibri Light" pitchFamily="34" charset="-122"/>
@@ -1501,7 +1501,7 @@
           <a:noFill/>
           <a:ln w="25400">
             <a:solidFill>
-              <a:srgbClr val="3E74B8"/>
+              <a:srgbClr val="A9A9AF"/>
             </a:solidFill>
             <a:prstDash val="solid"/>
           </a:ln>
@@ -1522,7 +1522,7 @@
             <a:avLst/>
           </a:prstGeom>
           <a:solidFill>
-            <a:srgbClr val="6FB8FF"/>
+            <a:srgbClr val="0071E3"/>
           </a:solidFill>
           <a:ln/>
         </p:spPr>
@@ -1554,7 +1554,7 @@
             <a:r>
               <a:rPr lang="en-US" sz="1600" b="1" dirty="0">
                 <a:solidFill>
-                  <a:srgbClr val="CDE3FF"/>
+                  <a:srgbClr val="0071E3"/>
                 </a:solidFill>
                 <a:latin typeface="Calibri" pitchFamily="34" charset="0"/>
                 <a:ea typeface="Calibri" pitchFamily="34" charset="-122"/>
@@ -1593,7 +1593,7 @@
             <a:r>
               <a:rPr lang="en-US" sz="1250" b="1" dirty="0">
                 <a:solidFill>
-                  <a:srgbClr val="FFFFFF"/>
+                  <a:srgbClr val="1D1D1F"/>
                 </a:solidFill>
                 <a:latin typeface="Calibri" pitchFamily="34" charset="0"/>
                 <a:ea typeface="Calibri" pitchFamily="34" charset="-122"/>
@@ -1632,7 +1632,7 @@
             <a:r>
               <a:rPr lang="en-US" sz="1050" dirty="0">
                 <a:solidFill>
-                  <a:srgbClr val="A9BFE0"/>
+                  <a:srgbClr val="6E6E73"/>
                 </a:solidFill>
                 <a:latin typeface="Calibri Light" pitchFamily="34" charset="0"/>
                 <a:ea typeface="Calibri Light" pitchFamily="34" charset="-122"/>
@@ -1659,7 +1659,7 @@
             <a:avLst/>
           </a:prstGeom>
           <a:solidFill>
-            <a:srgbClr val="6FB8FF"/>
+            <a:srgbClr val="0071E3"/>
           </a:solidFill>
           <a:ln/>
         </p:spPr>
@@ -1691,7 +1691,7 @@
             <a:r>
               <a:rPr lang="en-US" sz="1600" b="1" dirty="0">
                 <a:solidFill>
-                  <a:srgbClr val="CDE3FF"/>
+                  <a:srgbClr val="0071E3"/>
                 </a:solidFill>
                 <a:latin typeface="Calibri" pitchFamily="34" charset="0"/>
                 <a:ea typeface="Calibri" pitchFamily="34" charset="-122"/>
@@ -1730,7 +1730,7 @@
             <a:r>
               <a:rPr lang="en-US" sz="1250" b="1" dirty="0">
                 <a:solidFill>
-                  <a:srgbClr val="FFFFFF"/>
+                  <a:srgbClr val="1D1D1F"/>
                 </a:solidFill>
                 <a:latin typeface="Calibri" pitchFamily="34" charset="0"/>
                 <a:ea typeface="Calibri" pitchFamily="34" charset="-122"/>
@@ -1769,7 +1769,7 @@
             <a:r>
               <a:rPr lang="en-US" sz="1050" dirty="0">
                 <a:solidFill>
-                  <a:srgbClr val="A9BFE0"/>
+                  <a:srgbClr val="6E6E73"/>
                 </a:solidFill>
                 <a:latin typeface="Calibri Light" pitchFamily="34" charset="0"/>
                 <a:ea typeface="Calibri Light" pitchFamily="34" charset="-122"/>
@@ -1796,7 +1796,7 @@
             <a:avLst/>
           </a:prstGeom>
           <a:solidFill>
-            <a:srgbClr val="6FB8FF"/>
+            <a:srgbClr val="0071E3"/>
           </a:solidFill>
           <a:ln/>
         </p:spPr>
@@ -1828,7 +1828,7 @@
             <a:r>
               <a:rPr lang="en-US" sz="1600" b="1" dirty="0">
                 <a:solidFill>
-                  <a:srgbClr val="CDE3FF"/>
+                  <a:srgbClr val="0071E3"/>
                 </a:solidFill>
                 <a:latin typeface="Calibri" pitchFamily="34" charset="0"/>
                 <a:ea typeface="Calibri" pitchFamily="34" charset="-122"/>
@@ -1867,7 +1867,7 @@
             <a:r>
               <a:rPr lang="en-US" sz="1250" b="1" dirty="0">
                 <a:solidFill>
-                  <a:srgbClr val="FFFFFF"/>
+                  <a:srgbClr val="1D1D1F"/>
                 </a:solidFill>
                 <a:latin typeface="Calibri" pitchFamily="34" charset="0"/>
                 <a:ea typeface="Calibri" pitchFamily="34" charset="-122"/>
@@ -1906,7 +1906,7 @@
             <a:r>
               <a:rPr lang="en-US" sz="1050" dirty="0">
                 <a:solidFill>
-                  <a:srgbClr val="A9BFE0"/>
+                  <a:srgbClr val="6E6E73"/>
                 </a:solidFill>
                 <a:latin typeface="Calibri Light" pitchFamily="34" charset="0"/>
                 <a:ea typeface="Calibri Light" pitchFamily="34" charset="-122"/>
@@ -1933,7 +1933,7 @@
             <a:avLst/>
           </a:prstGeom>
           <a:solidFill>
-            <a:srgbClr val="F0A64A"/>
+            <a:srgbClr val="A04E00"/>
           </a:solidFill>
           <a:ln/>
         </p:spPr>
@@ -1965,7 +1965,7 @@
             <a:r>
               <a:rPr lang="en-US" sz="1600" b="1" dirty="0">
                 <a:solidFill>
-                  <a:srgbClr val="F0A64A"/>
+                  <a:srgbClr val="A04E00"/>
                 </a:solidFill>
                 <a:latin typeface="Calibri" pitchFamily="34" charset="0"/>
                 <a:ea typeface="Calibri" pitchFamily="34" charset="-122"/>
@@ -2004,7 +2004,7 @@
             <a:r>
               <a:rPr lang="en-US" sz="1250" b="1" dirty="0">
                 <a:solidFill>
-                  <a:srgbClr val="FFFFFF"/>
+                  <a:srgbClr val="1D1D1F"/>
                 </a:solidFill>
                 <a:latin typeface="Calibri" pitchFamily="34" charset="0"/>
                 <a:ea typeface="Calibri" pitchFamily="34" charset="-122"/>
@@ -2043,7 +2043,7 @@
             <a:r>
               <a:rPr lang="en-US" sz="1050" dirty="0">
                 <a:solidFill>
-                  <a:srgbClr val="A9BFE0"/>
+                  <a:srgbClr val="6E6E73"/>
                 </a:solidFill>
                 <a:latin typeface="Calibri Light" pitchFamily="34" charset="0"/>
                 <a:ea typeface="Calibri Light" pitchFamily="34" charset="-122"/>
@@ -2070,7 +2070,7 @@
             <a:avLst/>
           </a:prstGeom>
           <a:solidFill>
-            <a:srgbClr val="6FB8FF"/>
+            <a:srgbClr val="0071E3"/>
           </a:solidFill>
           <a:ln/>
         </p:spPr>
@@ -2102,7 +2102,7 @@
             <a:r>
               <a:rPr lang="en-US" sz="1600" b="1" dirty="0">
                 <a:solidFill>
-                  <a:srgbClr val="CDE3FF"/>
+                  <a:srgbClr val="0071E3"/>
                 </a:solidFill>
                 <a:latin typeface="Calibri" pitchFamily="34" charset="0"/>
                 <a:ea typeface="Calibri" pitchFamily="34" charset="-122"/>
@@ -2141,7 +2141,7 @@
             <a:r>
               <a:rPr lang="en-US" sz="1250" b="1" dirty="0">
                 <a:solidFill>
-                  <a:srgbClr val="FFFFFF"/>
+                  <a:srgbClr val="1D1D1F"/>
                 </a:solidFill>
                 <a:latin typeface="Calibri" pitchFamily="34" charset="0"/>
                 <a:ea typeface="Calibri" pitchFamily="34" charset="-122"/>
@@ -2180,7 +2180,7 @@
             <a:r>
               <a:rPr lang="en-US" sz="1050" dirty="0">
                 <a:solidFill>
-                  <a:srgbClr val="A9BFE0"/>
+                  <a:srgbClr val="6E6E73"/>
                 </a:solidFill>
                 <a:latin typeface="Calibri Light" pitchFamily="34" charset="0"/>
                 <a:ea typeface="Calibri Light" pitchFamily="34" charset="-122"/>
@@ -2207,7 +2207,7 @@
             <a:avLst/>
           </a:prstGeom>
           <a:solidFill>
-            <a:srgbClr val="6FB8FF"/>
+            <a:srgbClr val="0071E3"/>
           </a:solidFill>
           <a:ln/>
         </p:spPr>
@@ -2239,7 +2239,7 @@
             <a:r>
               <a:rPr lang="en-US" sz="1600" b="1" dirty="0">
                 <a:solidFill>
-                  <a:srgbClr val="CDE3FF"/>
+                  <a:srgbClr val="0071E3"/>
                 </a:solidFill>
                 <a:latin typeface="Calibri" pitchFamily="34" charset="0"/>
                 <a:ea typeface="Calibri" pitchFamily="34" charset="-122"/>
@@ -2278,7 +2278,7 @@
             <a:r>
               <a:rPr lang="en-US" sz="1250" b="1" dirty="0">
                 <a:solidFill>
-                  <a:srgbClr val="FFFFFF"/>
+                  <a:srgbClr val="1D1D1F"/>
                 </a:solidFill>
                 <a:latin typeface="Calibri" pitchFamily="34" charset="0"/>
                 <a:ea typeface="Calibri" pitchFamily="34" charset="-122"/>
@@ -2317,7 +2317,7 @@
             <a:r>
               <a:rPr lang="en-US" sz="1050" dirty="0">
                 <a:solidFill>
-                  <a:srgbClr val="A9BFE0"/>
+                  <a:srgbClr val="6E6E73"/>
                 </a:solidFill>
                 <a:latin typeface="Calibri Light" pitchFamily="34" charset="0"/>
                 <a:ea typeface="Calibri Light" pitchFamily="34" charset="-122"/>
@@ -2356,7 +2356,7 @@
             <a:r>
               <a:rPr lang="en-US" sz="1050" i="1" dirty="0">
                 <a:solidFill>
-                  <a:srgbClr val="F0A64A"/>
+                  <a:srgbClr val="A04E00"/>
                 </a:solidFill>
                 <a:latin typeface="Calibri Light" pitchFamily="34" charset="0"/>
                 <a:ea typeface="Calibri Light" pitchFamily="34" charset="-122"/>
@@ -2395,7 +2395,7 @@
             <a:r>
               <a:rPr lang="en-US" sz="1400" i="1" dirty="0">
                 <a:solidFill>
-                  <a:srgbClr val="CDE3FF"/>
+                  <a:srgbClr val="6E6E73"/>
                 </a:solidFill>
                 <a:latin typeface="Calibri Light" pitchFamily="34" charset="0"/>
                 <a:ea typeface="Calibri Light" pitchFamily="34" charset="-122"/>
@@ -2421,7 +2421,7 @@
     <p:bg>
       <p:bgPr>
         <a:solidFill>
-          <a:srgbClr val="07295C"/>
+          <a:srgbClr val="FBFBFD"/>
         </a:solidFill>
       </p:bgPr>
     </p:bg>
@@ -2466,7 +2466,7 @@
             <a:r>
               <a:rPr lang="en-US" sz="1100" b="1" spc="300" kern="0" dirty="0">
                 <a:solidFill>
-                  <a:srgbClr val="6FB8FF"/>
+                  <a:srgbClr val="0071E3"/>
                 </a:solidFill>
                 <a:latin typeface="Calibri" pitchFamily="34" charset="0"/>
                 <a:ea typeface="Calibri" pitchFamily="34" charset="-122"/>
@@ -2505,7 +2505,7 @@
             <a:r>
               <a:rPr lang="en-US" sz="3800" b="1" dirty="0">
                 <a:solidFill>
-                  <a:srgbClr val="FFFFFF"/>
+                  <a:srgbClr val="1D1D1F"/>
                 </a:solidFill>
                 <a:latin typeface="Calibri" pitchFamily="34" charset="0"/>
                 <a:ea typeface="Calibri" pitchFamily="34" charset="-122"/>
@@ -2544,7 +2544,7 @@
             <a:r>
               <a:rPr lang="en-US" sz="1500" dirty="0">
                 <a:solidFill>
-                  <a:srgbClr val="A9BFE0"/>
+                  <a:srgbClr val="6E6E73"/>
                 </a:solidFill>
                 <a:latin typeface="Calibri Light" pitchFamily="34" charset="0"/>
                 <a:ea typeface="Calibri Light" pitchFamily="34" charset="-122"/>
@@ -2575,9 +2575,9 @@
           </a:solidFill>
           <a:ln/>
           <a:effectLst>
-            <a:outerShdw sx="100000" sy="100000" kx="0" ky="0" algn="bl" rotWithShape="0" blurRad="127000" dist="25400" dir="8100000">
+            <a:outerShdw sx="100000" sy="100000" kx="0" ky="0" algn="bl" rotWithShape="0" blurRad="203200" dist="38100" dir="8100000">
               <a:srgbClr val="000000">
-                <a:alpha val="10000"/>
+                <a:alpha val="18000"/>
               </a:srgbClr>
             </a:outerShdw>
           </a:effectLst>
@@ -2598,7 +2598,7 @@
             <a:avLst/>
           </a:prstGeom>
           <a:solidFill>
-            <a:srgbClr val="D3D9E4"/>
+            <a:srgbClr val="A9A9AF"/>
           </a:solidFill>
           <a:ln/>
         </p:spPr>
@@ -2698,7 +2698,7 @@
             </a:avLst>
           </a:prstGeom>
           <a:solidFill>
-            <a:srgbClr val="F2F5FA"/>
+            <a:srgbClr val="F5F5F7"/>
           </a:solidFill>
           <a:ln/>
         </p:spPr>
@@ -2730,7 +2730,7 @@
             <a:r>
               <a:rPr lang="en-US" sz="1100" b="1" dirty="0">
                 <a:solidFill>
-                  <a:srgbClr val="0071E3"/>
+                  <a:srgbClr val="005BB8"/>
                 </a:solidFill>
                 <a:latin typeface="Calibri" pitchFamily="34" charset="0"/>
                 <a:ea typeface="Calibri" pitchFamily="34" charset="-122"/>
@@ -2798,7 +2798,7 @@
             </a:avLst>
           </a:prstGeom>
           <a:solidFill>
-            <a:srgbClr val="F2F5FA"/>
+            <a:srgbClr val="F5F5F7"/>
           </a:solidFill>
           <a:ln/>
         </p:spPr>
@@ -2830,7 +2830,7 @@
             <a:r>
               <a:rPr lang="en-US" sz="1100" b="1" dirty="0">
                 <a:solidFill>
-                  <a:srgbClr val="0071E3"/>
+                  <a:srgbClr val="005BB8"/>
                 </a:solidFill>
                 <a:latin typeface="Calibri" pitchFamily="34" charset="0"/>
                 <a:ea typeface="Calibri" pitchFamily="34" charset="-122"/>
@@ -2898,7 +2898,7 @@
             </a:avLst>
           </a:prstGeom>
           <a:solidFill>
-            <a:srgbClr val="F2F5FA"/>
+            <a:srgbClr val="F5F5F7"/>
           </a:solidFill>
           <a:ln/>
         </p:spPr>
@@ -2930,7 +2930,7 @@
             <a:r>
               <a:rPr lang="en-US" sz="1100" b="1" dirty="0">
                 <a:solidFill>
-                  <a:srgbClr val="0071E3"/>
+                  <a:srgbClr val="005BB8"/>
                 </a:solidFill>
                 <a:latin typeface="Calibri" pitchFamily="34" charset="0"/>
                 <a:ea typeface="Calibri" pitchFamily="34" charset="-122"/>
@@ -2998,7 +2998,7 @@
             </a:avLst>
           </a:prstGeom>
           <a:solidFill>
-            <a:srgbClr val="F2F5FA"/>
+            <a:srgbClr val="F5F5F7"/>
           </a:solidFill>
           <a:ln/>
         </p:spPr>
@@ -3030,7 +3030,7 @@
             <a:r>
               <a:rPr lang="en-US" sz="1100" b="1" dirty="0">
                 <a:solidFill>
-                  <a:srgbClr val="0071E3"/>
+                  <a:srgbClr val="005BB8"/>
                 </a:solidFill>
                 <a:latin typeface="Calibri" pitchFamily="34" charset="0"/>
                 <a:ea typeface="Calibri" pitchFamily="34" charset="-122"/>
@@ -3098,7 +3098,7 @@
             </a:avLst>
           </a:prstGeom>
           <a:solidFill>
-            <a:srgbClr val="F2F5FA"/>
+            <a:srgbClr val="F5F5F7"/>
           </a:solidFill>
           <a:ln/>
         </p:spPr>
@@ -3130,7 +3130,7 @@
             <a:r>
               <a:rPr lang="en-US" sz="1100" b="1" dirty="0">
                 <a:solidFill>
-                  <a:srgbClr val="0071E3"/>
+                  <a:srgbClr val="005BB8"/>
                 </a:solidFill>
                 <a:latin typeface="Calibri" pitchFamily="34" charset="0"/>
                 <a:ea typeface="Calibri" pitchFamily="34" charset="-122"/>
@@ -3239,9 +3239,9 @@
           </a:solidFill>
           <a:ln/>
           <a:effectLst>
-            <a:outerShdw sx="100000" sy="100000" kx="0" ky="0" algn="bl" rotWithShape="0" blurRad="127000" dist="25400" dir="8100000">
+            <a:outerShdw sx="100000" sy="100000" kx="0" ky="0" algn="bl" rotWithShape="0" blurRad="203200" dist="38100" dir="8100000">
               <a:srgbClr val="000000">
-                <a:alpha val="10000"/>
+                <a:alpha val="18000"/>
               </a:srgbClr>
             </a:outerShdw>
           </a:effectLst>
@@ -3362,7 +3362,7 @@
             </a:avLst>
           </a:prstGeom>
           <a:solidFill>
-            <a:srgbClr val="F2F5FA"/>
+            <a:srgbClr val="F5F5F7"/>
           </a:solidFill>
           <a:ln/>
         </p:spPr>
@@ -3394,7 +3394,7 @@
             <a:r>
               <a:rPr lang="en-US" sz="1100" b="1" dirty="0">
                 <a:solidFill>
-                  <a:srgbClr val="0071E3"/>
+                  <a:srgbClr val="005BB8"/>
                 </a:solidFill>
                 <a:latin typeface="Calibri" pitchFamily="34" charset="0"/>
                 <a:ea typeface="Calibri" pitchFamily="34" charset="-122"/>
@@ -3462,7 +3462,7 @@
             </a:avLst>
           </a:prstGeom>
           <a:solidFill>
-            <a:srgbClr val="F2F5FA"/>
+            <a:srgbClr val="F5F5F7"/>
           </a:solidFill>
           <a:ln/>
         </p:spPr>
@@ -3494,7 +3494,7 @@
             <a:r>
               <a:rPr lang="en-US" sz="1100" b="1" dirty="0">
                 <a:solidFill>
-                  <a:srgbClr val="0071E3"/>
+                  <a:srgbClr val="005BB8"/>
                 </a:solidFill>
                 <a:latin typeface="Calibri" pitchFamily="34" charset="0"/>
                 <a:ea typeface="Calibri" pitchFamily="34" charset="-122"/>
@@ -3662,7 +3662,7 @@
             </a:avLst>
           </a:prstGeom>
           <a:solidFill>
-            <a:srgbClr val="F2F5FA"/>
+            <a:srgbClr val="F5F5F7"/>
           </a:solidFill>
           <a:ln/>
         </p:spPr>
@@ -3694,7 +3694,7 @@
             <a:r>
               <a:rPr lang="en-US" sz="1100" b="1" dirty="0">
                 <a:solidFill>
-                  <a:srgbClr val="0071E3"/>
+                  <a:srgbClr val="005BB8"/>
                 </a:solidFill>
                 <a:latin typeface="Calibri" pitchFamily="34" charset="0"/>
                 <a:ea typeface="Calibri" pitchFamily="34" charset="-122"/>
@@ -3762,7 +3762,7 @@
             </a:avLst>
           </a:prstGeom>
           <a:solidFill>
-            <a:srgbClr val="F2F5FA"/>
+            <a:srgbClr val="F5F5F7"/>
           </a:solidFill>
           <a:ln/>
         </p:spPr>
@@ -3794,7 +3794,7 @@
             <a:r>
               <a:rPr lang="en-US" sz="1100" b="1" dirty="0">
                 <a:solidFill>
-                  <a:srgbClr val="0071E3"/>
+                  <a:srgbClr val="005BB8"/>
                 </a:solidFill>
                 <a:latin typeface="Calibri" pitchFamily="34" charset="0"/>
                 <a:ea typeface="Calibri" pitchFamily="34" charset="-122"/>
@@ -3903,9 +3903,9 @@
           </a:solidFill>
           <a:ln/>
           <a:effectLst>
-            <a:outerShdw sx="100000" sy="100000" kx="0" ky="0" algn="bl" rotWithShape="0" blurRad="127000" dist="25400" dir="8100000">
+            <a:outerShdw sx="100000" sy="100000" kx="0" ky="0" algn="bl" rotWithShape="0" blurRad="203200" dist="38100" dir="8100000">
               <a:srgbClr val="000000">
-                <a:alpha val="10000"/>
+                <a:alpha val="18000"/>
               </a:srgbClr>
             </a:outerShdw>
           </a:effectLst>
@@ -3926,7 +3926,7 @@
             <a:avLst/>
           </a:prstGeom>
           <a:solidFill>
-            <a:srgbClr val="D3D9E4"/>
+            <a:srgbClr val="A9A9AF"/>
           </a:solidFill>
           <a:ln/>
         </p:spPr>
@@ -4026,7 +4026,7 @@
             </a:avLst>
           </a:prstGeom>
           <a:solidFill>
-            <a:srgbClr val="F2F5FA"/>
+            <a:srgbClr val="F5F5F7"/>
           </a:solidFill>
           <a:ln/>
         </p:spPr>
@@ -4058,7 +4058,7 @@
             <a:r>
               <a:rPr lang="en-US" sz="1100" b="1" dirty="0">
                 <a:solidFill>
-                  <a:srgbClr val="0071E3"/>
+                  <a:srgbClr val="005BB8"/>
                 </a:solidFill>
                 <a:latin typeface="Calibri" pitchFamily="34" charset="0"/>
                 <a:ea typeface="Calibri" pitchFamily="34" charset="-122"/>
@@ -4126,7 +4126,7 @@
             </a:avLst>
           </a:prstGeom>
           <a:solidFill>
-            <a:srgbClr val="F2F5FA"/>
+            <a:srgbClr val="F5F5F7"/>
           </a:solidFill>
           <a:ln/>
         </p:spPr>
@@ -4158,7 +4158,7 @@
             <a:r>
               <a:rPr lang="en-US" sz="1100" b="1" dirty="0">
                 <a:solidFill>
-                  <a:srgbClr val="0071E3"/>
+                  <a:srgbClr val="005BB8"/>
                 </a:solidFill>
                 <a:latin typeface="Calibri" pitchFamily="34" charset="0"/>
                 <a:ea typeface="Calibri" pitchFamily="34" charset="-122"/>
@@ -4226,7 +4226,7 @@
             </a:avLst>
           </a:prstGeom>
           <a:solidFill>
-            <a:srgbClr val="F2F5FA"/>
+            <a:srgbClr val="F5F5F7"/>
           </a:solidFill>
           <a:ln/>
         </p:spPr>
@@ -4258,7 +4258,7 @@
             <a:r>
               <a:rPr lang="en-US" sz="1100" b="1" dirty="0">
                 <a:solidFill>
-                  <a:srgbClr val="0071E3"/>
+                  <a:srgbClr val="005BB8"/>
                 </a:solidFill>
                 <a:latin typeface="Calibri" pitchFamily="34" charset="0"/>
                 <a:ea typeface="Calibri" pitchFamily="34" charset="-122"/>
@@ -4455,7 +4455,7 @@
     <p:bg>
       <p:bgPr>
         <a:solidFill>
-          <a:srgbClr val="07295C"/>
+          <a:srgbClr val="FBFBFD"/>
         </a:solidFill>
       </p:bgPr>
     </p:bg>
@@ -4500,7 +4500,7 @@
             <a:r>
               <a:rPr lang="en-US" sz="1100" b="1" spc="300" kern="0" dirty="0">
                 <a:solidFill>
-                  <a:srgbClr val="6FB8FF"/>
+                  <a:srgbClr val="0071E3"/>
                 </a:solidFill>
                 <a:latin typeface="Calibri" pitchFamily="34" charset="0"/>
                 <a:ea typeface="Calibri" pitchFamily="34" charset="-122"/>
@@ -4539,7 +4539,7 @@
             <a:r>
               <a:rPr lang="en-US" sz="3800" b="1" dirty="0">
                 <a:solidFill>
-                  <a:srgbClr val="FFFFFF"/>
+                  <a:srgbClr val="1D1D1F"/>
                 </a:solidFill>
                 <a:latin typeface="Calibri" pitchFamily="34" charset="0"/>
                 <a:ea typeface="Calibri" pitchFamily="34" charset="-122"/>
@@ -4578,7 +4578,7 @@
             <a:r>
               <a:rPr lang="en-US" sz="1500" dirty="0">
                 <a:solidFill>
-                  <a:srgbClr val="A9BFE0"/>
+                  <a:srgbClr val="6E6E73"/>
                 </a:solidFill>
                 <a:latin typeface="Calibri Light" pitchFamily="34" charset="0"/>
                 <a:ea typeface="Calibri Light" pitchFamily="34" charset="-122"/>
@@ -4609,9 +4609,9 @@
           </a:solidFill>
           <a:ln/>
           <a:effectLst>
-            <a:outerShdw sx="100000" sy="100000" kx="0" ky="0" algn="bl" rotWithShape="0" blurRad="127000" dist="25400" dir="8100000">
+            <a:outerShdw sx="100000" sy="100000" kx="0" ky="0" algn="bl" rotWithShape="0" blurRad="203200" dist="38100" dir="8100000">
               <a:srgbClr val="000000">
-                <a:alpha val="10000"/>
+                <a:alpha val="18000"/>
               </a:srgbClr>
             </a:outerShdw>
           </a:effectLst>
@@ -4712,7 +4712,7 @@
           <a:noFill/>
           <a:ln w="12700">
             <a:solidFill>
-              <a:srgbClr val="D3D9E4"/>
+              <a:srgbClr val="A9A9AF"/>
             </a:solidFill>
             <a:prstDash val="solid"/>
           </a:ln>
@@ -4735,7 +4735,7 @@
           <a:noFill/>
           <a:ln w="12700">
             <a:solidFill>
-              <a:srgbClr val="D3D9E4"/>
+              <a:srgbClr val="A9A9AF"/>
             </a:solidFill>
             <a:prstDash val="solid"/>
           </a:ln>
@@ -4758,7 +4758,7 @@
           <a:noFill/>
           <a:ln w="12700">
             <a:solidFill>
-              <a:srgbClr val="D3D9E4"/>
+              <a:srgbClr val="A9A9AF"/>
             </a:solidFill>
             <a:prstDash val="solid"/>
           </a:ln>
@@ -4781,7 +4781,7 @@
           <a:noFill/>
           <a:ln w="12700">
             <a:solidFill>
-              <a:srgbClr val="D3D9E4"/>
+              <a:srgbClr val="A9A9AF"/>
             </a:solidFill>
             <a:prstDash val="solid"/>
           </a:ln>
@@ -4804,7 +4804,7 @@
           <a:noFill/>
           <a:ln w="12700">
             <a:solidFill>
-              <a:srgbClr val="D3D9E4"/>
+              <a:srgbClr val="A9A9AF"/>
             </a:solidFill>
             <a:prstDash val="solid"/>
           </a:ln>
@@ -4827,7 +4827,7 @@
           <a:noFill/>
           <a:ln w="12700">
             <a:solidFill>
-              <a:srgbClr val="D3D9E4"/>
+              <a:srgbClr val="A9A9AF"/>
             </a:solidFill>
             <a:prstDash val="solid"/>
           </a:ln>
@@ -4850,7 +4850,7 @@
           <a:noFill/>
           <a:ln w="12700">
             <a:solidFill>
-              <a:srgbClr val="D3D9E4"/>
+              <a:srgbClr val="A9A9AF"/>
             </a:solidFill>
             <a:prstDash val="solid"/>
           </a:ln>
@@ -4873,7 +4873,7 @@
           <a:noFill/>
           <a:ln w="12700">
             <a:solidFill>
-              <a:srgbClr val="D3D9E4"/>
+              <a:srgbClr val="A9A9AF"/>
             </a:solidFill>
             <a:prstDash val="solid"/>
           </a:ln>
@@ -4896,7 +4896,7 @@
           <a:noFill/>
           <a:ln w="12700">
             <a:solidFill>
-              <a:srgbClr val="D3D9E4"/>
+              <a:srgbClr val="A9A9AF"/>
             </a:solidFill>
             <a:prstDash val="solid"/>
           </a:ln>
@@ -4919,7 +4919,7 @@
           <a:noFill/>
           <a:ln w="12700">
             <a:solidFill>
-              <a:srgbClr val="D3D9E4"/>
+              <a:srgbClr val="A9A9AF"/>
             </a:solidFill>
             <a:prstDash val="solid"/>
           </a:ln>
@@ -4942,7 +4942,7 @@
           <a:noFill/>
           <a:ln w="12700">
             <a:solidFill>
-              <a:srgbClr val="D3D9E4"/>
+              <a:srgbClr val="A9A9AF"/>
             </a:solidFill>
             <a:prstDash val="solid"/>
           </a:ln>
@@ -4965,7 +4965,7 @@
           <a:noFill/>
           <a:ln w="12700">
             <a:solidFill>
-              <a:srgbClr val="D3D9E4"/>
+              <a:srgbClr val="A9A9AF"/>
             </a:solidFill>
             <a:prstDash val="solid"/>
           </a:ln>
@@ -4988,7 +4988,7 @@
           <a:noFill/>
           <a:ln w="12700">
             <a:solidFill>
-              <a:srgbClr val="D3D9E4"/>
+              <a:srgbClr val="A9A9AF"/>
             </a:solidFill>
             <a:prstDash val="solid"/>
           </a:ln>
@@ -5011,7 +5011,7 @@
           <a:noFill/>
           <a:ln w="12700">
             <a:solidFill>
-              <a:srgbClr val="D3D9E4"/>
+              <a:srgbClr val="A9A9AF"/>
             </a:solidFill>
             <a:prstDash val="solid"/>
           </a:ln>
@@ -5034,7 +5034,7 @@
           <a:noFill/>
           <a:ln w="12700">
             <a:solidFill>
-              <a:srgbClr val="D3D9E4"/>
+              <a:srgbClr val="A9A9AF"/>
             </a:solidFill>
             <a:prstDash val="solid"/>
           </a:ln>
@@ -5057,7 +5057,7 @@
           <a:noFill/>
           <a:ln w="12700">
             <a:solidFill>
-              <a:srgbClr val="D3D9E4"/>
+              <a:srgbClr val="A9A9AF"/>
             </a:solidFill>
             <a:prstDash val="solid"/>
           </a:ln>
@@ -5080,7 +5080,7 @@
           <a:noFill/>
           <a:ln w="12700">
             <a:solidFill>
-              <a:srgbClr val="D3D9E4"/>
+              <a:srgbClr val="A9A9AF"/>
             </a:solidFill>
             <a:prstDash val="solid"/>
           </a:ln>
@@ -5103,7 +5103,7 @@
           <a:noFill/>
           <a:ln w="12700">
             <a:solidFill>
-              <a:srgbClr val="D3D9E4"/>
+              <a:srgbClr val="A9A9AF"/>
             </a:solidFill>
             <a:prstDash val="solid"/>
           </a:ln>
@@ -5126,7 +5126,7 @@
           <a:noFill/>
           <a:ln w="12700">
             <a:solidFill>
-              <a:srgbClr val="D3D9E4"/>
+              <a:srgbClr val="A9A9AF"/>
             </a:solidFill>
             <a:prstDash val="solid"/>
           </a:ln>
@@ -5149,7 +5149,7 @@
           <a:noFill/>
           <a:ln w="12700">
             <a:solidFill>
-              <a:srgbClr val="D3D9E4"/>
+              <a:srgbClr val="A9A9AF"/>
             </a:solidFill>
             <a:prstDash val="solid"/>
           </a:ln>
@@ -5172,7 +5172,7 @@
           <a:noFill/>
           <a:ln w="12700">
             <a:solidFill>
-              <a:srgbClr val="D3D9E4"/>
+              <a:srgbClr val="A9A9AF"/>
             </a:solidFill>
             <a:prstDash val="solid"/>
           </a:ln>
@@ -5642,9 +5642,9 @@
           </a:solidFill>
           <a:ln/>
           <a:effectLst>
-            <a:outerShdw sx="100000" sy="100000" kx="0" ky="0" algn="bl" rotWithShape="0" blurRad="127000" dist="25400" dir="8100000">
+            <a:outerShdw sx="100000" sy="100000" kx="0" ky="0" algn="bl" rotWithShape="0" blurRad="203200" dist="38100" dir="8100000">
               <a:srgbClr val="000000">
-                <a:alpha val="10000"/>
+                <a:alpha val="18000"/>
               </a:srgbClr>
             </a:outerShdw>
           </a:effectLst>
@@ -5782,7 +5782,7 @@
             <a:avLst/>
           </a:prstGeom>
           <a:solidFill>
-            <a:srgbClr val="F2F5FA"/>
+            <a:srgbClr val="F5F5F7"/>
           </a:solidFill>
           <a:ln/>
         </p:spPr>
@@ -5900,7 +5900,7 @@
             <a:avLst/>
           </a:prstGeom>
           <a:solidFill>
-            <a:srgbClr val="F2F5FA"/>
+            <a:srgbClr val="F5F5F7"/>
           </a:solidFill>
           <a:ln/>
         </p:spPr>
@@ -6018,7 +6018,7 @@
             <a:avLst/>
           </a:prstGeom>
           <a:solidFill>
-            <a:srgbClr val="F2F5FA"/>
+            <a:srgbClr val="F5F5F7"/>
           </a:solidFill>
           <a:ln/>
         </p:spPr>
@@ -6175,7 +6175,7 @@
             <a:avLst/>
           </a:prstGeom>
           <a:solidFill>
-            <a:srgbClr val="F2F5FA"/>
+            <a:srgbClr val="F5F5F7"/>
           </a:solidFill>
           <a:ln/>
         </p:spPr>
@@ -6195,7 +6195,7 @@
             <a:avLst/>
           </a:prstGeom>
           <a:solidFill>
-            <a:srgbClr val="F0A64A"/>
+            <a:srgbClr val="A04E00"/>
           </a:solidFill>
           <a:ln/>
         </p:spPr>
@@ -6293,7 +6293,7 @@
             <a:avLst/>
           </a:prstGeom>
           <a:solidFill>
-            <a:srgbClr val="F2F5FA"/>
+            <a:srgbClr val="F5F5F7"/>
           </a:solidFill>
           <a:ln/>
         </p:spPr>
@@ -6313,7 +6313,7 @@
             <a:avLst/>
           </a:prstGeom>
           <a:solidFill>
-            <a:srgbClr val="F0A64A"/>
+            <a:srgbClr val="A04E00"/>
           </a:solidFill>
           <a:ln/>
         </p:spPr>
@@ -6411,7 +6411,7 @@
             <a:avLst/>
           </a:prstGeom>
           <a:solidFill>
-            <a:srgbClr val="F2F5FA"/>
+            <a:srgbClr val="F5F5F7"/>
           </a:solidFill>
           <a:ln/>
         </p:spPr>
@@ -6431,7 +6431,7 @@
             <a:avLst/>
           </a:prstGeom>
           <a:solidFill>
-            <a:srgbClr val="F0A64A"/>
+            <a:srgbClr val="A04E00"/>
           </a:solidFill>
           <a:ln/>
         </p:spPr>
@@ -6561,7 +6561,7 @@
             <a:r>
               <a:rPr lang="en-US" sz="1150" dirty="0">
                 <a:solidFill>
-                  <a:srgbClr val="A9BFE0"/>
+                  <a:srgbClr val="6E6E73"/>
                 </a:solidFill>
                 <a:latin typeface="Calibri Light" pitchFamily="34" charset="0"/>
                 <a:ea typeface="Calibri Light" pitchFamily="34" charset="-122"/>
@@ -6587,7 +6587,7 @@
     <p:bg>
       <p:bgPr>
         <a:solidFill>
-          <a:srgbClr val="07295C"/>
+          <a:srgbClr val="FBFBFD"/>
         </a:solidFill>
       </p:bgPr>
     </p:bg>
@@ -6632,7 +6632,7 @@
             <a:r>
               <a:rPr lang="en-US" sz="1100" b="1" spc="300" kern="0" dirty="0">
                 <a:solidFill>
-                  <a:srgbClr val="6FB8FF"/>
+                  <a:srgbClr val="0071E3"/>
                 </a:solidFill>
                 <a:latin typeface="Calibri" pitchFamily="34" charset="0"/>
                 <a:ea typeface="Calibri" pitchFamily="34" charset="-122"/>
@@ -6671,7 +6671,7 @@
             <a:r>
               <a:rPr lang="en-US" sz="3800" b="1" dirty="0">
                 <a:solidFill>
-                  <a:srgbClr val="FFFFFF"/>
+                  <a:srgbClr val="1D1D1F"/>
                 </a:solidFill>
                 <a:latin typeface="Calibri" pitchFamily="34" charset="0"/>
                 <a:ea typeface="Calibri" pitchFamily="34" charset="-122"/>
@@ -6710,7 +6710,7 @@
             <a:r>
               <a:rPr lang="en-US" sz="1500" dirty="0">
                 <a:solidFill>
-                  <a:srgbClr val="A9BFE0"/>
+                  <a:srgbClr val="6E6E73"/>
                 </a:solidFill>
                 <a:latin typeface="Calibri Light" pitchFamily="34" charset="0"/>
                 <a:ea typeface="Calibri Light" pitchFamily="34" charset="-122"/>
@@ -6749,7 +6749,7 @@
             <a:r>
               <a:rPr lang="en-US" sz="1000" b="1" spc="200" kern="0" dirty="0">
                 <a:solidFill>
-                  <a:srgbClr val="A9BFE0"/>
+                  <a:srgbClr val="6E6E73"/>
                 </a:solidFill>
                 <a:latin typeface="Calibri" pitchFamily="34" charset="0"/>
                 <a:ea typeface="Calibri" pitchFamily="34" charset="-122"/>
@@ -6796,7 +6796,7 @@
             <a:avLst/>
           </a:prstGeom>
           <a:solidFill>
-            <a:srgbClr val="0071E3"/>
+            <a:srgbClr val="005BB8"/>
           </a:solidFill>
           <a:ln/>
         </p:spPr>
@@ -6828,7 +6828,7 @@
             <a:r>
               <a:rPr lang="en-US" sz="1100" b="1" dirty="0">
                 <a:solidFill>
-                  <a:srgbClr val="0071E3"/>
+                  <a:srgbClr val="005BB8"/>
                 </a:solidFill>
                 <a:latin typeface="Calibri" pitchFamily="34" charset="0"/>
                 <a:ea typeface="Calibri" pitchFamily="34" charset="-122"/>
@@ -6906,7 +6906,7 @@
             <a:r>
               <a:rPr lang="en-US" sz="1150" dirty="0">
                 <a:solidFill>
-                  <a:srgbClr val="A9BFE0"/>
+                  <a:srgbClr val="6E6E73"/>
                 </a:solidFill>
                 <a:latin typeface="Calibri Light" pitchFamily="34" charset="0"/>
                 <a:ea typeface="Calibri Light" pitchFamily="34" charset="-122"/>
@@ -6953,7 +6953,7 @@
             <a:avLst/>
           </a:prstGeom>
           <a:solidFill>
-            <a:srgbClr val="0071E3"/>
+            <a:srgbClr val="005BB8"/>
           </a:solidFill>
           <a:ln/>
         </p:spPr>
@@ -6985,7 +6985,7 @@
             <a:r>
               <a:rPr lang="en-US" sz="1100" b="1" dirty="0">
                 <a:solidFill>
-                  <a:srgbClr val="0071E3"/>
+                  <a:srgbClr val="005BB8"/>
                 </a:solidFill>
                 <a:latin typeface="Calibri" pitchFamily="34" charset="0"/>
                 <a:ea typeface="Calibri" pitchFamily="34" charset="-122"/>
@@ -7063,7 +7063,7 @@
             <a:r>
               <a:rPr lang="en-US" sz="1150" dirty="0">
                 <a:solidFill>
-                  <a:srgbClr val="A9BFE0"/>
+                  <a:srgbClr val="6E6E73"/>
                 </a:solidFill>
                 <a:latin typeface="Calibri Light" pitchFamily="34" charset="0"/>
                 <a:ea typeface="Calibri Light" pitchFamily="34" charset="-122"/>
@@ -7110,7 +7110,7 @@
             <a:avLst/>
           </a:prstGeom>
           <a:solidFill>
-            <a:srgbClr val="0071E3"/>
+            <a:srgbClr val="005BB8"/>
           </a:solidFill>
           <a:ln/>
         </p:spPr>
@@ -7142,7 +7142,7 @@
             <a:r>
               <a:rPr lang="en-US" sz="1100" b="1" dirty="0">
                 <a:solidFill>
-                  <a:srgbClr val="0071E3"/>
+                  <a:srgbClr val="005BB8"/>
                 </a:solidFill>
                 <a:latin typeface="Calibri" pitchFamily="34" charset="0"/>
                 <a:ea typeface="Calibri" pitchFamily="34" charset="-122"/>
@@ -7220,7 +7220,7 @@
             <a:r>
               <a:rPr lang="en-US" sz="1150" dirty="0">
                 <a:solidFill>
-                  <a:srgbClr val="A9BFE0"/>
+                  <a:srgbClr val="6E6E73"/>
                 </a:solidFill>
                 <a:latin typeface="Calibri Light" pitchFamily="34" charset="0"/>
                 <a:ea typeface="Calibri Light" pitchFamily="34" charset="-122"/>
@@ -7267,7 +7267,7 @@
             <a:avLst/>
           </a:prstGeom>
           <a:solidFill>
-            <a:srgbClr val="0071E3"/>
+            <a:srgbClr val="005BB8"/>
           </a:solidFill>
           <a:ln/>
         </p:spPr>
@@ -7299,7 +7299,7 @@
             <a:r>
               <a:rPr lang="en-US" sz="1100" b="1" dirty="0">
                 <a:solidFill>
-                  <a:srgbClr val="0071E3"/>
+                  <a:srgbClr val="005BB8"/>
                 </a:solidFill>
                 <a:latin typeface="Calibri" pitchFamily="34" charset="0"/>
                 <a:ea typeface="Calibri" pitchFamily="34" charset="-122"/>
@@ -7377,7 +7377,7 @@
             <a:r>
               <a:rPr lang="en-US" sz="1150" dirty="0">
                 <a:solidFill>
-                  <a:srgbClr val="A9BFE0"/>
+                  <a:srgbClr val="6E6E73"/>
                 </a:solidFill>
                 <a:latin typeface="Calibri Light" pitchFamily="34" charset="0"/>
                 <a:ea typeface="Calibri Light" pitchFamily="34" charset="-122"/>
@@ -7424,7 +7424,7 @@
             <a:avLst/>
           </a:prstGeom>
           <a:solidFill>
-            <a:srgbClr val="0071E3"/>
+            <a:srgbClr val="005BB8"/>
           </a:solidFill>
           <a:ln/>
         </p:spPr>
@@ -7456,7 +7456,7 @@
             <a:r>
               <a:rPr lang="en-US" sz="1100" b="1" dirty="0">
                 <a:solidFill>
-                  <a:srgbClr val="0071E3"/>
+                  <a:srgbClr val="005BB8"/>
                 </a:solidFill>
                 <a:latin typeface="Calibri" pitchFamily="34" charset="0"/>
                 <a:ea typeface="Calibri" pitchFamily="34" charset="-122"/>
@@ -7534,7 +7534,7 @@
             <a:r>
               <a:rPr lang="en-US" sz="1150" dirty="0">
                 <a:solidFill>
-                  <a:srgbClr val="A9BFE0"/>
+                  <a:srgbClr val="6E6E73"/>
                 </a:solidFill>
                 <a:latin typeface="Calibri Light" pitchFamily="34" charset="0"/>
                 <a:ea typeface="Calibri Light" pitchFamily="34" charset="-122"/>
@@ -7581,7 +7581,7 @@
             <a:avLst/>
           </a:prstGeom>
           <a:solidFill>
-            <a:srgbClr val="0071E3"/>
+            <a:srgbClr val="005BB8"/>
           </a:solidFill>
           <a:ln/>
         </p:spPr>
@@ -7613,7 +7613,7 @@
             <a:r>
               <a:rPr lang="en-US" sz="1100" b="1" dirty="0">
                 <a:solidFill>
-                  <a:srgbClr val="0071E3"/>
+                  <a:srgbClr val="005BB8"/>
                 </a:solidFill>
                 <a:latin typeface="Calibri" pitchFamily="34" charset="0"/>
                 <a:ea typeface="Calibri" pitchFamily="34" charset="-122"/>
@@ -7691,7 +7691,7 @@
             <a:r>
               <a:rPr lang="en-US" sz="1150" dirty="0">
                 <a:solidFill>
-                  <a:srgbClr val="A9BFE0"/>
+                  <a:srgbClr val="6E6E73"/>
                 </a:solidFill>
                 <a:latin typeface="Calibri Light" pitchFamily="34" charset="0"/>
                 <a:ea typeface="Calibri Light" pitchFamily="34" charset="-122"/>
@@ -7738,7 +7738,7 @@
             <a:avLst/>
           </a:prstGeom>
           <a:solidFill>
-            <a:srgbClr val="5A6070"/>
+            <a:srgbClr val="4A5060"/>
           </a:solidFill>
           <a:ln/>
         </p:spPr>
@@ -7770,7 +7770,7 @@
             <a:r>
               <a:rPr lang="en-US" sz="1100" b="1" dirty="0">
                 <a:solidFill>
-                  <a:srgbClr val="5A6070"/>
+                  <a:srgbClr val="4A5060"/>
                 </a:solidFill>
                 <a:latin typeface="Calibri" pitchFamily="34" charset="0"/>
                 <a:ea typeface="Calibri" pitchFamily="34" charset="-122"/>
@@ -7848,7 +7848,7 @@
             <a:r>
               <a:rPr lang="en-US" sz="1150" dirty="0">
                 <a:solidFill>
-                  <a:srgbClr val="A9BFE0"/>
+                  <a:srgbClr val="6E6E73"/>
                 </a:solidFill>
                 <a:latin typeface="Calibri Light" pitchFamily="34" charset="0"/>
                 <a:ea typeface="Calibri Light" pitchFamily="34" charset="-122"/>
@@ -7895,7 +7895,7 @@
             <a:avLst/>
           </a:prstGeom>
           <a:solidFill>
-            <a:srgbClr val="5A6070"/>
+            <a:srgbClr val="4A5060"/>
           </a:solidFill>
           <a:ln/>
         </p:spPr>
@@ -7927,7 +7927,7 @@
             <a:r>
               <a:rPr lang="en-US" sz="1100" b="1" dirty="0">
                 <a:solidFill>
-                  <a:srgbClr val="5A6070"/>
+                  <a:srgbClr val="4A5060"/>
                 </a:solidFill>
                 <a:latin typeface="Calibri" pitchFamily="34" charset="0"/>
                 <a:ea typeface="Calibri" pitchFamily="34" charset="-122"/>
@@ -8005,7 +8005,7 @@
             <a:r>
               <a:rPr lang="en-US" sz="1150" dirty="0">
                 <a:solidFill>
-                  <a:srgbClr val="A9BFE0"/>
+                  <a:srgbClr val="6E6E73"/>
                 </a:solidFill>
                 <a:latin typeface="Calibri Light" pitchFamily="34" charset="0"/>
                 <a:ea typeface="Calibri Light" pitchFamily="34" charset="-122"/>
@@ -8034,7 +8034,7 @@
           <a:noFill/>
           <a:ln w="25400">
             <a:solidFill>
-              <a:srgbClr val="D3D9E4"/>
+              <a:srgbClr val="A9A9AF"/>
             </a:solidFill>
             <a:prstDash val="solid"/>
           </a:ln>
@@ -8067,7 +8067,7 @@
             <a:r>
               <a:rPr lang="en-US" sz="1100" b="1" spc="200" kern="0" dirty="0">
                 <a:solidFill>
-                  <a:srgbClr val="A9BFE0"/>
+                  <a:srgbClr val="6E6E73"/>
                 </a:solidFill>
                 <a:latin typeface="Calibri" pitchFamily="34" charset="0"/>
                 <a:ea typeface="Calibri" pitchFamily="34" charset="-122"/>
@@ -8096,7 +8096,7 @@
           <a:noFill/>
           <a:ln w="25400">
             <a:solidFill>
-              <a:srgbClr val="D3D9E4"/>
+              <a:srgbClr val="A9A9AF"/>
             </a:solidFill>
             <a:prstDash val="solid"/>
           </a:ln>
@@ -8129,7 +8129,7 @@
             <a:r>
               <a:rPr lang="en-US" sz="1100" b="1" spc="200" kern="0" dirty="0">
                 <a:solidFill>
-                  <a:srgbClr val="A9BFE0"/>
+                  <a:srgbClr val="6E6E73"/>
                 </a:solidFill>
                 <a:latin typeface="Calibri" pitchFamily="34" charset="0"/>
                 <a:ea typeface="Calibri" pitchFamily="34" charset="-122"/>
@@ -8158,7 +8158,7 @@
           <a:noFill/>
           <a:ln w="25400">
             <a:solidFill>
-              <a:srgbClr val="D3D9E4"/>
+              <a:srgbClr val="A9A9AF"/>
             </a:solidFill>
             <a:prstDash val="solid"/>
           </a:ln>
@@ -8191,7 +8191,7 @@
             <a:r>
               <a:rPr lang="en-US" sz="1100" b="1" spc="200" kern="0" dirty="0">
                 <a:solidFill>
-                  <a:srgbClr val="A9BFE0"/>
+                  <a:srgbClr val="6E6E73"/>
                 </a:solidFill>
                 <a:latin typeface="Calibri" pitchFamily="34" charset="0"/>
                 <a:ea typeface="Calibri" pitchFamily="34" charset="-122"/>
@@ -8218,7 +8218,7 @@
             <a:avLst/>
           </a:prstGeom>
           <a:solidFill>
-            <a:srgbClr val="FFFFFF"/>
+            <a:srgbClr val="E8F1FD"/>
           </a:solidFill>
           <a:ln/>
         </p:spPr>
@@ -8296,7 +8296,7 @@
     <p:bg>
       <p:bgPr>
         <a:solidFill>
-          <a:srgbClr val="07295C"/>
+          <a:srgbClr val="FBFBFD"/>
         </a:solidFill>
       </p:bgPr>
     </p:bg>
@@ -8341,7 +8341,7 @@
             <a:r>
               <a:rPr lang="en-US" sz="1100" b="1" spc="300" kern="0" dirty="0">
                 <a:solidFill>
-                  <a:srgbClr val="6FB8FF"/>
+                  <a:srgbClr val="0071E3"/>
                 </a:solidFill>
                 <a:latin typeface="Calibri" pitchFamily="34" charset="0"/>
                 <a:ea typeface="Calibri" pitchFamily="34" charset="-122"/>
@@ -8380,7 +8380,7 @@
             <a:r>
               <a:rPr lang="en-US" sz="3800" b="1" dirty="0">
                 <a:solidFill>
-                  <a:srgbClr val="FFFFFF"/>
+                  <a:srgbClr val="1D1D1F"/>
                 </a:solidFill>
                 <a:latin typeface="Calibri" pitchFamily="34" charset="0"/>
                 <a:ea typeface="Calibri" pitchFamily="34" charset="-122"/>
@@ -8419,7 +8419,7 @@
             <a:r>
               <a:rPr lang="en-US" sz="1500" dirty="0">
                 <a:solidFill>
-                  <a:srgbClr val="A9BFE0"/>
+                  <a:srgbClr val="6E6E73"/>
                 </a:solidFill>
                 <a:latin typeface="Calibri Light" pitchFamily="34" charset="0"/>
                 <a:ea typeface="Calibri Light" pitchFamily="34" charset="-122"/>
@@ -8450,9 +8450,9 @@
           </a:solidFill>
           <a:ln/>
           <a:effectLst>
-            <a:outerShdw sx="100000" sy="100000" kx="0" ky="0" algn="bl" rotWithShape="0" blurRad="127000" dist="25400" dir="8100000">
+            <a:outerShdw sx="100000" sy="100000" kx="0" ky="0" algn="bl" rotWithShape="0" blurRad="203200" dist="38100" dir="8100000">
               <a:srgbClr val="000000">
-                <a:alpha val="10000"/>
+                <a:alpha val="18000"/>
               </a:srgbClr>
             </a:outerShdw>
           </a:effectLst>
@@ -8573,7 +8573,7 @@
           <a:noFill/>
           <a:ln w="12700">
             <a:solidFill>
-              <a:srgbClr val="D3D9E4"/>
+              <a:srgbClr val="A9A9AF"/>
             </a:solidFill>
             <a:prstDash val="solid"/>
           </a:ln>
@@ -8637,9 +8637,9 @@
           </a:solidFill>
           <a:ln/>
           <a:effectLst>
-            <a:outerShdw sx="100000" sy="100000" kx="0" ky="0" algn="bl" rotWithShape="0" blurRad="127000" dist="25400" dir="8100000">
+            <a:outerShdw sx="100000" sy="100000" kx="0" ky="0" algn="bl" rotWithShape="0" blurRad="203200" dist="38100" dir="8100000">
               <a:srgbClr val="000000">
-                <a:alpha val="10000"/>
+                <a:alpha val="18000"/>
               </a:srgbClr>
             </a:outerShdw>
           </a:effectLst>
@@ -8760,7 +8760,7 @@
           <a:noFill/>
           <a:ln w="12700">
             <a:solidFill>
-              <a:srgbClr val="D3D9E4"/>
+              <a:srgbClr val="A9A9AF"/>
             </a:solidFill>
             <a:prstDash val="solid"/>
           </a:ln>
@@ -8824,9 +8824,9 @@
           </a:solidFill>
           <a:ln/>
           <a:effectLst>
-            <a:outerShdw sx="100000" sy="100000" kx="0" ky="0" algn="bl" rotWithShape="0" blurRad="127000" dist="25400" dir="8100000">
+            <a:outerShdw sx="100000" sy="100000" kx="0" ky="0" algn="bl" rotWithShape="0" blurRad="203200" dist="38100" dir="8100000">
               <a:srgbClr val="000000">
-                <a:alpha val="10000"/>
+                <a:alpha val="18000"/>
               </a:srgbClr>
             </a:outerShdw>
           </a:effectLst>
@@ -8847,7 +8847,7 @@
             <a:avLst/>
           </a:prstGeom>
           <a:solidFill>
-            <a:srgbClr val="9A6410"/>
+            <a:srgbClr val="B85C00"/>
           </a:solidFill>
           <a:ln/>
         </p:spPr>
@@ -8879,7 +8879,7 @@
             <a:r>
               <a:rPr lang="en-US" sz="3800" b="1" dirty="0">
                 <a:solidFill>
-                  <a:srgbClr val="9A6410"/>
+                  <a:srgbClr val="B85C00"/>
                 </a:solidFill>
                 <a:latin typeface="Calibri" pitchFamily="34" charset="0"/>
                 <a:ea typeface="Calibri" pitchFamily="34" charset="-122"/>
@@ -8947,7 +8947,7 @@
           <a:noFill/>
           <a:ln w="12700">
             <a:solidFill>
-              <a:srgbClr val="D3D9E4"/>
+              <a:srgbClr val="A9A9AF"/>
             </a:solidFill>
             <a:prstDash val="solid"/>
           </a:ln>
@@ -9011,9 +9011,9 @@
           </a:solidFill>
           <a:ln/>
           <a:effectLst>
-            <a:outerShdw sx="100000" sy="100000" kx="0" ky="0" algn="bl" rotWithShape="0" blurRad="127000" dist="25400" dir="8100000">
+            <a:outerShdw sx="100000" sy="100000" kx="0" ky="0" algn="bl" rotWithShape="0" blurRad="203200" dist="38100" dir="8100000">
               <a:srgbClr val="000000">
-                <a:alpha val="10000"/>
+                <a:alpha val="18000"/>
               </a:srgbClr>
             </a:outerShdw>
           </a:effectLst>
@@ -9034,7 +9034,7 @@
             <a:avLst/>
           </a:prstGeom>
           <a:solidFill>
-            <a:srgbClr val="9A6410"/>
+            <a:srgbClr val="B85C00"/>
           </a:solidFill>
           <a:ln/>
         </p:spPr>
@@ -9066,7 +9066,7 @@
             <a:r>
               <a:rPr lang="en-US" sz="3800" b="1" dirty="0">
                 <a:solidFill>
-                  <a:srgbClr val="9A6410"/>
+                  <a:srgbClr val="B85C00"/>
                 </a:solidFill>
                 <a:latin typeface="Calibri" pitchFamily="34" charset="0"/>
                 <a:ea typeface="Calibri" pitchFamily="34" charset="-122"/>
@@ -9134,7 +9134,7 @@
           <a:noFill/>
           <a:ln w="12700">
             <a:solidFill>
-              <a:srgbClr val="D3D9E4"/>
+              <a:srgbClr val="A9A9AF"/>
             </a:solidFill>
             <a:prstDash val="solid"/>
           </a:ln>
@@ -9194,7 +9194,7 @@
             <a:avLst/>
           </a:prstGeom>
           <a:solidFill>
-            <a:srgbClr val="0F3B78"/>
+            <a:srgbClr val="E8F1FD"/>
           </a:solidFill>
           <a:ln/>
         </p:spPr>
@@ -9214,7 +9214,7 @@
             <a:avLst/>
           </a:prstGeom>
           <a:solidFill>
-            <a:srgbClr val="6FB8FF"/>
+            <a:srgbClr val="0071E3"/>
           </a:solidFill>
           <a:ln/>
         </p:spPr>
@@ -9246,7 +9246,7 @@
             <a:r>
               <a:rPr lang="en-US" sz="1350" b="1" dirty="0">
                 <a:solidFill>
-                  <a:srgbClr val="FFFFFF"/>
+                  <a:srgbClr val="1D1D1F"/>
                 </a:solidFill>
                 <a:latin typeface="Calibri Light" pitchFamily="34" charset="0"/>
                 <a:ea typeface="Calibri Light" pitchFamily="34" charset="-122"/>
@@ -9260,7 +9260,7 @@
             <a:r>
               <a:rPr lang="en-US" sz="1350" dirty="0">
                 <a:solidFill>
-                  <a:srgbClr val="CDE3FF"/>
+                  <a:srgbClr val="6E6E73"/>
                 </a:solidFill>
                 <a:latin typeface="Calibri Light" pitchFamily="34" charset="0"/>
                 <a:ea typeface="Calibri Light" pitchFamily="34" charset="-122"/>
@@ -9299,7 +9299,7 @@
             <a:r>
               <a:rPr lang="en-US" sz="1000" dirty="0">
                 <a:solidFill>
-                  <a:srgbClr val="9AA6BC"/>
+                  <a:srgbClr val="6E6E73"/>
                 </a:solidFill>
                 <a:latin typeface="Calibri Light" pitchFamily="34" charset="0"/>
                 <a:ea typeface="Calibri Light" pitchFamily="34" charset="-122"/>
@@ -9325,7 +9325,7 @@
     <p:bg>
       <p:bgPr>
         <a:solidFill>
-          <a:srgbClr val="07295C"/>
+          <a:srgbClr val="FBFBFD"/>
         </a:solidFill>
       </p:bgPr>
     </p:bg>
@@ -9370,7 +9370,7 @@
             <a:r>
               <a:rPr lang="en-US" sz="1100" b="1" spc="300" kern="0" dirty="0">
                 <a:solidFill>
-                  <a:srgbClr val="6FB8FF"/>
+                  <a:srgbClr val="0071E3"/>
                 </a:solidFill>
                 <a:latin typeface="Calibri" pitchFamily="34" charset="0"/>
                 <a:ea typeface="Calibri" pitchFamily="34" charset="-122"/>
@@ -9409,7 +9409,7 @@
             <a:r>
               <a:rPr lang="en-US" sz="3800" b="1" dirty="0">
                 <a:solidFill>
-                  <a:srgbClr val="FFFFFF"/>
+                  <a:srgbClr val="1D1D1F"/>
                 </a:solidFill>
                 <a:latin typeface="Calibri" pitchFamily="34" charset="0"/>
                 <a:ea typeface="Calibri" pitchFamily="34" charset="-122"/>
@@ -9448,7 +9448,7 @@
             <a:r>
               <a:rPr lang="en-US" sz="1500" dirty="0">
                 <a:solidFill>
-                  <a:srgbClr val="A9BFE0"/>
+                  <a:srgbClr val="6E6E73"/>
                 </a:solidFill>
                 <a:latin typeface="Calibri Light" pitchFamily="34" charset="0"/>
                 <a:ea typeface="Calibri Light" pitchFamily="34" charset="-122"/>
@@ -9479,9 +9479,9 @@
           </a:solidFill>
           <a:ln/>
           <a:effectLst>
-            <a:outerShdw sx="100000" sy="100000" kx="0" ky="0" algn="bl" rotWithShape="0" blurRad="127000" dist="25400" dir="8100000">
+            <a:outerShdw sx="100000" sy="100000" kx="0" ky="0" algn="bl" rotWithShape="0" blurRad="203200" dist="38100" dir="8100000">
               <a:srgbClr val="000000">
-                <a:alpha val="10000"/>
+                <a:alpha val="18000"/>
               </a:srgbClr>
             </a:outerShdw>
           </a:effectLst>
@@ -9612,7 +9612,7 @@
             <a:r>
               <a:rPr lang="en-US" sz="1000" b="1" dirty="0">
                 <a:solidFill>
-                  <a:srgbClr val="0071E3"/>
+                  <a:srgbClr val="005BB8"/>
                 </a:solidFill>
                 <a:latin typeface="Calibri" pitchFamily="34" charset="0"/>
                 <a:ea typeface="Calibri" pitchFamily="34" charset="-122"/>
@@ -9704,7 +9704,7 @@
             <a:r>
               <a:rPr lang="en-US" sz="1000" b="1" dirty="0">
                 <a:solidFill>
-                  <a:srgbClr val="0071E3"/>
+                  <a:srgbClr val="005BB8"/>
                 </a:solidFill>
                 <a:latin typeface="Calibri" pitchFamily="34" charset="0"/>
                 <a:ea typeface="Calibri" pitchFamily="34" charset="-122"/>
@@ -9796,7 +9796,7 @@
             <a:r>
               <a:rPr lang="en-US" sz="1000" b="1" dirty="0">
                 <a:solidFill>
-                  <a:srgbClr val="0071E3"/>
+                  <a:srgbClr val="005BB8"/>
                 </a:solidFill>
                 <a:latin typeface="Calibri" pitchFamily="34" charset="0"/>
                 <a:ea typeface="Calibri" pitchFamily="34" charset="-122"/>
@@ -9888,7 +9888,7 @@
             <a:r>
               <a:rPr lang="en-US" sz="1000" b="1" dirty="0">
                 <a:solidFill>
-                  <a:srgbClr val="0071E3"/>
+                  <a:srgbClr val="005BB8"/>
                 </a:solidFill>
                 <a:latin typeface="Calibri" pitchFamily="34" charset="0"/>
                 <a:ea typeface="Calibri" pitchFamily="34" charset="-122"/>
@@ -9980,7 +9980,7 @@
             <a:r>
               <a:rPr lang="en-US" sz="1000" b="1" dirty="0">
                 <a:solidFill>
-                  <a:srgbClr val="0071E3"/>
+                  <a:srgbClr val="005BB8"/>
                 </a:solidFill>
                 <a:latin typeface="Calibri" pitchFamily="34" charset="0"/>
                 <a:ea typeface="Calibri" pitchFamily="34" charset="-122"/>
@@ -10072,7 +10072,7 @@
             <a:r>
               <a:rPr lang="en-US" sz="1000" b="1" dirty="0">
                 <a:solidFill>
-                  <a:srgbClr val="0071E3"/>
+                  <a:srgbClr val="005BB8"/>
                 </a:solidFill>
                 <a:latin typeface="Calibri" pitchFamily="34" charset="0"/>
                 <a:ea typeface="Calibri" pitchFamily="34" charset="-122"/>
@@ -10164,7 +10164,7 @@
             <a:r>
               <a:rPr lang="en-US" sz="1000" b="1" dirty="0">
                 <a:solidFill>
-                  <a:srgbClr val="0071E3"/>
+                  <a:srgbClr val="005BB8"/>
                 </a:solidFill>
                 <a:latin typeface="Calibri" pitchFamily="34" charset="0"/>
                 <a:ea typeface="Calibri" pitchFamily="34" charset="-122"/>
@@ -10256,7 +10256,7 @@
             <a:r>
               <a:rPr lang="en-US" sz="1000" b="1" dirty="0">
                 <a:solidFill>
-                  <a:srgbClr val="0071E3"/>
+                  <a:srgbClr val="005BB8"/>
                 </a:solidFill>
                 <a:latin typeface="Calibri" pitchFamily="34" charset="0"/>
                 <a:ea typeface="Calibri" pitchFamily="34" charset="-122"/>
@@ -10348,7 +10348,7 @@
             <a:r>
               <a:rPr lang="en-US" sz="1000" b="1" dirty="0">
                 <a:solidFill>
-                  <a:srgbClr val="0071E3"/>
+                  <a:srgbClr val="005BB8"/>
                 </a:solidFill>
                 <a:latin typeface="Calibri" pitchFamily="34" charset="0"/>
                 <a:ea typeface="Calibri" pitchFamily="34" charset="-122"/>
@@ -10440,7 +10440,7 @@
             <a:r>
               <a:rPr lang="en-US" sz="1000" b="1" dirty="0">
                 <a:solidFill>
-                  <a:srgbClr val="0071E3"/>
+                  <a:srgbClr val="005BB8"/>
                 </a:solidFill>
                 <a:latin typeface="Calibri" pitchFamily="34" charset="0"/>
                 <a:ea typeface="Calibri" pitchFamily="34" charset="-122"/>
@@ -10532,7 +10532,7 @@
             <a:r>
               <a:rPr lang="en-US" sz="1000" b="1" dirty="0">
                 <a:solidFill>
-                  <a:srgbClr val="0071E3"/>
+                  <a:srgbClr val="005BB8"/>
                 </a:solidFill>
                 <a:latin typeface="Calibri" pitchFamily="34" charset="0"/>
                 <a:ea typeface="Calibri" pitchFamily="34" charset="-122"/>
@@ -10624,7 +10624,7 @@
             <a:r>
               <a:rPr lang="en-US" sz="1000" b="1" dirty="0">
                 <a:solidFill>
-                  <a:srgbClr val="0071E3"/>
+                  <a:srgbClr val="005BB8"/>
                 </a:solidFill>
                 <a:latin typeface="Calibri" pitchFamily="34" charset="0"/>
                 <a:ea typeface="Calibri" pitchFamily="34" charset="-122"/>
@@ -10708,9 +10708,9 @@
           </a:solidFill>
           <a:ln/>
           <a:effectLst>
-            <a:outerShdw sx="100000" sy="100000" kx="0" ky="0" algn="bl" rotWithShape="0" blurRad="127000" dist="25400" dir="8100000">
+            <a:outerShdw sx="100000" sy="100000" kx="0" ky="0" algn="bl" rotWithShape="0" blurRad="203200" dist="38100" dir="8100000">
               <a:srgbClr val="000000">
-                <a:alpha val="10000"/>
+                <a:alpha val="18000"/>
               </a:srgbClr>
             </a:outerShdw>
           </a:effectLst>
@@ -10731,7 +10731,7 @@
             <a:avLst/>
           </a:prstGeom>
           <a:solidFill>
-            <a:srgbClr val="9A6410"/>
+            <a:srgbClr val="B85C00"/>
           </a:solidFill>
           <a:ln/>
         </p:spPr>
@@ -10841,7 +10841,7 @@
             <a:r>
               <a:rPr lang="en-US" sz="1000" b="1" dirty="0">
                 <a:solidFill>
-                  <a:srgbClr val="9A6410"/>
+                  <a:srgbClr val="B85C00"/>
                 </a:solidFill>
                 <a:latin typeface="Calibri" pitchFamily="34" charset="0"/>
                 <a:ea typeface="Calibri" pitchFamily="34" charset="-122"/>
@@ -10958,7 +10958,7 @@
             <a:r>
               <a:rPr lang="en-US" sz="1000" b="1" dirty="0">
                 <a:solidFill>
-                  <a:srgbClr val="9A6410"/>
+                  <a:srgbClr val="B85C00"/>
                 </a:solidFill>
                 <a:latin typeface="Calibri" pitchFamily="34" charset="0"/>
                 <a:ea typeface="Calibri" pitchFamily="34" charset="-122"/>
@@ -11075,7 +11075,7 @@
             <a:r>
               <a:rPr lang="en-US" sz="1000" b="1" dirty="0">
                 <a:solidFill>
-                  <a:srgbClr val="9A6410"/>
+                  <a:srgbClr val="B85C00"/>
                 </a:solidFill>
                 <a:latin typeface="Calibri" pitchFamily="34" charset="0"/>
                 <a:ea typeface="Calibri" pitchFamily="34" charset="-122"/>
@@ -11192,7 +11192,7 @@
             <a:r>
               <a:rPr lang="en-US" sz="1000" b="1" dirty="0">
                 <a:solidFill>
-                  <a:srgbClr val="9A6410"/>
+                  <a:srgbClr val="B85C00"/>
                 </a:solidFill>
                 <a:latin typeface="Calibri" pitchFamily="34" charset="0"/>
                 <a:ea typeface="Calibri" pitchFamily="34" charset="-122"/>
@@ -11309,7 +11309,7 @@
             <a:r>
               <a:rPr lang="en-US" sz="1000" b="1" dirty="0">
                 <a:solidFill>
-                  <a:srgbClr val="9A6410"/>
+                  <a:srgbClr val="B85C00"/>
                 </a:solidFill>
                 <a:latin typeface="Calibri" pitchFamily="34" charset="0"/>
                 <a:ea typeface="Calibri" pitchFamily="34" charset="-122"/>
@@ -11426,7 +11426,7 @@
             <a:r>
               <a:rPr lang="en-US" sz="1000" b="1" dirty="0">
                 <a:solidFill>
-                  <a:srgbClr val="9A6410"/>
+                  <a:srgbClr val="B85C00"/>
                 </a:solidFill>
                 <a:latin typeface="Calibri" pitchFamily="34" charset="0"/>
                 <a:ea typeface="Calibri" pitchFamily="34" charset="-122"/>
@@ -11543,7 +11543,7 @@
             <a:r>
               <a:rPr lang="en-US" sz="1000" b="1" dirty="0">
                 <a:solidFill>
-                  <a:srgbClr val="9A6410"/>
+                  <a:srgbClr val="B85C00"/>
                 </a:solidFill>
                 <a:latin typeface="Calibri" pitchFamily="34" charset="0"/>
                 <a:ea typeface="Calibri" pitchFamily="34" charset="-122"/>
@@ -11652,9 +11652,9 @@
           </a:solidFill>
           <a:ln/>
           <a:effectLst>
-            <a:outerShdw sx="100000" sy="100000" kx="0" ky="0" algn="bl" rotWithShape="0" blurRad="127000" dist="25400" dir="8100000">
+            <a:outerShdw sx="100000" sy="100000" kx="0" ky="0" algn="bl" rotWithShape="0" blurRad="203200" dist="38100" dir="8100000">
               <a:srgbClr val="000000">
-                <a:alpha val="10000"/>
+                <a:alpha val="18000"/>
               </a:srgbClr>
             </a:outerShdw>
           </a:effectLst>
@@ -11889,7 +11889,7 @@
             <a:r>
               <a:rPr lang="en-US" sz="1100" dirty="0">
                 <a:solidFill>
-                  <a:srgbClr val="A9BFE0"/>
+                  <a:srgbClr val="6E6E73"/>
                 </a:solidFill>
                 <a:latin typeface="Calibri Light" pitchFamily="34" charset="0"/>
                 <a:ea typeface="Calibri Light" pitchFamily="34" charset="-122"/>
@@ -11928,7 +11928,7 @@
             <a:r>
               <a:rPr lang="en-US" sz="1100" dirty="0">
                 <a:solidFill>
-                  <a:srgbClr val="A9BFE0"/>
+                  <a:srgbClr val="6E6E73"/>
                 </a:solidFill>
                 <a:latin typeface="Calibri Light" pitchFamily="34" charset="0"/>
                 <a:ea typeface="Calibri Light" pitchFamily="34" charset="-122"/>

</xml_diff>

<commit_message>
frise FR+EN et diapo 1: depart au besoin de modeliser la meteo, suppression des dates anterieures a l'ordinateur; ajout des cas d'usage Monte-Carlo, ENIAC 1950, UNIVAC 1952 et score de credit 1958; separateur explicite entre les deux lignees
</commit_message>
<xml_diff>
--- a/slides/Genese-de-l-IA.pptx
+++ b/slides/Genese-de-l-IA.pptx
@@ -1395,7 +1395,7 @@
                 <a:ea typeface="Calibri" pitchFamily="34" charset="-122"/>
                 <a:cs typeface="Calibri" pitchFamily="34" charset="-120"/>
               </a:rPr>
-              <a:t>Soixante-dix ans,</a:t>
+              <a:t>Cent ans,</a:t>
             </a:r>
             <a:endParaRPr lang="en-US" sz="4200" dirty="0"/>
           </a:p>
@@ -1454,7 +1454,7 @@
                 <a:ea typeface="Calibri Light" pitchFamily="34" charset="-122"/>
                 <a:cs typeface="Calibri Light" pitchFamily="34" charset="-120"/>
               </a:rPr>
-              <a:t>Le même projet — faire faire à une machine ce qui demande de l'intelligence — a changé d'étiquette à chaque fois que la précédente s'est dévaluée.</a:t>
+              <a:t>Tout part d'un besoin que personne ne savait satisfaire : prévoir le temps. C'est lui qui a justifié de construire la machine — et le domaine a changé d'étiquette à chaque déception depuis.</a:t>
             </a:r>
             <a:endParaRPr lang="en-US" sz="1500" dirty="0"/>
           </a:p>
@@ -1515,7 +1515,7 @@
         </p:nvSpPr>
         <p:spPr>
           <a:xfrm>
-            <a:off x="1335024" y="4215384"/>
+            <a:off x="1124712" y="4215384"/>
             <a:ext cx="164592" cy="164592"/>
           </a:xfrm>
           <a:prstGeom prst="ellipse">
@@ -1535,8 +1535,8 @@
         </p:nvSpPr>
         <p:spPr>
           <a:xfrm>
-            <a:off x="548640" y="3657600"/>
-            <a:ext cx="1737360" cy="310896"/>
+            <a:off x="530352" y="3675888"/>
+            <a:ext cx="1353312" cy="292608"/>
           </a:xfrm>
           <a:prstGeom prst="rect">
             <a:avLst/>
@@ -1552,7 +1552,7 @@
               <a:buNone/>
             </a:pPr>
             <a:r>
-              <a:rPr lang="en-US" sz="1600" b="1" dirty="0">
+              <a:rPr lang="en-US" sz="1450" b="1" dirty="0">
                 <a:solidFill>
                   <a:srgbClr val="0071E3"/>
                 </a:solidFill>
@@ -1560,9 +1560,9 @@
                 <a:ea typeface="Calibri" pitchFamily="34" charset="-122"/>
                 <a:cs typeface="Calibri" pitchFamily="34" charset="-120"/>
               </a:rPr>
-              <a:t>1805</a:t>
-            </a:r>
-            <a:endParaRPr lang="en-US" sz="1600" dirty="0"/>
+              <a:t>1922</a:t>
+            </a:r>
+            <a:endParaRPr lang="en-US" sz="1450" dirty="0"/>
           </a:p>
         </p:txBody>
       </p:sp>
@@ -1574,8 +1574,8 @@
         </p:nvSpPr>
         <p:spPr>
           <a:xfrm>
-            <a:off x="548640" y="4498848"/>
-            <a:ext cx="1737360" cy="310896"/>
+            <a:off x="530352" y="4480560"/>
+            <a:ext cx="1353312" cy="420624"/>
           </a:xfrm>
           <a:prstGeom prst="rect">
             <a:avLst/>
@@ -1591,7 +1591,7 @@
               <a:buNone/>
             </a:pPr>
             <a:r>
-              <a:rPr lang="en-US" sz="1250" b="1" dirty="0">
+              <a:rPr lang="en-US" sz="1150" b="1" dirty="0">
                 <a:solidFill>
                   <a:srgbClr val="1D1D1F"/>
                 </a:solidFill>
@@ -1599,9 +1599,9 @@
                 <a:ea typeface="Calibri" pitchFamily="34" charset="-122"/>
                 <a:cs typeface="Calibri" pitchFamily="34" charset="-120"/>
               </a:rPr>
-              <a:t>Les moindres carrés</a:t>
-            </a:r>
-            <a:endParaRPr lang="en-US" sz="1250" dirty="0"/>
+              <a:t>Prévoir le temps</a:t>
+            </a:r>
+            <a:endParaRPr lang="en-US" sz="1150" dirty="0"/>
           </a:p>
         </p:txBody>
       </p:sp>
@@ -1613,8 +1613,8 @@
         </p:nvSpPr>
         <p:spPr>
           <a:xfrm>
-            <a:off x="548640" y="4828032"/>
-            <a:ext cx="1737360" cy="457200"/>
+            <a:off x="530352" y="4919472"/>
+            <a:ext cx="1353312" cy="566928"/>
           </a:xfrm>
           <a:prstGeom prst="rect">
             <a:avLst/>
@@ -1630,7 +1630,7 @@
               <a:buNone/>
             </a:pPr>
             <a:r>
-              <a:rPr lang="en-US" sz="1050" dirty="0">
+              <a:rPr lang="en-US" sz="1000" dirty="0">
                 <a:solidFill>
                   <a:srgbClr val="6E6E73"/>
                 </a:solidFill>
@@ -1638,9 +1638,9 @@
                 <a:ea typeface="Calibri Light" pitchFamily="34" charset="-122"/>
                 <a:cs typeface="Calibri Light" pitchFamily="34" charset="-120"/>
               </a:rPr>
-              <a:t>Prédire avec des chiffres</a:t>
-            </a:r>
-            <a:endParaRPr lang="en-US" sz="1050" dirty="0"/>
+              <a:t>Le besoin qui fera la machine</a:t>
+            </a:r>
+            <a:endParaRPr lang="en-US" sz="1000" dirty="0"/>
           </a:p>
         </p:txBody>
       </p:sp>
@@ -1652,7 +1652,7 @@
         </p:nvSpPr>
         <p:spPr>
           <a:xfrm>
-            <a:off x="3209544" y="4215384"/>
+            <a:off x="2523744" y="4215384"/>
             <a:ext cx="164592" cy="164592"/>
           </a:xfrm>
           <a:prstGeom prst="ellipse">
@@ -1672,8 +1672,8 @@
         </p:nvSpPr>
         <p:spPr>
           <a:xfrm>
-            <a:off x="2423160" y="3657600"/>
-            <a:ext cx="1737360" cy="310896"/>
+            <a:off x="1929384" y="3675888"/>
+            <a:ext cx="1353312" cy="292608"/>
           </a:xfrm>
           <a:prstGeom prst="rect">
             <a:avLst/>
@@ -1689,7 +1689,7 @@
               <a:buNone/>
             </a:pPr>
             <a:r>
-              <a:rPr lang="en-US" sz="1600" b="1" dirty="0">
+              <a:rPr lang="en-US" sz="1450" b="1" dirty="0">
                 <a:solidFill>
                   <a:srgbClr val="0071E3"/>
                 </a:solidFill>
@@ -1697,9 +1697,9 @@
                 <a:ea typeface="Calibri" pitchFamily="34" charset="-122"/>
                 <a:cs typeface="Calibri" pitchFamily="34" charset="-120"/>
               </a:rPr>
-              <a:t>1922</a:t>
-            </a:r>
-            <a:endParaRPr lang="en-US" sz="1600" dirty="0"/>
+              <a:t>1950</a:t>
+            </a:r>
+            <a:endParaRPr lang="en-US" sz="1450" dirty="0"/>
           </a:p>
         </p:txBody>
       </p:sp>
@@ -1711,8 +1711,8 @@
         </p:nvSpPr>
         <p:spPr>
           <a:xfrm>
-            <a:off x="2423160" y="4498848"/>
-            <a:ext cx="1737360" cy="310896"/>
+            <a:off x="1929384" y="4480560"/>
+            <a:ext cx="1353312" cy="420624"/>
           </a:xfrm>
           <a:prstGeom prst="rect">
             <a:avLst/>
@@ -1728,7 +1728,7 @@
               <a:buNone/>
             </a:pPr>
             <a:r>
-              <a:rPr lang="en-US" sz="1250" b="1" dirty="0">
+              <a:rPr lang="en-US" sz="1150" b="1" dirty="0">
                 <a:solidFill>
                   <a:srgbClr val="1D1D1F"/>
                 </a:solidFill>
@@ -1736,9 +1736,9 @@
                 <a:ea typeface="Calibri" pitchFamily="34" charset="-122"/>
                 <a:cs typeface="Calibri" pitchFamily="34" charset="-120"/>
               </a:rPr>
-              <a:t>La météo à la main</a:t>
-            </a:r>
-            <a:endParaRPr lang="en-US" sz="1250" dirty="0"/>
+              <a:t>La météo sur ENIAC</a:t>
+            </a:r>
+            <a:endParaRPr lang="en-US" sz="1150" dirty="0"/>
           </a:p>
         </p:txBody>
       </p:sp>
@@ -1750,8 +1750,8 @@
         </p:nvSpPr>
         <p:spPr>
           <a:xfrm>
-            <a:off x="2423160" y="4828032"/>
-            <a:ext cx="1737360" cy="457200"/>
+            <a:off x="1929384" y="4919472"/>
+            <a:ext cx="1353312" cy="566928"/>
           </a:xfrm>
           <a:prstGeom prst="rect">
             <a:avLst/>
@@ -1767,7 +1767,7 @@
               <a:buNone/>
             </a:pPr>
             <a:r>
-              <a:rPr lang="en-US" sz="1050" dirty="0">
+              <a:rPr lang="en-US" sz="1000" dirty="0">
                 <a:solidFill>
                   <a:srgbClr val="6E6E73"/>
                 </a:solidFill>
@@ -1775,9 +1775,9 @@
                 <a:ea typeface="Calibri Light" pitchFamily="34" charset="-122"/>
                 <a:cs typeface="Calibri Light" pitchFamily="34" charset="-120"/>
               </a:rPr>
-              <a:t>Le véritable ancêtre</a:t>
-            </a:r>
-            <a:endParaRPr lang="en-US" sz="1050" dirty="0"/>
+              <a:t>24 h de prévision, des semaines de calcul</a:t>
+            </a:r>
+            <a:endParaRPr lang="en-US" sz="1000" dirty="0"/>
           </a:p>
         </p:txBody>
       </p:sp>
@@ -1789,7 +1789,7 @@
         </p:nvSpPr>
         <p:spPr>
           <a:xfrm>
-            <a:off x="5084064" y="4215384"/>
+            <a:off x="3922776" y="4215384"/>
             <a:ext cx="164592" cy="164592"/>
           </a:xfrm>
           <a:prstGeom prst="ellipse">
@@ -1809,8 +1809,8 @@
         </p:nvSpPr>
         <p:spPr>
           <a:xfrm>
-            <a:off x="4297680" y="3657600"/>
-            <a:ext cx="1737360" cy="310896"/>
+            <a:off x="3328416" y="3675888"/>
+            <a:ext cx="1353312" cy="292608"/>
           </a:xfrm>
           <a:prstGeom prst="rect">
             <a:avLst/>
@@ -1826,7 +1826,7 @@
               <a:buNone/>
             </a:pPr>
             <a:r>
-              <a:rPr lang="en-US" sz="1600" b="1" dirty="0">
+              <a:rPr lang="en-US" sz="1450" b="1" dirty="0">
                 <a:solidFill>
                   <a:srgbClr val="0071E3"/>
                 </a:solidFill>
@@ -1834,9 +1834,9 @@
                 <a:ea typeface="Calibri" pitchFamily="34" charset="-122"/>
                 <a:cs typeface="Calibri" pitchFamily="34" charset="-120"/>
               </a:rPr>
-              <a:t>1956</a:t>
-            </a:r>
-            <a:endParaRPr lang="en-US" sz="1600" dirty="0"/>
+              <a:t>1952</a:t>
+            </a:r>
+            <a:endParaRPr lang="en-US" sz="1450" dirty="0"/>
           </a:p>
         </p:txBody>
       </p:sp>
@@ -1848,8 +1848,8 @@
         </p:nvSpPr>
         <p:spPr>
           <a:xfrm>
-            <a:off x="4297680" y="4498848"/>
-            <a:ext cx="1737360" cy="310896"/>
+            <a:off x="3328416" y="4480560"/>
+            <a:ext cx="1353312" cy="420624"/>
           </a:xfrm>
           <a:prstGeom prst="rect">
             <a:avLst/>
@@ -1865,7 +1865,7 @@
               <a:buNone/>
             </a:pPr>
             <a:r>
-              <a:rPr lang="en-US" sz="1250" b="1" dirty="0">
+              <a:rPr lang="en-US" sz="1150" b="1" dirty="0">
                 <a:solidFill>
                   <a:srgbClr val="1D1D1F"/>
                 </a:solidFill>
@@ -1873,9 +1873,9 @@
                 <a:ea typeface="Calibri" pitchFamily="34" charset="-122"/>
                 <a:cs typeface="Calibri" pitchFamily="34" charset="-120"/>
               </a:rPr>
-              <a:t>Le mot est inventé</a:t>
-            </a:r>
-            <a:endParaRPr lang="en-US" sz="1250" dirty="0"/>
+              <a:t>UNIVAC prédit l'élection</a:t>
+            </a:r>
+            <a:endParaRPr lang="en-US" sz="1150" dirty="0"/>
           </a:p>
         </p:txBody>
       </p:sp>
@@ -1887,8 +1887,8 @@
         </p:nvSpPr>
         <p:spPr>
           <a:xfrm>
-            <a:off x="4297680" y="4828032"/>
-            <a:ext cx="1737360" cy="457200"/>
+            <a:off x="3328416" y="4919472"/>
+            <a:ext cx="1353312" cy="566928"/>
           </a:xfrm>
           <a:prstGeom prst="rect">
             <a:avLst/>
@@ -1904,7 +1904,7 @@
               <a:buNone/>
             </a:pPr>
             <a:r>
-              <a:rPr lang="en-US" sz="1050" dirty="0">
+              <a:rPr lang="en-US" sz="1000" dirty="0">
                 <a:solidFill>
                   <a:srgbClr val="6E6E73"/>
                 </a:solidFill>
@@ -1912,21 +1912,295 @@
                 <a:ea typeface="Calibri Light" pitchFamily="34" charset="-122"/>
                 <a:cs typeface="Calibri Light" pitchFamily="34" charset="-120"/>
               </a:rPr>
+              <a:t>438-93, contre tous les sondages</a:t>
+            </a:r>
+            <a:endParaRPr lang="en-US" sz="1000" dirty="0"/>
+          </a:p>
+        </p:txBody>
+      </p:sp>
+      <p:sp>
+        <p:nvSpPr>
+          <p:cNvPr id="19" name="Shape 16"/>
+          <p:cNvSpPr/>
+          <p:nvPr/>
+        </p:nvSpPr>
+        <p:spPr>
+          <a:xfrm>
+            <a:off x="5321808" y="4215384"/>
+            <a:ext cx="164592" cy="164592"/>
+          </a:xfrm>
+          <a:prstGeom prst="ellipse">
+            <a:avLst/>
+          </a:prstGeom>
+          <a:solidFill>
+            <a:srgbClr val="0071E3"/>
+          </a:solidFill>
+          <a:ln/>
+        </p:spPr>
+      </p:sp>
+      <p:sp>
+        <p:nvSpPr>
+          <p:cNvPr id="20" name="Text 17"/>
+          <p:cNvSpPr/>
+          <p:nvPr/>
+        </p:nvSpPr>
+        <p:spPr>
+          <a:xfrm>
+            <a:off x="4727448" y="3675888"/>
+            <a:ext cx="1353312" cy="292608"/>
+          </a:xfrm>
+          <a:prstGeom prst="rect">
+            <a:avLst/>
+          </a:prstGeom>
+          <a:noFill/>
+          <a:ln/>
+        </p:spPr>
+        <p:txBody>
+          <a:bodyPr wrap="square" lIns="0" tIns="0" rIns="0" bIns="0" rtlCol="0" anchor="ctr"/>
+          <a:lstStyle/>
+          <a:p>
+            <a:pPr algn="ctr" indent="0" marL="0">
+              <a:buNone/>
+            </a:pPr>
+            <a:r>
+              <a:rPr lang="en-US" sz="1450" b="1" dirty="0">
+                <a:solidFill>
+                  <a:srgbClr val="0071E3"/>
+                </a:solidFill>
+                <a:latin typeface="Calibri" pitchFamily="34" charset="0"/>
+                <a:ea typeface="Calibri" pitchFamily="34" charset="-122"/>
+                <a:cs typeface="Calibri" pitchFamily="34" charset="-120"/>
+              </a:rPr>
+              <a:t>1956</a:t>
+            </a:r>
+            <a:endParaRPr lang="en-US" sz="1450" dirty="0"/>
+          </a:p>
+        </p:txBody>
+      </p:sp>
+      <p:sp>
+        <p:nvSpPr>
+          <p:cNvPr id="21" name="Text 18"/>
+          <p:cNvSpPr/>
+          <p:nvPr/>
+        </p:nvSpPr>
+        <p:spPr>
+          <a:xfrm>
+            <a:off x="4727448" y="4480560"/>
+            <a:ext cx="1353312" cy="420624"/>
+          </a:xfrm>
+          <a:prstGeom prst="rect">
+            <a:avLst/>
+          </a:prstGeom>
+          <a:noFill/>
+          <a:ln/>
+        </p:spPr>
+        <p:txBody>
+          <a:bodyPr wrap="square" lIns="0" tIns="0" rIns="0" bIns="0" rtlCol="0" anchor="ctr"/>
+          <a:lstStyle/>
+          <a:p>
+            <a:pPr algn="ctr" indent="0" marL="0">
+              <a:buNone/>
+            </a:pPr>
+            <a:r>
+              <a:rPr lang="en-US" sz="1150" b="1" dirty="0">
+                <a:solidFill>
+                  <a:srgbClr val="1D1D1F"/>
+                </a:solidFill>
+                <a:latin typeface="Calibri" pitchFamily="34" charset="0"/>
+                <a:ea typeface="Calibri" pitchFamily="34" charset="-122"/>
+                <a:cs typeface="Calibri" pitchFamily="34" charset="-120"/>
+              </a:rPr>
+              <a:t>Le mot est inventé</a:t>
+            </a:r>
+            <a:endParaRPr lang="en-US" sz="1150" dirty="0"/>
+          </a:p>
+        </p:txBody>
+      </p:sp>
+      <p:sp>
+        <p:nvSpPr>
+          <p:cNvPr id="22" name="Text 19"/>
+          <p:cNvSpPr/>
+          <p:nvPr/>
+        </p:nvSpPr>
+        <p:spPr>
+          <a:xfrm>
+            <a:off x="4727448" y="4919472"/>
+            <a:ext cx="1353312" cy="566928"/>
+          </a:xfrm>
+          <a:prstGeom prst="rect">
+            <a:avLst/>
+          </a:prstGeom>
+          <a:noFill/>
+          <a:ln/>
+        </p:spPr>
+        <p:txBody>
+          <a:bodyPr wrap="square" lIns="0" tIns="0" rIns="0" bIns="0" rtlCol="0" anchor="ctr"/>
+          <a:lstStyle/>
+          <a:p>
+            <a:pPr algn="ctr" indent="0" marL="0">
+              <a:buNone/>
+            </a:pPr>
+            <a:r>
+              <a:rPr lang="en-US" sz="1000" dirty="0">
+                <a:solidFill>
+                  <a:srgbClr val="6E6E73"/>
+                </a:solidFill>
+                <a:latin typeface="Calibri Light" pitchFamily="34" charset="0"/>
+                <a:ea typeface="Calibri Light" pitchFamily="34" charset="-122"/>
+                <a:cs typeface="Calibri Light" pitchFamily="34" charset="-120"/>
+              </a:rPr>
               <a:t>Conférence de Dartmouth</a:t>
             </a:r>
-            <a:endParaRPr lang="en-US" sz="1050" dirty="0"/>
-          </a:p>
-        </p:txBody>
-      </p:sp>
-      <p:sp>
-        <p:nvSpPr>
-          <p:cNvPr id="19" name="Shape 16"/>
-          <p:cNvSpPr/>
-          <p:nvPr/>
-        </p:nvSpPr>
-        <p:spPr>
-          <a:xfrm>
-            <a:off x="6958584" y="4215384"/>
+            <a:endParaRPr lang="en-US" sz="1000" dirty="0"/>
+          </a:p>
+        </p:txBody>
+      </p:sp>
+      <p:sp>
+        <p:nvSpPr>
+          <p:cNvPr id="23" name="Shape 20"/>
+          <p:cNvSpPr/>
+          <p:nvPr/>
+        </p:nvSpPr>
+        <p:spPr>
+          <a:xfrm>
+            <a:off x="6720840" y="4215384"/>
+            <a:ext cx="164592" cy="164592"/>
+          </a:xfrm>
+          <a:prstGeom prst="ellipse">
+            <a:avLst/>
+          </a:prstGeom>
+          <a:solidFill>
+            <a:srgbClr val="0071E3"/>
+          </a:solidFill>
+          <a:ln/>
+        </p:spPr>
+      </p:sp>
+      <p:sp>
+        <p:nvSpPr>
+          <p:cNvPr id="24" name="Text 21"/>
+          <p:cNvSpPr/>
+          <p:nvPr/>
+        </p:nvSpPr>
+        <p:spPr>
+          <a:xfrm>
+            <a:off x="6126480" y="3675888"/>
+            <a:ext cx="1353312" cy="292608"/>
+          </a:xfrm>
+          <a:prstGeom prst="rect">
+            <a:avLst/>
+          </a:prstGeom>
+          <a:noFill/>
+          <a:ln/>
+        </p:spPr>
+        <p:txBody>
+          <a:bodyPr wrap="square" lIns="0" tIns="0" rIns="0" bIns="0" rtlCol="0" anchor="ctr"/>
+          <a:lstStyle/>
+          <a:p>
+            <a:pPr algn="ctr" indent="0" marL="0">
+              <a:buNone/>
+            </a:pPr>
+            <a:r>
+              <a:rPr lang="en-US" sz="1450" b="1" dirty="0">
+                <a:solidFill>
+                  <a:srgbClr val="0071E3"/>
+                </a:solidFill>
+                <a:latin typeface="Calibri" pitchFamily="34" charset="0"/>
+                <a:ea typeface="Calibri" pitchFamily="34" charset="-122"/>
+                <a:cs typeface="Calibri" pitchFamily="34" charset="-120"/>
+              </a:rPr>
+              <a:t>1958</a:t>
+            </a:r>
+            <a:endParaRPr lang="en-US" sz="1450" dirty="0"/>
+          </a:p>
+        </p:txBody>
+      </p:sp>
+      <p:sp>
+        <p:nvSpPr>
+          <p:cNvPr id="25" name="Text 22"/>
+          <p:cNvSpPr/>
+          <p:nvPr/>
+        </p:nvSpPr>
+        <p:spPr>
+          <a:xfrm>
+            <a:off x="6126480" y="4480560"/>
+            <a:ext cx="1353312" cy="420624"/>
+          </a:xfrm>
+          <a:prstGeom prst="rect">
+            <a:avLst/>
+          </a:prstGeom>
+          <a:noFill/>
+          <a:ln/>
+        </p:spPr>
+        <p:txBody>
+          <a:bodyPr wrap="square" lIns="0" tIns="0" rIns="0" bIns="0" rtlCol="0" anchor="ctr"/>
+          <a:lstStyle/>
+          <a:p>
+            <a:pPr algn="ctr" indent="0" marL="0">
+              <a:buNone/>
+            </a:pPr>
+            <a:r>
+              <a:rPr lang="en-US" sz="1150" b="1" dirty="0">
+                <a:solidFill>
+                  <a:srgbClr val="1D1D1F"/>
+                </a:solidFill>
+                <a:latin typeface="Calibri" pitchFamily="34" charset="0"/>
+                <a:ea typeface="Calibri" pitchFamily="34" charset="-122"/>
+                <a:cs typeface="Calibri" pitchFamily="34" charset="-120"/>
+              </a:rPr>
+              <a:t>Le score de crédit</a:t>
+            </a:r>
+            <a:endParaRPr lang="en-US" sz="1150" dirty="0"/>
+          </a:p>
+        </p:txBody>
+      </p:sp>
+      <p:sp>
+        <p:nvSpPr>
+          <p:cNvPr id="26" name="Text 23"/>
+          <p:cNvSpPr/>
+          <p:nvPr/>
+        </p:nvSpPr>
+        <p:spPr>
+          <a:xfrm>
+            <a:off x="6126480" y="4919472"/>
+            <a:ext cx="1353312" cy="566928"/>
+          </a:xfrm>
+          <a:prstGeom prst="rect">
+            <a:avLst/>
+          </a:prstGeom>
+          <a:noFill/>
+          <a:ln/>
+        </p:spPr>
+        <p:txBody>
+          <a:bodyPr wrap="square" lIns="0" tIns="0" rIns="0" bIns="0" rtlCol="0" anchor="ctr"/>
+          <a:lstStyle/>
+          <a:p>
+            <a:pPr algn="ctr" indent="0" marL="0">
+              <a:buNone/>
+            </a:pPr>
+            <a:r>
+              <a:rPr lang="en-US" sz="1000" dirty="0">
+                <a:solidFill>
+                  <a:srgbClr val="6E6E73"/>
+                </a:solidFill>
+                <a:latin typeface="Calibri Light" pitchFamily="34" charset="0"/>
+                <a:ea typeface="Calibri Light" pitchFamily="34" charset="-122"/>
+                <a:cs typeface="Calibri Light" pitchFamily="34" charset="-120"/>
+              </a:rPr>
+              <a:t>La prédiction entre dans l'économie</a:t>
+            </a:r>
+            <a:endParaRPr lang="en-US" sz="1000" dirty="0"/>
+          </a:p>
+        </p:txBody>
+      </p:sp>
+      <p:sp>
+        <p:nvSpPr>
+          <p:cNvPr id="27" name="Shape 24"/>
+          <p:cNvSpPr/>
+          <p:nvPr/>
+        </p:nvSpPr>
+        <p:spPr>
+          <a:xfrm>
+            <a:off x="8119872" y="4215384"/>
             <a:ext cx="164592" cy="164592"/>
           </a:xfrm>
           <a:prstGeom prst="ellipse">
@@ -1940,14 +2214,14 @@
       </p:sp>
       <p:sp>
         <p:nvSpPr>
-          <p:cNvPr id="20" name="Text 17"/>
-          <p:cNvSpPr/>
-          <p:nvPr/>
-        </p:nvSpPr>
-        <p:spPr>
-          <a:xfrm>
-            <a:off x="6172200" y="3657600"/>
-            <a:ext cx="1737360" cy="310896"/>
+          <p:cNvPr id="28" name="Text 25"/>
+          <p:cNvSpPr/>
+          <p:nvPr/>
+        </p:nvSpPr>
+        <p:spPr>
+          <a:xfrm>
+            <a:off x="7525512" y="3675888"/>
+            <a:ext cx="1353312" cy="292608"/>
           </a:xfrm>
           <a:prstGeom prst="rect">
             <a:avLst/>
@@ -1963,7 +2237,7 @@
               <a:buNone/>
             </a:pPr>
             <a:r>
-              <a:rPr lang="en-US" sz="1600" b="1" dirty="0">
+              <a:rPr lang="en-US" sz="1450" b="1" dirty="0">
                 <a:solidFill>
                   <a:srgbClr val="A04E00"/>
                 </a:solidFill>
@@ -1973,20 +2247,20 @@
               </a:rPr>
               <a:t>1974 · 87</a:t>
             </a:r>
-            <a:endParaRPr lang="en-US" sz="1600" dirty="0"/>
-          </a:p>
-        </p:txBody>
-      </p:sp>
-      <p:sp>
-        <p:nvSpPr>
-          <p:cNvPr id="21" name="Text 18"/>
-          <p:cNvSpPr/>
-          <p:nvPr/>
-        </p:nvSpPr>
-        <p:spPr>
-          <a:xfrm>
-            <a:off x="6172200" y="4498848"/>
-            <a:ext cx="1737360" cy="310896"/>
+            <a:endParaRPr lang="en-US" sz="1450" dirty="0"/>
+          </a:p>
+        </p:txBody>
+      </p:sp>
+      <p:sp>
+        <p:nvSpPr>
+          <p:cNvPr id="29" name="Text 26"/>
+          <p:cNvSpPr/>
+          <p:nvPr/>
+        </p:nvSpPr>
+        <p:spPr>
+          <a:xfrm>
+            <a:off x="7525512" y="4480560"/>
+            <a:ext cx="1353312" cy="420624"/>
           </a:xfrm>
           <a:prstGeom prst="rect">
             <a:avLst/>
@@ -2002,7 +2276,7 @@
               <a:buNone/>
             </a:pPr>
             <a:r>
-              <a:rPr lang="en-US" sz="1250" b="1" dirty="0">
+              <a:rPr lang="en-US" sz="1150" b="1" dirty="0">
                 <a:solidFill>
                   <a:srgbClr val="1D1D1F"/>
                 </a:solidFill>
@@ -2012,20 +2286,20 @@
               </a:rPr>
               <a:t>Deux hivers</a:t>
             </a:r>
-            <a:endParaRPr lang="en-US" sz="1250" dirty="0"/>
-          </a:p>
-        </p:txBody>
-      </p:sp>
-      <p:sp>
-        <p:nvSpPr>
-          <p:cNvPr id="22" name="Text 19"/>
-          <p:cNvSpPr/>
-          <p:nvPr/>
-        </p:nvSpPr>
-        <p:spPr>
-          <a:xfrm>
-            <a:off x="6172200" y="4828032"/>
-            <a:ext cx="1737360" cy="457200"/>
+            <a:endParaRPr lang="en-US" sz="1150" dirty="0"/>
+          </a:p>
+        </p:txBody>
+      </p:sp>
+      <p:sp>
+        <p:nvSpPr>
+          <p:cNvPr id="30" name="Text 27"/>
+          <p:cNvSpPr/>
+          <p:nvPr/>
+        </p:nvSpPr>
+        <p:spPr>
+          <a:xfrm>
+            <a:off x="7525512" y="4919472"/>
+            <a:ext cx="1353312" cy="566928"/>
           </a:xfrm>
           <a:prstGeom prst="rect">
             <a:avLst/>
@@ -2041,7 +2315,7 @@
               <a:buNone/>
             </a:pPr>
             <a:r>
-              <a:rPr lang="en-US" sz="1050" dirty="0">
+              <a:rPr lang="en-US" sz="1000" dirty="0">
                 <a:solidFill>
                   <a:srgbClr val="6E6E73"/>
                 </a:solidFill>
@@ -2051,19 +2325,19 @@
               </a:rPr>
               <a:t>Le mot devient un repoussoir</a:t>
             </a:r>
-            <a:endParaRPr lang="en-US" sz="1050" dirty="0"/>
-          </a:p>
-        </p:txBody>
-      </p:sp>
-      <p:sp>
-        <p:nvSpPr>
-          <p:cNvPr id="23" name="Shape 20"/>
-          <p:cNvSpPr/>
-          <p:nvPr/>
-        </p:nvSpPr>
-        <p:spPr>
-          <a:xfrm>
-            <a:off x="8833104" y="4215384"/>
+            <a:endParaRPr lang="en-US" sz="1000" dirty="0"/>
+          </a:p>
+        </p:txBody>
+      </p:sp>
+      <p:sp>
+        <p:nvSpPr>
+          <p:cNvPr id="31" name="Shape 28"/>
+          <p:cNvSpPr/>
+          <p:nvPr/>
+        </p:nvSpPr>
+        <p:spPr>
+          <a:xfrm>
+            <a:off x="9518904" y="4215384"/>
             <a:ext cx="164592" cy="164592"/>
           </a:xfrm>
           <a:prstGeom prst="ellipse">
@@ -2077,14 +2351,14 @@
       </p:sp>
       <p:sp>
         <p:nvSpPr>
-          <p:cNvPr id="24" name="Text 21"/>
-          <p:cNvSpPr/>
-          <p:nvPr/>
-        </p:nvSpPr>
-        <p:spPr>
-          <a:xfrm>
-            <a:off x="8046720" y="3657600"/>
-            <a:ext cx="1737360" cy="310896"/>
+          <p:cNvPr id="32" name="Text 29"/>
+          <p:cNvSpPr/>
+          <p:nvPr/>
+        </p:nvSpPr>
+        <p:spPr>
+          <a:xfrm>
+            <a:off x="8924544" y="3675888"/>
+            <a:ext cx="1353312" cy="292608"/>
           </a:xfrm>
           <a:prstGeom prst="rect">
             <a:avLst/>
@@ -2100,7 +2374,7 @@
               <a:buNone/>
             </a:pPr>
             <a:r>
-              <a:rPr lang="en-US" sz="1600" b="1" dirty="0">
+              <a:rPr lang="en-US" sz="1450" b="1" dirty="0">
                 <a:solidFill>
                   <a:srgbClr val="0071E3"/>
                 </a:solidFill>
@@ -2110,20 +2384,20 @@
               </a:rPr>
               <a:t>2012</a:t>
             </a:r>
-            <a:endParaRPr lang="en-US" sz="1600" dirty="0"/>
-          </a:p>
-        </p:txBody>
-      </p:sp>
-      <p:sp>
-        <p:nvSpPr>
-          <p:cNvPr id="25" name="Text 22"/>
-          <p:cNvSpPr/>
-          <p:nvPr/>
-        </p:nvSpPr>
-        <p:spPr>
-          <a:xfrm>
-            <a:off x="8046720" y="4498848"/>
-            <a:ext cx="1737360" cy="310896"/>
+            <a:endParaRPr lang="en-US" sz="1450" dirty="0"/>
+          </a:p>
+        </p:txBody>
+      </p:sp>
+      <p:sp>
+        <p:nvSpPr>
+          <p:cNvPr id="33" name="Text 30"/>
+          <p:cNvSpPr/>
+          <p:nvPr/>
+        </p:nvSpPr>
+        <p:spPr>
+          <a:xfrm>
+            <a:off x="8924544" y="4480560"/>
+            <a:ext cx="1353312" cy="420624"/>
           </a:xfrm>
           <a:prstGeom prst="rect">
             <a:avLst/>
@@ -2139,7 +2413,7 @@
               <a:buNone/>
             </a:pPr>
             <a:r>
-              <a:rPr lang="en-US" sz="1250" b="1" dirty="0">
+              <a:rPr lang="en-US" sz="1150" b="1" dirty="0">
                 <a:solidFill>
                   <a:srgbClr val="1D1D1F"/>
                 </a:solidFill>
@@ -2149,20 +2423,20 @@
               </a:rPr>
               <a:t>L'apprentissage profond</a:t>
             </a:r>
-            <a:endParaRPr lang="en-US" sz="1250" dirty="0"/>
-          </a:p>
-        </p:txBody>
-      </p:sp>
-      <p:sp>
-        <p:nvSpPr>
-          <p:cNvPr id="26" name="Text 23"/>
-          <p:cNvSpPr/>
-          <p:nvPr/>
-        </p:nvSpPr>
-        <p:spPr>
-          <a:xfrm>
-            <a:off x="8046720" y="4828032"/>
-            <a:ext cx="1737360" cy="457200"/>
+            <a:endParaRPr lang="en-US" sz="1150" dirty="0"/>
+          </a:p>
+        </p:txBody>
+      </p:sp>
+      <p:sp>
+        <p:nvSpPr>
+          <p:cNvPr id="34" name="Text 31"/>
+          <p:cNvSpPr/>
+          <p:nvPr/>
+        </p:nvSpPr>
+        <p:spPr>
+          <a:xfrm>
+            <a:off x="8924544" y="4919472"/>
+            <a:ext cx="1353312" cy="566928"/>
           </a:xfrm>
           <a:prstGeom prst="rect">
             <a:avLst/>
@@ -2178,7 +2452,7 @@
               <a:buNone/>
             </a:pPr>
             <a:r>
-              <a:rPr lang="en-US" sz="1050" dirty="0">
+              <a:rPr lang="en-US" sz="1000" dirty="0">
                 <a:solidFill>
                   <a:srgbClr val="6E6E73"/>
                 </a:solidFill>
@@ -2188,19 +2462,19 @@
               </a:rPr>
               <a:t>Le moment où ça marche</a:t>
             </a:r>
-            <a:endParaRPr lang="en-US" sz="1050" dirty="0"/>
-          </a:p>
-        </p:txBody>
-      </p:sp>
-      <p:sp>
-        <p:nvSpPr>
-          <p:cNvPr id="27" name="Shape 24"/>
-          <p:cNvSpPr/>
-          <p:nvPr/>
-        </p:nvSpPr>
-        <p:spPr>
-          <a:xfrm>
-            <a:off x="10707624" y="4215384"/>
+            <a:endParaRPr lang="en-US" sz="1000" dirty="0"/>
+          </a:p>
+        </p:txBody>
+      </p:sp>
+      <p:sp>
+        <p:nvSpPr>
+          <p:cNvPr id="35" name="Shape 32"/>
+          <p:cNvSpPr/>
+          <p:nvPr/>
+        </p:nvSpPr>
+        <p:spPr>
+          <a:xfrm>
+            <a:off x="10917936" y="4215384"/>
             <a:ext cx="164592" cy="164592"/>
           </a:xfrm>
           <a:prstGeom prst="ellipse">
@@ -2214,14 +2488,14 @@
       </p:sp>
       <p:sp>
         <p:nvSpPr>
-          <p:cNvPr id="28" name="Text 25"/>
-          <p:cNvSpPr/>
-          <p:nvPr/>
-        </p:nvSpPr>
-        <p:spPr>
-          <a:xfrm>
-            <a:off x="9921240" y="3657600"/>
-            <a:ext cx="1737360" cy="310896"/>
+          <p:cNvPr id="36" name="Text 33"/>
+          <p:cNvSpPr/>
+          <p:nvPr/>
+        </p:nvSpPr>
+        <p:spPr>
+          <a:xfrm>
+            <a:off x="10323576" y="3675888"/>
+            <a:ext cx="1353312" cy="292608"/>
           </a:xfrm>
           <a:prstGeom prst="rect">
             <a:avLst/>
@@ -2237,7 +2511,7 @@
               <a:buNone/>
             </a:pPr>
             <a:r>
-              <a:rPr lang="en-US" sz="1600" b="1" dirty="0">
+              <a:rPr lang="en-US" sz="1450" b="1" dirty="0">
                 <a:solidFill>
                   <a:srgbClr val="0071E3"/>
                 </a:solidFill>
@@ -2247,20 +2521,20 @@
               </a:rPr>
               <a:t>2022</a:t>
             </a:r>
-            <a:endParaRPr lang="en-US" sz="1600" dirty="0"/>
-          </a:p>
-        </p:txBody>
-      </p:sp>
-      <p:sp>
-        <p:nvSpPr>
-          <p:cNvPr id="29" name="Text 26"/>
-          <p:cNvSpPr/>
-          <p:nvPr/>
-        </p:nvSpPr>
-        <p:spPr>
-          <a:xfrm>
-            <a:off x="9921240" y="4498848"/>
-            <a:ext cx="1737360" cy="310896"/>
+            <a:endParaRPr lang="en-US" sz="1450" dirty="0"/>
+          </a:p>
+        </p:txBody>
+      </p:sp>
+      <p:sp>
+        <p:nvSpPr>
+          <p:cNvPr id="37" name="Text 34"/>
+          <p:cNvSpPr/>
+          <p:nvPr/>
+        </p:nvSpPr>
+        <p:spPr>
+          <a:xfrm>
+            <a:off x="10323576" y="4480560"/>
+            <a:ext cx="1353312" cy="420624"/>
           </a:xfrm>
           <a:prstGeom prst="rect">
             <a:avLst/>
@@ -2276,7 +2550,7 @@
               <a:buNone/>
             </a:pPr>
             <a:r>
-              <a:rPr lang="en-US" sz="1250" b="1" dirty="0">
+              <a:rPr lang="en-US" sz="1150" b="1" dirty="0">
                 <a:solidFill>
                   <a:srgbClr val="1D1D1F"/>
                 </a:solidFill>
@@ -2286,20 +2560,20 @@
               </a:rPr>
               <a:t>L'accès grand public</a:t>
             </a:r>
-            <a:endParaRPr lang="en-US" sz="1250" dirty="0"/>
-          </a:p>
-        </p:txBody>
-      </p:sp>
-      <p:sp>
-        <p:nvSpPr>
-          <p:cNvPr id="30" name="Text 27"/>
-          <p:cNvSpPr/>
-          <p:nvPr/>
-        </p:nvSpPr>
-        <p:spPr>
-          <a:xfrm>
-            <a:off x="9921240" y="4828032"/>
-            <a:ext cx="1737360" cy="457200"/>
+            <a:endParaRPr lang="en-US" sz="1150" dirty="0"/>
+          </a:p>
+        </p:txBody>
+      </p:sp>
+      <p:sp>
+        <p:nvSpPr>
+          <p:cNvPr id="38" name="Text 35"/>
+          <p:cNvSpPr/>
+          <p:nvPr/>
+        </p:nvSpPr>
+        <p:spPr>
+          <a:xfrm>
+            <a:off x="10323576" y="4919472"/>
+            <a:ext cx="1353312" cy="566928"/>
           </a:xfrm>
           <a:prstGeom prst="rect">
             <a:avLst/>
@@ -2315,7 +2589,7 @@
               <a:buNone/>
             </a:pPr>
             <a:r>
-              <a:rPr lang="en-US" sz="1050" dirty="0">
+              <a:rPr lang="en-US" sz="1000" dirty="0">
                 <a:solidFill>
                   <a:srgbClr val="6E6E73"/>
                 </a:solidFill>
@@ -2325,19 +2599,19 @@
               </a:rPr>
               <a:t>Une date, pas une percée</a:t>
             </a:r>
-            <a:endParaRPr lang="en-US" sz="1050" dirty="0"/>
-          </a:p>
-        </p:txBody>
-      </p:sp>
-      <p:sp>
-        <p:nvSpPr>
-          <p:cNvPr id="31" name="Text 28"/>
-          <p:cNvSpPr/>
-          <p:nvPr/>
-        </p:nvSpPr>
-        <p:spPr>
-          <a:xfrm>
-            <a:off x="5669280" y="5376672"/>
+            <a:endParaRPr lang="en-US" sz="1000" dirty="0"/>
+          </a:p>
+        </p:txBody>
+      </p:sp>
+      <p:sp>
+        <p:nvSpPr>
+          <p:cNvPr id="39" name="Text 36"/>
+          <p:cNvSpPr/>
+          <p:nvPr/>
+        </p:nvSpPr>
+        <p:spPr>
+          <a:xfrm>
+            <a:off x="7196328" y="5541264"/>
             <a:ext cx="2743200" cy="274320"/>
           </a:xfrm>
           <a:prstGeom prst="rect">
@@ -2370,13 +2644,13 @@
       </p:sp>
       <p:sp>
         <p:nvSpPr>
-          <p:cNvPr id="32" name="Text 29"/>
-          <p:cNvSpPr/>
-          <p:nvPr/>
-        </p:nvSpPr>
-        <p:spPr>
-          <a:xfrm>
-            <a:off x="640080" y="5943600"/>
+          <p:cNvPr id="40" name="Text 37"/>
+          <p:cNvSpPr/>
+          <p:nvPr/>
+        </p:nvSpPr>
+        <p:spPr>
+          <a:xfrm>
+            <a:off x="640080" y="6053328"/>
             <a:ext cx="10911535" cy="384048"/>
           </a:xfrm>
           <a:prstGeom prst="rect">

</xml_diff>

<commit_message>
Slides : reseau de neurones redessine, pastilles RN sur le chemin des donnees
Co-Authored-By: Claude Opus 5 <noreply@anthropic.com>
</commit_message>
<xml_diff>
--- a/slides/Genese-de-l-IA.pptx
+++ b/slides/Genese-de-l-IA.pptx
@@ -3025,7 +3025,7 @@
         <p:spPr>
           <a:xfrm>
             <a:off x="1508760" y="2724912"/>
-            <a:ext cx="2280818" cy="365760"/>
+            <a:ext cx="2006498" cy="365760"/>
           </a:xfrm>
           <a:prstGeom prst="rect">
             <a:avLst/>
@@ -3125,7 +3125,7 @@
         <p:spPr>
           <a:xfrm>
             <a:off x="1508760" y="3108960"/>
-            <a:ext cx="2280818" cy="365760"/>
+            <a:ext cx="2006498" cy="365760"/>
           </a:xfrm>
           <a:prstGeom prst="rect">
             <a:avLst/>
@@ -3225,7 +3225,7 @@
         <p:spPr>
           <a:xfrm>
             <a:off x="1508760" y="3493008"/>
-            <a:ext cx="2280818" cy="365760"/>
+            <a:ext cx="2006498" cy="365760"/>
           </a:xfrm>
           <a:prstGeom prst="rect">
             <a:avLst/>
@@ -3325,7 +3325,7 @@
         <p:spPr>
           <a:xfrm>
             <a:off x="1508760" y="3877056"/>
-            <a:ext cx="2280818" cy="365760"/>
+            <a:ext cx="2006498" cy="365760"/>
           </a:xfrm>
           <a:prstGeom prst="rect">
             <a:avLst/>
@@ -3358,6 +3358,65 @@
       <p:sp>
         <p:nvSpPr>
           <p:cNvPr id="21" name="Shape 19"/>
+          <p:cNvSpPr/>
+          <p:nvPr/>
+        </p:nvSpPr>
+        <p:spPr>
+          <a:xfrm>
+            <a:off x="3314090" y="3959352"/>
+            <a:ext cx="201168" cy="201168"/>
+          </a:xfrm>
+          <a:prstGeom prst="ellipse">
+            <a:avLst/>
+          </a:prstGeom>
+          <a:solidFill>
+            <a:srgbClr val="0071E3"/>
+          </a:solidFill>
+          <a:ln/>
+        </p:spPr>
+      </p:sp>
+      <p:sp>
+        <p:nvSpPr>
+          <p:cNvPr id="22" name="Text 20"/>
+          <p:cNvSpPr/>
+          <p:nvPr/>
+        </p:nvSpPr>
+        <p:spPr>
+          <a:xfrm>
+            <a:off x="3314090" y="3959352"/>
+            <a:ext cx="201168" cy="201168"/>
+          </a:xfrm>
+          <a:prstGeom prst="rect">
+            <a:avLst/>
+          </a:prstGeom>
+          <a:noFill/>
+          <a:ln/>
+        </p:spPr>
+        <p:txBody>
+          <a:bodyPr wrap="square" lIns="0" tIns="0" rIns="0" bIns="0" rtlCol="0" anchor="ctr"/>
+          <a:lstStyle/>
+          <a:p>
+            <a:pPr algn="ctr" indent="0" marL="0">
+              <a:buNone/>
+            </a:pPr>
+            <a:r>
+              <a:rPr lang="en-US" sz="650" b="1" dirty="0">
+                <a:solidFill>
+                  <a:srgbClr val="FFFFFF"/>
+                </a:solidFill>
+                <a:latin typeface="Calibri" pitchFamily="34" charset="0"/>
+                <a:ea typeface="Calibri" pitchFamily="34" charset="-122"/>
+                <a:cs typeface="Calibri" pitchFamily="34" charset="-120"/>
+              </a:rPr>
+              <a:t>RN</a:t>
+            </a:r>
+            <a:endParaRPr lang="en-US" sz="650" dirty="0"/>
+          </a:p>
+        </p:txBody>
+      </p:sp>
+      <p:sp>
+        <p:nvSpPr>
+          <p:cNvPr id="23" name="Shape 21"/>
           <p:cNvSpPr/>
           <p:nvPr/>
         </p:nvSpPr>
@@ -3379,7 +3438,7 @@
       </p:sp>
       <p:sp>
         <p:nvSpPr>
-          <p:cNvPr id="22" name="Text 20"/>
+          <p:cNvPr id="24" name="Text 22"/>
           <p:cNvSpPr/>
           <p:nvPr/>
         </p:nvSpPr>
@@ -3418,14 +3477,14 @@
       </p:sp>
       <p:sp>
         <p:nvSpPr>
-          <p:cNvPr id="23" name="Text 21"/>
+          <p:cNvPr id="25" name="Text 23"/>
           <p:cNvSpPr/>
           <p:nvPr/>
         </p:nvSpPr>
         <p:spPr>
           <a:xfrm>
             <a:off x="1508760" y="4261104"/>
-            <a:ext cx="2280818" cy="365760"/>
+            <a:ext cx="2006498" cy="365760"/>
           </a:xfrm>
           <a:prstGeom prst="rect">
             <a:avLst/>
@@ -3457,7 +3516,7 @@
       </p:sp>
       <p:sp>
         <p:nvSpPr>
-          <p:cNvPr id="24" name="Text 22"/>
+          <p:cNvPr id="26" name="Text 24"/>
           <p:cNvSpPr/>
           <p:nvPr/>
         </p:nvSpPr>
@@ -3496,7 +3555,7 @@
       </p:sp>
       <p:sp>
         <p:nvSpPr>
-          <p:cNvPr id="25" name="Shape 23"/>
+          <p:cNvPr id="27" name="Shape 25"/>
           <p:cNvSpPr/>
           <p:nvPr/>
         </p:nvSpPr>
@@ -3523,7 +3582,7 @@
       </p:sp>
       <p:sp>
         <p:nvSpPr>
-          <p:cNvPr id="26" name="Shape 24"/>
+          <p:cNvPr id="28" name="Shape 26"/>
           <p:cNvSpPr/>
           <p:nvPr/>
         </p:nvSpPr>
@@ -3543,7 +3602,7 @@
       </p:sp>
       <p:sp>
         <p:nvSpPr>
-          <p:cNvPr id="27" name="Text 25"/>
+          <p:cNvPr id="29" name="Text 27"/>
           <p:cNvSpPr/>
           <p:nvPr/>
         </p:nvSpPr>
@@ -3582,7 +3641,7 @@
       </p:sp>
       <p:sp>
         <p:nvSpPr>
-          <p:cNvPr id="28" name="Text 26"/>
+          <p:cNvPr id="30" name="Text 28"/>
           <p:cNvSpPr/>
           <p:nvPr/>
         </p:nvSpPr>
@@ -3621,7 +3680,7 @@
       </p:sp>
       <p:sp>
         <p:nvSpPr>
-          <p:cNvPr id="29" name="Shape 27"/>
+          <p:cNvPr id="31" name="Shape 29"/>
           <p:cNvSpPr/>
           <p:nvPr/>
         </p:nvSpPr>
@@ -3643,7 +3702,7 @@
       </p:sp>
       <p:sp>
         <p:nvSpPr>
-          <p:cNvPr id="30" name="Text 28"/>
+          <p:cNvPr id="32" name="Text 30"/>
           <p:cNvSpPr/>
           <p:nvPr/>
         </p:nvSpPr>
@@ -3682,14 +3741,14 @@
       </p:sp>
       <p:sp>
         <p:nvSpPr>
-          <p:cNvPr id="31" name="Text 29"/>
+          <p:cNvPr id="33" name="Text 31"/>
           <p:cNvSpPr/>
           <p:nvPr/>
         </p:nvSpPr>
         <p:spPr>
           <a:xfrm>
             <a:off x="5252618" y="2724912"/>
-            <a:ext cx="2280818" cy="365760"/>
+            <a:ext cx="2006498" cy="365760"/>
           </a:xfrm>
           <a:prstGeom prst="rect">
             <a:avLst/>
@@ -3721,7 +3780,7 @@
       </p:sp>
       <p:sp>
         <p:nvSpPr>
-          <p:cNvPr id="32" name="Shape 30"/>
+          <p:cNvPr id="34" name="Shape 32"/>
           <p:cNvSpPr/>
           <p:nvPr/>
         </p:nvSpPr>
@@ -3743,7 +3802,7 @@
       </p:sp>
       <p:sp>
         <p:nvSpPr>
-          <p:cNvPr id="33" name="Text 31"/>
+          <p:cNvPr id="35" name="Text 33"/>
           <p:cNvSpPr/>
           <p:nvPr/>
         </p:nvSpPr>
@@ -3782,14 +3841,14 @@
       </p:sp>
       <p:sp>
         <p:nvSpPr>
-          <p:cNvPr id="34" name="Text 32"/>
+          <p:cNvPr id="36" name="Text 34"/>
           <p:cNvSpPr/>
           <p:nvPr/>
         </p:nvSpPr>
         <p:spPr>
           <a:xfrm>
             <a:off x="5252618" y="3108960"/>
-            <a:ext cx="2280818" cy="365760"/>
+            <a:ext cx="2006498" cy="365760"/>
           </a:xfrm>
           <a:prstGeom prst="rect">
             <a:avLst/>
@@ -3821,7 +3880,66 @@
       </p:sp>
       <p:sp>
         <p:nvSpPr>
-          <p:cNvPr id="35" name="Shape 33"/>
+          <p:cNvPr id="37" name="Shape 35"/>
+          <p:cNvSpPr/>
+          <p:nvPr/>
+        </p:nvSpPr>
+        <p:spPr>
+          <a:xfrm>
+            <a:off x="7057949" y="3191256"/>
+            <a:ext cx="201168" cy="201168"/>
+          </a:xfrm>
+          <a:prstGeom prst="ellipse">
+            <a:avLst/>
+          </a:prstGeom>
+          <a:solidFill>
+            <a:srgbClr val="0071E3"/>
+          </a:solidFill>
+          <a:ln/>
+        </p:spPr>
+      </p:sp>
+      <p:sp>
+        <p:nvSpPr>
+          <p:cNvPr id="38" name="Text 36"/>
+          <p:cNvSpPr/>
+          <p:nvPr/>
+        </p:nvSpPr>
+        <p:spPr>
+          <a:xfrm>
+            <a:off x="7057949" y="3191256"/>
+            <a:ext cx="201168" cy="201168"/>
+          </a:xfrm>
+          <a:prstGeom prst="rect">
+            <a:avLst/>
+          </a:prstGeom>
+          <a:noFill/>
+          <a:ln/>
+        </p:spPr>
+        <p:txBody>
+          <a:bodyPr wrap="square" lIns="0" tIns="0" rIns="0" bIns="0" rtlCol="0" anchor="ctr"/>
+          <a:lstStyle/>
+          <a:p>
+            <a:pPr algn="ctr" indent="0" marL="0">
+              <a:buNone/>
+            </a:pPr>
+            <a:r>
+              <a:rPr lang="en-US" sz="650" b="1" dirty="0">
+                <a:solidFill>
+                  <a:srgbClr val="FFFFFF"/>
+                </a:solidFill>
+                <a:latin typeface="Calibri" pitchFamily="34" charset="0"/>
+                <a:ea typeface="Calibri" pitchFamily="34" charset="-122"/>
+                <a:cs typeface="Calibri" pitchFamily="34" charset="-120"/>
+              </a:rPr>
+              <a:t>RN</a:t>
+            </a:r>
+            <a:endParaRPr lang="en-US" sz="650" dirty="0"/>
+          </a:p>
+        </p:txBody>
+      </p:sp>
+      <p:sp>
+        <p:nvSpPr>
+          <p:cNvPr id="39" name="Shape 37"/>
           <p:cNvSpPr/>
           <p:nvPr/>
         </p:nvSpPr>
@@ -3843,7 +3961,7 @@
       </p:sp>
       <p:sp>
         <p:nvSpPr>
-          <p:cNvPr id="36" name="Text 34"/>
+          <p:cNvPr id="40" name="Text 38"/>
           <p:cNvSpPr/>
           <p:nvPr/>
         </p:nvSpPr>
@@ -3882,14 +4000,14 @@
       </p:sp>
       <p:sp>
         <p:nvSpPr>
-          <p:cNvPr id="37" name="Text 35"/>
+          <p:cNvPr id="41" name="Text 39"/>
           <p:cNvSpPr/>
           <p:nvPr/>
         </p:nvSpPr>
         <p:spPr>
           <a:xfrm>
             <a:off x="5252618" y="3493008"/>
-            <a:ext cx="2280818" cy="365760"/>
+            <a:ext cx="2006498" cy="365760"/>
           </a:xfrm>
           <a:prstGeom prst="rect">
             <a:avLst/>
@@ -3921,7 +4039,7 @@
       </p:sp>
       <p:sp>
         <p:nvSpPr>
-          <p:cNvPr id="38" name="Shape 36"/>
+          <p:cNvPr id="42" name="Shape 40"/>
           <p:cNvSpPr/>
           <p:nvPr/>
         </p:nvSpPr>
@@ -3943,7 +4061,7 @@
       </p:sp>
       <p:sp>
         <p:nvSpPr>
-          <p:cNvPr id="39" name="Text 37"/>
+          <p:cNvPr id="43" name="Text 41"/>
           <p:cNvSpPr/>
           <p:nvPr/>
         </p:nvSpPr>
@@ -3982,14 +4100,14 @@
       </p:sp>
       <p:sp>
         <p:nvSpPr>
-          <p:cNvPr id="40" name="Text 38"/>
+          <p:cNvPr id="44" name="Text 42"/>
           <p:cNvSpPr/>
           <p:nvPr/>
         </p:nvSpPr>
         <p:spPr>
           <a:xfrm>
             <a:off x="5252618" y="3877056"/>
-            <a:ext cx="2280818" cy="365760"/>
+            <a:ext cx="2006498" cy="365760"/>
           </a:xfrm>
           <a:prstGeom prst="rect">
             <a:avLst/>
@@ -4021,7 +4139,7 @@
       </p:sp>
       <p:sp>
         <p:nvSpPr>
-          <p:cNvPr id="41" name="Shape 39"/>
+          <p:cNvPr id="45" name="Shape 43"/>
           <p:cNvSpPr/>
           <p:nvPr/>
         </p:nvSpPr>
@@ -4043,7 +4161,7 @@
       </p:sp>
       <p:sp>
         <p:nvSpPr>
-          <p:cNvPr id="42" name="Text 40"/>
+          <p:cNvPr id="46" name="Text 44"/>
           <p:cNvSpPr/>
           <p:nvPr/>
         </p:nvSpPr>
@@ -4082,14 +4200,14 @@
       </p:sp>
       <p:sp>
         <p:nvSpPr>
-          <p:cNvPr id="43" name="Text 41"/>
+          <p:cNvPr id="47" name="Text 45"/>
           <p:cNvSpPr/>
           <p:nvPr/>
         </p:nvSpPr>
         <p:spPr>
           <a:xfrm>
             <a:off x="5252618" y="4261104"/>
-            <a:ext cx="2280818" cy="365760"/>
+            <a:ext cx="2006498" cy="365760"/>
           </a:xfrm>
           <a:prstGeom prst="rect">
             <a:avLst/>
@@ -4121,7 +4239,66 @@
       </p:sp>
       <p:sp>
         <p:nvSpPr>
-          <p:cNvPr id="44" name="Text 42"/>
+          <p:cNvPr id="48" name="Shape 46"/>
+          <p:cNvSpPr/>
+          <p:nvPr/>
+        </p:nvSpPr>
+        <p:spPr>
+          <a:xfrm>
+            <a:off x="7057949" y="4343400"/>
+            <a:ext cx="201168" cy="201168"/>
+          </a:xfrm>
+          <a:prstGeom prst="ellipse">
+            <a:avLst/>
+          </a:prstGeom>
+          <a:solidFill>
+            <a:srgbClr val="0071E3"/>
+          </a:solidFill>
+          <a:ln/>
+        </p:spPr>
+      </p:sp>
+      <p:sp>
+        <p:nvSpPr>
+          <p:cNvPr id="49" name="Text 47"/>
+          <p:cNvSpPr/>
+          <p:nvPr/>
+        </p:nvSpPr>
+        <p:spPr>
+          <a:xfrm>
+            <a:off x="7057949" y="4343400"/>
+            <a:ext cx="201168" cy="201168"/>
+          </a:xfrm>
+          <a:prstGeom prst="rect">
+            <a:avLst/>
+          </a:prstGeom>
+          <a:noFill/>
+          <a:ln/>
+        </p:spPr>
+        <p:txBody>
+          <a:bodyPr wrap="square" lIns="0" tIns="0" rIns="0" bIns="0" rtlCol="0" anchor="ctr"/>
+          <a:lstStyle/>
+          <a:p>
+            <a:pPr algn="ctr" indent="0" marL="0">
+              <a:buNone/>
+            </a:pPr>
+            <a:r>
+              <a:rPr lang="en-US" sz="650" b="1" dirty="0">
+                <a:solidFill>
+                  <a:srgbClr val="FFFFFF"/>
+                </a:solidFill>
+                <a:latin typeface="Calibri" pitchFamily="34" charset="0"/>
+                <a:ea typeface="Calibri" pitchFamily="34" charset="-122"/>
+                <a:cs typeface="Calibri" pitchFamily="34" charset="-120"/>
+              </a:rPr>
+              <a:t>RN</a:t>
+            </a:r>
+            <a:endParaRPr lang="en-US" sz="650" dirty="0"/>
+          </a:p>
+        </p:txBody>
+      </p:sp>
+      <p:sp>
+        <p:nvSpPr>
+          <p:cNvPr id="50" name="Text 48"/>
           <p:cNvSpPr/>
           <p:nvPr/>
         </p:nvSpPr>
@@ -4160,7 +4337,7 @@
       </p:sp>
       <p:sp>
         <p:nvSpPr>
-          <p:cNvPr id="45" name="Shape 43"/>
+          <p:cNvPr id="51" name="Shape 49"/>
           <p:cNvSpPr/>
           <p:nvPr/>
         </p:nvSpPr>
@@ -4187,7 +4364,7 @@
       </p:sp>
       <p:sp>
         <p:nvSpPr>
-          <p:cNvPr id="46" name="Shape 44"/>
+          <p:cNvPr id="52" name="Shape 50"/>
           <p:cNvSpPr/>
           <p:nvPr/>
         </p:nvSpPr>
@@ -4207,7 +4384,7 @@
       </p:sp>
       <p:sp>
         <p:nvSpPr>
-          <p:cNvPr id="47" name="Text 45"/>
+          <p:cNvPr id="53" name="Text 51"/>
           <p:cNvSpPr/>
           <p:nvPr/>
         </p:nvSpPr>
@@ -4246,7 +4423,7 @@
       </p:sp>
       <p:sp>
         <p:nvSpPr>
-          <p:cNvPr id="48" name="Text 46"/>
+          <p:cNvPr id="54" name="Text 52"/>
           <p:cNvSpPr/>
           <p:nvPr/>
         </p:nvSpPr>
@@ -4285,7 +4462,7 @@
       </p:sp>
       <p:sp>
         <p:nvSpPr>
-          <p:cNvPr id="49" name="Shape 47"/>
+          <p:cNvPr id="55" name="Shape 53"/>
           <p:cNvSpPr/>
           <p:nvPr/>
         </p:nvSpPr>
@@ -4307,7 +4484,7 @@
       </p:sp>
       <p:sp>
         <p:nvSpPr>
-          <p:cNvPr id="50" name="Text 48"/>
+          <p:cNvPr id="56" name="Text 54"/>
           <p:cNvSpPr/>
           <p:nvPr/>
         </p:nvSpPr>
@@ -4346,14 +4523,14 @@
       </p:sp>
       <p:sp>
         <p:nvSpPr>
-          <p:cNvPr id="51" name="Text 49"/>
+          <p:cNvPr id="57" name="Text 55"/>
           <p:cNvSpPr/>
           <p:nvPr/>
         </p:nvSpPr>
         <p:spPr>
           <a:xfrm>
             <a:off x="8996477" y="2724912"/>
-            <a:ext cx="2280818" cy="365760"/>
+            <a:ext cx="2006498" cy="365760"/>
           </a:xfrm>
           <a:prstGeom prst="rect">
             <a:avLst/>
@@ -4385,7 +4562,7 @@
       </p:sp>
       <p:sp>
         <p:nvSpPr>
-          <p:cNvPr id="52" name="Shape 50"/>
+          <p:cNvPr id="58" name="Shape 56"/>
           <p:cNvSpPr/>
           <p:nvPr/>
         </p:nvSpPr>
@@ -4407,7 +4584,7 @@
       </p:sp>
       <p:sp>
         <p:nvSpPr>
-          <p:cNvPr id="53" name="Text 51"/>
+          <p:cNvPr id="59" name="Text 57"/>
           <p:cNvSpPr/>
           <p:nvPr/>
         </p:nvSpPr>
@@ -4446,14 +4623,14 @@
       </p:sp>
       <p:sp>
         <p:nvSpPr>
-          <p:cNvPr id="54" name="Text 52"/>
+          <p:cNvPr id="60" name="Text 58"/>
           <p:cNvSpPr/>
           <p:nvPr/>
         </p:nvSpPr>
         <p:spPr>
           <a:xfrm>
             <a:off x="8996477" y="3108960"/>
-            <a:ext cx="2280818" cy="365760"/>
+            <a:ext cx="2006498" cy="365760"/>
           </a:xfrm>
           <a:prstGeom prst="rect">
             <a:avLst/>
@@ -4485,7 +4662,7 @@
       </p:sp>
       <p:sp>
         <p:nvSpPr>
-          <p:cNvPr id="55" name="Shape 53"/>
+          <p:cNvPr id="61" name="Shape 59"/>
           <p:cNvSpPr/>
           <p:nvPr/>
         </p:nvSpPr>
@@ -4507,7 +4684,7 @@
       </p:sp>
       <p:sp>
         <p:nvSpPr>
-          <p:cNvPr id="56" name="Text 54"/>
+          <p:cNvPr id="62" name="Text 60"/>
           <p:cNvSpPr/>
           <p:nvPr/>
         </p:nvSpPr>
@@ -4546,14 +4723,14 @@
       </p:sp>
       <p:sp>
         <p:nvSpPr>
-          <p:cNvPr id="57" name="Text 55"/>
+          <p:cNvPr id="63" name="Text 61"/>
           <p:cNvSpPr/>
           <p:nvPr/>
         </p:nvSpPr>
         <p:spPr>
           <a:xfrm>
             <a:off x="8996477" y="3493008"/>
-            <a:ext cx="2280818" cy="365760"/>
+            <a:ext cx="2006498" cy="365760"/>
           </a:xfrm>
           <a:prstGeom prst="rect">
             <a:avLst/>
@@ -4585,7 +4762,7 @@
       </p:sp>
       <p:sp>
         <p:nvSpPr>
-          <p:cNvPr id="58" name="Text 56"/>
+          <p:cNvPr id="64" name="Text 62"/>
           <p:cNvSpPr/>
           <p:nvPr/>
         </p:nvSpPr>
@@ -4624,7 +4801,105 @@
       </p:sp>
       <p:sp>
         <p:nvSpPr>
-          <p:cNvPr id="59" name="Shape 57"/>
+          <p:cNvPr id="65" name="Shape 63"/>
+          <p:cNvSpPr/>
+          <p:nvPr/>
+        </p:nvSpPr>
+        <p:spPr>
+          <a:xfrm>
+            <a:off x="640080" y="5577840"/>
+            <a:ext cx="182880" cy="182880"/>
+          </a:xfrm>
+          <a:prstGeom prst="ellipse">
+            <a:avLst/>
+          </a:prstGeom>
+          <a:solidFill>
+            <a:srgbClr val="0071E3"/>
+          </a:solidFill>
+          <a:ln/>
+        </p:spPr>
+      </p:sp>
+      <p:sp>
+        <p:nvSpPr>
+          <p:cNvPr id="66" name="Text 64"/>
+          <p:cNvSpPr/>
+          <p:nvPr/>
+        </p:nvSpPr>
+        <p:spPr>
+          <a:xfrm>
+            <a:off x="640080" y="5577840"/>
+            <a:ext cx="182880" cy="182880"/>
+          </a:xfrm>
+          <a:prstGeom prst="rect">
+            <a:avLst/>
+          </a:prstGeom>
+          <a:noFill/>
+          <a:ln/>
+        </p:spPr>
+        <p:txBody>
+          <a:bodyPr wrap="square" lIns="0" tIns="0" rIns="0" bIns="0" rtlCol="0" anchor="ctr"/>
+          <a:lstStyle/>
+          <a:p>
+            <a:pPr algn="ctr" indent="0" marL="0">
+              <a:buNone/>
+            </a:pPr>
+            <a:r>
+              <a:rPr lang="en-US" sz="600" b="1" dirty="0">
+                <a:solidFill>
+                  <a:srgbClr val="FFFFFF"/>
+                </a:solidFill>
+                <a:latin typeface="Calibri" pitchFamily="34" charset="0"/>
+                <a:ea typeface="Calibri" pitchFamily="34" charset="-122"/>
+                <a:cs typeface="Calibri" pitchFamily="34" charset="-120"/>
+              </a:rPr>
+              <a:t>RN</a:t>
+            </a:r>
+            <a:endParaRPr lang="en-US" sz="600" dirty="0"/>
+          </a:p>
+        </p:txBody>
+      </p:sp>
+      <p:sp>
+        <p:nvSpPr>
+          <p:cNvPr id="67" name="Text 65"/>
+          <p:cNvSpPr/>
+          <p:nvPr/>
+        </p:nvSpPr>
+        <p:spPr>
+          <a:xfrm>
+            <a:off x="896112" y="5559552"/>
+            <a:ext cx="4754880" cy="219456"/>
+          </a:xfrm>
+          <a:prstGeom prst="rect">
+            <a:avLst/>
+          </a:prstGeom>
+          <a:noFill/>
+          <a:ln/>
+        </p:spPr>
+        <p:txBody>
+          <a:bodyPr wrap="square" lIns="0" tIns="0" rIns="0" bIns="0" rtlCol="0" anchor="ctr"/>
+          <a:lstStyle/>
+          <a:p>
+            <a:pPr indent="0" marL="0">
+              <a:buNone/>
+            </a:pPr>
+            <a:r>
+              <a:rPr lang="en-US" sz="1050" dirty="0">
+                <a:solidFill>
+                  <a:srgbClr val="6E6E73"/>
+                </a:solidFill>
+                <a:latin typeface="Calibri Light" pitchFamily="34" charset="0"/>
+                <a:ea typeface="Calibri Light" pitchFamily="34" charset="-122"/>
+                <a:cs typeface="Calibri Light" pitchFamily="34" charset="-120"/>
+              </a:rPr>
+              <a:t>réseau de neurones — les trois seules étapes qui en sont un</a:t>
+            </a:r>
+            <a:endParaRPr lang="en-US" sz="1050" dirty="0"/>
+          </a:p>
+        </p:txBody>
+      </p:sp>
+      <p:sp>
+        <p:nvSpPr>
+          <p:cNvPr id="68" name="Shape 66"/>
           <p:cNvSpPr/>
           <p:nvPr/>
         </p:nvSpPr>
@@ -4644,7 +4919,7 @@
       </p:sp>
       <p:sp>
         <p:nvSpPr>
-          <p:cNvPr id="60" name="Shape 58"/>
+          <p:cNvPr id="69" name="Shape 67"/>
           <p:cNvSpPr/>
           <p:nvPr/>
         </p:nvSpPr>
@@ -4664,7 +4939,7 @@
       </p:sp>
       <p:sp>
         <p:nvSpPr>
-          <p:cNvPr id="61" name="Text 59"/>
+          <p:cNvPr id="70" name="Text 68"/>
           <p:cNvSpPr/>
           <p:nvPr/>
         </p:nvSpPr>
@@ -4924,7 +5199,7 @@
                 <a:ea typeface="Calibri" pitchFamily="34" charset="-122"/>
                 <a:cs typeface="Calibri" pitchFamily="34" charset="-120"/>
               </a:rPr>
-              <a:t>Entrées, couches, sortie</a:t>
+              <a:t>Entrées, poids, couches, sortie</a:t>
             </a:r>
             <a:endParaRPr lang="en-US" sz="1300" dirty="0"/>
           </a:p>
@@ -4977,14 +5252,882 @@
         </p:nvSpPr>
         <p:spPr>
           <a:xfrm>
-            <a:off x="1527048" y="3246120"/>
-            <a:ext cx="1060704" cy="0"/>
+            <a:off x="2212848" y="2852928"/>
+            <a:ext cx="2157984" cy="1975104"/>
+          </a:xfrm>
+          <a:prstGeom prst="roundRect">
+            <a:avLst>
+              <a:gd name="adj" fmla="val 5556"/>
+            </a:avLst>
+          </a:prstGeom>
+          <a:solidFill>
+            <a:srgbClr val="F0F6FE"/>
+          </a:solidFill>
+          <a:ln w="12700">
+            <a:solidFill>
+              <a:srgbClr val="F0F6FE"/>
+            </a:solidFill>
+            <a:prstDash val="solid"/>
+          </a:ln>
+        </p:spPr>
+      </p:sp>
+      <p:sp>
+        <p:nvSpPr>
+          <p:cNvPr id="9" name="Text 7"/>
+          <p:cNvSpPr/>
+          <p:nvPr/>
+        </p:nvSpPr>
+        <p:spPr>
+          <a:xfrm>
+            <a:off x="2212848" y="2889504"/>
+            <a:ext cx="2157984" cy="219456"/>
+          </a:xfrm>
+          <a:prstGeom prst="rect">
+            <a:avLst/>
+          </a:prstGeom>
+          <a:noFill/>
+          <a:ln/>
+        </p:spPr>
+        <p:txBody>
+          <a:bodyPr wrap="square" lIns="0" tIns="0" rIns="0" bIns="0" rtlCol="0" anchor="ctr"/>
+          <a:lstStyle/>
+          <a:p>
+            <a:pPr algn="ctr" indent="0" marL="0">
+              <a:buNone/>
+            </a:pPr>
+            <a:r>
+              <a:rPr lang="en-US" sz="850" b="1" spc="160" kern="0" dirty="0">
+                <a:solidFill>
+                  <a:srgbClr val="005BB8"/>
+                </a:solidFill>
+                <a:latin typeface="Calibri" pitchFamily="34" charset="0"/>
+                <a:ea typeface="Calibri" pitchFamily="34" charset="-122"/>
+                <a:cs typeface="Calibri" pitchFamily="34" charset="-120"/>
+              </a:rPr>
+              <a:t>COUCHES CACHÉES</a:t>
+            </a:r>
+            <a:endParaRPr lang="en-US" sz="850" dirty="0"/>
+          </a:p>
+        </p:txBody>
+      </p:sp>
+      <p:sp>
+        <p:nvSpPr>
+          <p:cNvPr id="10" name="Shape 8"/>
+          <p:cNvSpPr/>
+          <p:nvPr/>
+        </p:nvSpPr>
+        <p:spPr>
+          <a:xfrm flipV="1">
+            <a:off x="1554480" y="3218688"/>
+            <a:ext cx="1097280" cy="182880"/>
           </a:xfrm>
           <a:prstGeom prst="line">
             <a:avLst/>
           </a:prstGeom>
           <a:noFill/>
-          <a:ln w="12700">
+          <a:ln w="14796">
+            <a:solidFill>
+              <a:srgbClr val="0071E3">
+                <a:alpha val="43000"/>
+              </a:srgbClr>
+            </a:solidFill>
+            <a:prstDash val="solid"/>
+          </a:ln>
+        </p:spPr>
+      </p:sp>
+      <p:sp>
+        <p:nvSpPr>
+          <p:cNvPr id="11" name="Shape 9"/>
+          <p:cNvSpPr/>
+          <p:nvPr/>
+        </p:nvSpPr>
+        <p:spPr>
+          <a:xfrm>
+            <a:off x="1554480" y="3401568"/>
+            <a:ext cx="1097280" cy="246888"/>
+          </a:xfrm>
+          <a:prstGeom prst="line">
+            <a:avLst/>
+          </a:prstGeom>
+          <a:noFill/>
+          <a:ln w="30480">
+            <a:solidFill>
+              <a:srgbClr val="0071E3">
+                <a:alpha val="70000"/>
+              </a:srgbClr>
+            </a:solidFill>
+            <a:prstDash val="solid"/>
+          </a:ln>
+        </p:spPr>
+      </p:sp>
+      <p:sp>
+        <p:nvSpPr>
+          <p:cNvPr id="12" name="Shape 10"/>
+          <p:cNvSpPr/>
+          <p:nvPr/>
+        </p:nvSpPr>
+        <p:spPr>
+          <a:xfrm>
+            <a:off x="1554480" y="3401568"/>
+            <a:ext cx="1097280" cy="676656"/>
+          </a:xfrm>
+          <a:prstGeom prst="line">
+            <a:avLst/>
+          </a:prstGeom>
+          <a:noFill/>
+          <a:ln w="19622">
+            <a:solidFill>
+              <a:srgbClr val="0071E3">
+                <a:alpha val="51000"/>
+              </a:srgbClr>
+            </a:solidFill>
+            <a:prstDash val="solid"/>
+          </a:ln>
+        </p:spPr>
+      </p:sp>
+      <p:sp>
+        <p:nvSpPr>
+          <p:cNvPr id="13" name="Shape 11"/>
+          <p:cNvSpPr/>
+          <p:nvPr/>
+        </p:nvSpPr>
+        <p:spPr>
+          <a:xfrm>
+            <a:off x="1554480" y="3401568"/>
+            <a:ext cx="1097280" cy="1106424"/>
+          </a:xfrm>
+          <a:prstGeom prst="line">
+            <a:avLst/>
+          </a:prstGeom>
+          <a:noFill/>
+          <a:ln w="25654">
+            <a:solidFill>
+              <a:srgbClr val="0071E3">
+                <a:alpha val="62000"/>
+              </a:srgbClr>
+            </a:solidFill>
+            <a:prstDash val="solid"/>
+          </a:ln>
+        </p:spPr>
+      </p:sp>
+      <p:sp>
+        <p:nvSpPr>
+          <p:cNvPr id="14" name="Shape 12"/>
+          <p:cNvSpPr/>
+          <p:nvPr/>
+        </p:nvSpPr>
+        <p:spPr>
+          <a:xfrm flipV="1">
+            <a:off x="1554480" y="3218688"/>
+            <a:ext cx="1097280" cy="731520"/>
+          </a:xfrm>
+          <a:prstGeom prst="line">
+            <a:avLst/>
+          </a:prstGeom>
+          <a:noFill/>
+          <a:ln w="13589">
+            <a:solidFill>
+              <a:srgbClr val="0071E3">
+                <a:alpha val="41000"/>
+              </a:srgbClr>
+            </a:solidFill>
+            <a:prstDash val="solid"/>
+          </a:ln>
+        </p:spPr>
+      </p:sp>
+      <p:sp>
+        <p:nvSpPr>
+          <p:cNvPr id="15" name="Shape 13"/>
+          <p:cNvSpPr/>
+          <p:nvPr/>
+        </p:nvSpPr>
+        <p:spPr>
+          <a:xfrm flipV="1">
+            <a:off x="1554480" y="3648456"/>
+            <a:ext cx="1097280" cy="301752"/>
+          </a:xfrm>
+          <a:prstGeom prst="line">
+            <a:avLst/>
+          </a:prstGeom>
+          <a:noFill/>
+          <a:ln w="30480">
+            <a:solidFill>
+              <a:srgbClr val="0071E3">
+                <a:alpha val="70000"/>
+              </a:srgbClr>
+            </a:solidFill>
+            <a:prstDash val="solid"/>
+          </a:ln>
+        </p:spPr>
+      </p:sp>
+      <p:sp>
+        <p:nvSpPr>
+          <p:cNvPr id="16" name="Shape 14"/>
+          <p:cNvSpPr/>
+          <p:nvPr/>
+        </p:nvSpPr>
+        <p:spPr>
+          <a:xfrm>
+            <a:off x="1554480" y="3950208"/>
+            <a:ext cx="1097280" cy="128016"/>
+          </a:xfrm>
+          <a:prstGeom prst="line">
+            <a:avLst/>
+          </a:prstGeom>
+          <a:noFill/>
+          <a:ln w="17209">
+            <a:solidFill>
+              <a:srgbClr val="0071E3">
+                <a:alpha val="47000"/>
+              </a:srgbClr>
+            </a:solidFill>
+            <a:prstDash val="solid"/>
+          </a:ln>
+        </p:spPr>
+      </p:sp>
+      <p:sp>
+        <p:nvSpPr>
+          <p:cNvPr id="17" name="Shape 15"/>
+          <p:cNvSpPr/>
+          <p:nvPr/>
+        </p:nvSpPr>
+        <p:spPr>
+          <a:xfrm>
+            <a:off x="1554480" y="3950208"/>
+            <a:ext cx="1097280" cy="557784"/>
+          </a:xfrm>
+          <a:prstGeom prst="line">
+            <a:avLst/>
+          </a:prstGeom>
+          <a:noFill/>
+          <a:ln w="23241">
+            <a:solidFill>
+              <a:srgbClr val="0071E3">
+                <a:alpha val="57000"/>
+              </a:srgbClr>
+            </a:solidFill>
+            <a:prstDash val="solid"/>
+          </a:ln>
+        </p:spPr>
+      </p:sp>
+      <p:sp>
+        <p:nvSpPr>
+          <p:cNvPr id="18" name="Shape 16"/>
+          <p:cNvSpPr/>
+          <p:nvPr/>
+        </p:nvSpPr>
+        <p:spPr>
+          <a:xfrm flipV="1">
+            <a:off x="1554480" y="3218688"/>
+            <a:ext cx="1097280" cy="1280160"/>
+          </a:xfrm>
+          <a:prstGeom prst="line">
+            <a:avLst/>
+          </a:prstGeom>
+          <a:noFill/>
+          <a:ln w="28067">
+            <a:solidFill>
+              <a:srgbClr val="0071E3">
+                <a:alpha val="66000"/>
+              </a:srgbClr>
+            </a:solidFill>
+            <a:prstDash val="solid"/>
+          </a:ln>
+        </p:spPr>
+      </p:sp>
+      <p:sp>
+        <p:nvSpPr>
+          <p:cNvPr id="19" name="Shape 17"/>
+          <p:cNvSpPr/>
+          <p:nvPr/>
+        </p:nvSpPr>
+        <p:spPr>
+          <a:xfrm flipV="1">
+            <a:off x="1554480" y="3648456"/>
+            <a:ext cx="1097280" cy="850392"/>
+          </a:xfrm>
+          <a:prstGeom prst="line">
+            <a:avLst/>
+          </a:prstGeom>
+          <a:noFill/>
+          <a:ln w="16002">
+            <a:solidFill>
+              <a:srgbClr val="0071E3">
+                <a:alpha val="45000"/>
+              </a:srgbClr>
+            </a:solidFill>
+            <a:prstDash val="solid"/>
+          </a:ln>
+        </p:spPr>
+      </p:sp>
+      <p:sp>
+        <p:nvSpPr>
+          <p:cNvPr id="20" name="Shape 18"/>
+          <p:cNvSpPr/>
+          <p:nvPr/>
+        </p:nvSpPr>
+        <p:spPr>
+          <a:xfrm flipV="1">
+            <a:off x="1554480" y="4078224"/>
+            <a:ext cx="1097280" cy="420624"/>
+          </a:xfrm>
+          <a:prstGeom prst="line">
+            <a:avLst/>
+          </a:prstGeom>
+          <a:noFill/>
+          <a:ln w="20828">
+            <a:solidFill>
+              <a:srgbClr val="0071E3">
+                <a:alpha val="53000"/>
+              </a:srgbClr>
+            </a:solidFill>
+            <a:prstDash val="solid"/>
+          </a:ln>
+        </p:spPr>
+      </p:sp>
+      <p:sp>
+        <p:nvSpPr>
+          <p:cNvPr id="21" name="Shape 19"/>
+          <p:cNvSpPr/>
+          <p:nvPr/>
+        </p:nvSpPr>
+        <p:spPr>
+          <a:xfrm>
+            <a:off x="1554480" y="4498848"/>
+            <a:ext cx="1097280" cy="9144"/>
+          </a:xfrm>
+          <a:prstGeom prst="line">
+            <a:avLst/>
+          </a:prstGeom>
+          <a:noFill/>
+          <a:ln w="30480">
+            <a:solidFill>
+              <a:srgbClr val="0071E3">
+                <a:alpha val="70000"/>
+              </a:srgbClr>
+            </a:solidFill>
+            <a:prstDash val="solid"/>
+          </a:ln>
+        </p:spPr>
+      </p:sp>
+      <p:sp>
+        <p:nvSpPr>
+          <p:cNvPr id="22" name="Shape 20"/>
+          <p:cNvSpPr/>
+          <p:nvPr/>
+        </p:nvSpPr>
+        <p:spPr>
+          <a:xfrm>
+            <a:off x="2926080" y="3218688"/>
+            <a:ext cx="731520" cy="0"/>
+          </a:xfrm>
+          <a:prstGeom prst="line">
+            <a:avLst/>
+          </a:prstGeom>
+          <a:noFill/>
+          <a:ln w="18415">
+            <a:solidFill>
+              <a:srgbClr val="0071E3">
+                <a:alpha val="49000"/>
+              </a:srgbClr>
+            </a:solidFill>
+            <a:prstDash val="solid"/>
+          </a:ln>
+        </p:spPr>
+      </p:sp>
+      <p:sp>
+        <p:nvSpPr>
+          <p:cNvPr id="23" name="Shape 21"/>
+          <p:cNvSpPr/>
+          <p:nvPr/>
+        </p:nvSpPr>
+        <p:spPr>
+          <a:xfrm>
+            <a:off x="2926080" y="3218688"/>
+            <a:ext cx="731520" cy="429768"/>
+          </a:xfrm>
+          <a:prstGeom prst="line">
+            <a:avLst/>
+          </a:prstGeom>
+          <a:noFill/>
+          <a:ln w="26861">
+            <a:solidFill>
+              <a:srgbClr val="0071E3">
+                <a:alpha val="64000"/>
+              </a:srgbClr>
+            </a:solidFill>
+            <a:prstDash val="solid"/>
+          </a:ln>
+        </p:spPr>
+      </p:sp>
+      <p:sp>
+        <p:nvSpPr>
+          <p:cNvPr id="24" name="Shape 22"/>
+          <p:cNvSpPr/>
+          <p:nvPr/>
+        </p:nvSpPr>
+        <p:spPr>
+          <a:xfrm>
+            <a:off x="2926080" y="3218688"/>
+            <a:ext cx="731520" cy="859536"/>
+          </a:xfrm>
+          <a:prstGeom prst="line">
+            <a:avLst/>
+          </a:prstGeom>
+          <a:noFill/>
+          <a:ln w="14796">
+            <a:solidFill>
+              <a:srgbClr val="0071E3">
+                <a:alpha val="43000"/>
+              </a:srgbClr>
+            </a:solidFill>
+            <a:prstDash val="solid"/>
+          </a:ln>
+        </p:spPr>
+      </p:sp>
+      <p:sp>
+        <p:nvSpPr>
+          <p:cNvPr id="25" name="Shape 23"/>
+          <p:cNvSpPr/>
+          <p:nvPr/>
+        </p:nvSpPr>
+        <p:spPr>
+          <a:xfrm>
+            <a:off x="2926080" y="3218688"/>
+            <a:ext cx="731520" cy="1289304"/>
+          </a:xfrm>
+          <a:prstGeom prst="line">
+            <a:avLst/>
+          </a:prstGeom>
+          <a:noFill/>
+          <a:ln w="30480">
+            <a:solidFill>
+              <a:srgbClr val="0071E3">
+                <a:alpha val="70000"/>
+              </a:srgbClr>
+            </a:solidFill>
+            <a:prstDash val="solid"/>
+          </a:ln>
+        </p:spPr>
+      </p:sp>
+      <p:sp>
+        <p:nvSpPr>
+          <p:cNvPr id="26" name="Shape 24"/>
+          <p:cNvSpPr/>
+          <p:nvPr/>
+        </p:nvSpPr>
+        <p:spPr>
+          <a:xfrm flipV="1">
+            <a:off x="2926080" y="3218688"/>
+            <a:ext cx="731520" cy="429768"/>
+          </a:xfrm>
+          <a:prstGeom prst="line">
+            <a:avLst/>
+          </a:prstGeom>
+          <a:noFill/>
+          <a:ln w="23241">
+            <a:solidFill>
+              <a:srgbClr val="0071E3">
+                <a:alpha val="57000"/>
+              </a:srgbClr>
+            </a:solidFill>
+            <a:prstDash val="solid"/>
+          </a:ln>
+        </p:spPr>
+      </p:sp>
+      <p:sp>
+        <p:nvSpPr>
+          <p:cNvPr id="27" name="Shape 25"/>
+          <p:cNvSpPr/>
+          <p:nvPr/>
+        </p:nvSpPr>
+        <p:spPr>
+          <a:xfrm>
+            <a:off x="2926080" y="3648456"/>
+            <a:ext cx="731520" cy="0"/>
+          </a:xfrm>
+          <a:prstGeom prst="line">
+            <a:avLst/>
+          </a:prstGeom>
+          <a:noFill/>
+          <a:ln w="17209">
+            <a:solidFill>
+              <a:srgbClr val="0071E3">
+                <a:alpha val="47000"/>
+              </a:srgbClr>
+            </a:solidFill>
+            <a:prstDash val="solid"/>
+          </a:ln>
+        </p:spPr>
+      </p:sp>
+      <p:sp>
+        <p:nvSpPr>
+          <p:cNvPr id="28" name="Shape 26"/>
+          <p:cNvSpPr/>
+          <p:nvPr/>
+        </p:nvSpPr>
+        <p:spPr>
+          <a:xfrm>
+            <a:off x="2926080" y="3648456"/>
+            <a:ext cx="731520" cy="429768"/>
+          </a:xfrm>
+          <a:prstGeom prst="line">
+            <a:avLst/>
+          </a:prstGeom>
+          <a:noFill/>
+          <a:ln w="29273">
+            <a:solidFill>
+              <a:srgbClr val="0071E3">
+                <a:alpha val="68000"/>
+              </a:srgbClr>
+            </a:solidFill>
+            <a:prstDash val="solid"/>
+          </a:ln>
+        </p:spPr>
+      </p:sp>
+      <p:sp>
+        <p:nvSpPr>
+          <p:cNvPr id="29" name="Shape 27"/>
+          <p:cNvSpPr/>
+          <p:nvPr/>
+        </p:nvSpPr>
+        <p:spPr>
+          <a:xfrm>
+            <a:off x="2926080" y="3648456"/>
+            <a:ext cx="731520" cy="859536"/>
+          </a:xfrm>
+          <a:prstGeom prst="line">
+            <a:avLst/>
+          </a:prstGeom>
+          <a:noFill/>
+          <a:ln w="13589">
+            <a:solidFill>
+              <a:srgbClr val="0071E3">
+                <a:alpha val="41000"/>
+              </a:srgbClr>
+            </a:solidFill>
+            <a:prstDash val="solid"/>
+          </a:ln>
+        </p:spPr>
+      </p:sp>
+      <p:sp>
+        <p:nvSpPr>
+          <p:cNvPr id="30" name="Shape 28"/>
+          <p:cNvSpPr/>
+          <p:nvPr/>
+        </p:nvSpPr>
+        <p:spPr>
+          <a:xfrm flipV="1">
+            <a:off x="2926080" y="3218688"/>
+            <a:ext cx="731520" cy="859536"/>
+          </a:xfrm>
+          <a:prstGeom prst="line">
+            <a:avLst/>
+          </a:prstGeom>
+          <a:noFill/>
+          <a:ln w="20828">
+            <a:solidFill>
+              <a:srgbClr val="0071E3">
+                <a:alpha val="53000"/>
+              </a:srgbClr>
+            </a:solidFill>
+            <a:prstDash val="solid"/>
+          </a:ln>
+        </p:spPr>
+      </p:sp>
+      <p:sp>
+        <p:nvSpPr>
+          <p:cNvPr id="31" name="Shape 29"/>
+          <p:cNvSpPr/>
+          <p:nvPr/>
+        </p:nvSpPr>
+        <p:spPr>
+          <a:xfrm flipV="1">
+            <a:off x="2926080" y="3648456"/>
+            <a:ext cx="731520" cy="429768"/>
+          </a:xfrm>
+          <a:prstGeom prst="line">
+            <a:avLst/>
+          </a:prstGeom>
+          <a:noFill/>
+          <a:ln w="25654">
+            <a:solidFill>
+              <a:srgbClr val="0071E3">
+                <a:alpha val="62000"/>
+              </a:srgbClr>
+            </a:solidFill>
+            <a:prstDash val="solid"/>
+          </a:ln>
+        </p:spPr>
+      </p:sp>
+      <p:sp>
+        <p:nvSpPr>
+          <p:cNvPr id="32" name="Shape 30"/>
+          <p:cNvSpPr/>
+          <p:nvPr/>
+        </p:nvSpPr>
+        <p:spPr>
+          <a:xfrm>
+            <a:off x="2926080" y="4078224"/>
+            <a:ext cx="731520" cy="0"/>
+          </a:xfrm>
+          <a:prstGeom prst="line">
+            <a:avLst/>
+          </a:prstGeom>
+          <a:noFill/>
+          <a:ln w="16002">
+            <a:solidFill>
+              <a:srgbClr val="0071E3">
+                <a:alpha val="45000"/>
+              </a:srgbClr>
+            </a:solidFill>
+            <a:prstDash val="solid"/>
+          </a:ln>
+        </p:spPr>
+      </p:sp>
+      <p:sp>
+        <p:nvSpPr>
+          <p:cNvPr id="33" name="Shape 31"/>
+          <p:cNvSpPr/>
+          <p:nvPr/>
+        </p:nvSpPr>
+        <p:spPr>
+          <a:xfrm>
+            <a:off x="2926080" y="4078224"/>
+            <a:ext cx="731520" cy="429768"/>
+          </a:xfrm>
+          <a:prstGeom prst="line">
+            <a:avLst/>
+          </a:prstGeom>
+          <a:noFill/>
+          <a:ln w="30480">
+            <a:solidFill>
+              <a:srgbClr val="0071E3">
+                <a:alpha val="70000"/>
+              </a:srgbClr>
+            </a:solidFill>
+            <a:prstDash val="solid"/>
+          </a:ln>
+        </p:spPr>
+      </p:sp>
+      <p:sp>
+        <p:nvSpPr>
+          <p:cNvPr id="34" name="Shape 32"/>
+          <p:cNvSpPr/>
+          <p:nvPr/>
+        </p:nvSpPr>
+        <p:spPr>
+          <a:xfrm flipV="1">
+            <a:off x="2926080" y="3218688"/>
+            <a:ext cx="731520" cy="1289304"/>
+          </a:xfrm>
+          <a:prstGeom prst="line">
+            <a:avLst/>
+          </a:prstGeom>
+          <a:noFill/>
+          <a:ln w="19622">
+            <a:solidFill>
+              <a:srgbClr val="0071E3">
+                <a:alpha val="51000"/>
+              </a:srgbClr>
+            </a:solidFill>
+            <a:prstDash val="solid"/>
+          </a:ln>
+        </p:spPr>
+      </p:sp>
+      <p:sp>
+        <p:nvSpPr>
+          <p:cNvPr id="35" name="Shape 33"/>
+          <p:cNvSpPr/>
+          <p:nvPr/>
+        </p:nvSpPr>
+        <p:spPr>
+          <a:xfrm flipV="1">
+            <a:off x="2926080" y="3648456"/>
+            <a:ext cx="731520" cy="859536"/>
+          </a:xfrm>
+          <a:prstGeom prst="line">
+            <a:avLst/>
+          </a:prstGeom>
+          <a:noFill/>
+          <a:ln w="28067">
+            <a:solidFill>
+              <a:srgbClr val="0071E3">
+                <a:alpha val="66000"/>
+              </a:srgbClr>
+            </a:solidFill>
+            <a:prstDash val="solid"/>
+          </a:ln>
+        </p:spPr>
+      </p:sp>
+      <p:sp>
+        <p:nvSpPr>
+          <p:cNvPr id="36" name="Shape 34"/>
+          <p:cNvSpPr/>
+          <p:nvPr/>
+        </p:nvSpPr>
+        <p:spPr>
+          <a:xfrm flipV="1">
+            <a:off x="2926080" y="4078224"/>
+            <a:ext cx="731520" cy="429768"/>
+          </a:xfrm>
+          <a:prstGeom prst="line">
+            <a:avLst/>
+          </a:prstGeom>
+          <a:noFill/>
+          <a:ln w="14796">
+            <a:solidFill>
+              <a:srgbClr val="0071E3">
+                <a:alpha val="43000"/>
+              </a:srgbClr>
+            </a:solidFill>
+            <a:prstDash val="solid"/>
+          </a:ln>
+        </p:spPr>
+      </p:sp>
+      <p:sp>
+        <p:nvSpPr>
+          <p:cNvPr id="37" name="Shape 35"/>
+          <p:cNvSpPr/>
+          <p:nvPr/>
+        </p:nvSpPr>
+        <p:spPr>
+          <a:xfrm>
+            <a:off x="2926080" y="4507992"/>
+            <a:ext cx="731520" cy="0"/>
+          </a:xfrm>
+          <a:prstGeom prst="line">
+            <a:avLst/>
+          </a:prstGeom>
+          <a:noFill/>
+          <a:ln w="24447">
+            <a:solidFill>
+              <a:srgbClr val="0071E3">
+                <a:alpha val="59000"/>
+              </a:srgbClr>
+            </a:solidFill>
+            <a:prstDash val="solid"/>
+          </a:ln>
+        </p:spPr>
+      </p:sp>
+      <p:sp>
+        <p:nvSpPr>
+          <p:cNvPr id="38" name="Shape 36"/>
+          <p:cNvSpPr/>
+          <p:nvPr/>
+        </p:nvSpPr>
+        <p:spPr>
+          <a:xfrm>
+            <a:off x="3931920" y="3218688"/>
+            <a:ext cx="1069848" cy="640080"/>
+          </a:xfrm>
+          <a:prstGeom prst="line">
+            <a:avLst/>
+          </a:prstGeom>
+          <a:noFill/>
+          <a:ln w="30480">
+            <a:solidFill>
+              <a:srgbClr val="0071E3">
+                <a:alpha val="70000"/>
+              </a:srgbClr>
+            </a:solidFill>
+            <a:prstDash val="solid"/>
+          </a:ln>
+        </p:spPr>
+      </p:sp>
+      <p:sp>
+        <p:nvSpPr>
+          <p:cNvPr id="39" name="Shape 37"/>
+          <p:cNvSpPr/>
+          <p:nvPr/>
+        </p:nvSpPr>
+        <p:spPr>
+          <a:xfrm>
+            <a:off x="3931920" y="3648456"/>
+            <a:ext cx="1069848" cy="210312"/>
+          </a:xfrm>
+          <a:prstGeom prst="line">
+            <a:avLst/>
+          </a:prstGeom>
+          <a:noFill/>
+          <a:ln w="17209">
+            <a:solidFill>
+              <a:srgbClr val="0071E3">
+                <a:alpha val="47000"/>
+              </a:srgbClr>
+            </a:solidFill>
+            <a:prstDash val="solid"/>
+          </a:ln>
+        </p:spPr>
+      </p:sp>
+      <p:sp>
+        <p:nvSpPr>
+          <p:cNvPr id="40" name="Shape 38"/>
+          <p:cNvSpPr/>
+          <p:nvPr/>
+        </p:nvSpPr>
+        <p:spPr>
+          <a:xfrm flipV="1">
+            <a:off x="3931920" y="3858768"/>
+            <a:ext cx="1069848" cy="219456"/>
+          </a:xfrm>
+          <a:prstGeom prst="line">
+            <a:avLst/>
+          </a:prstGeom>
+          <a:noFill/>
+          <a:ln w="22035">
+            <a:solidFill>
+              <a:srgbClr val="0071E3">
+                <a:alpha val="55000"/>
+              </a:srgbClr>
+            </a:solidFill>
+            <a:prstDash val="solid"/>
+          </a:ln>
+        </p:spPr>
+      </p:sp>
+      <p:sp>
+        <p:nvSpPr>
+          <p:cNvPr id="41" name="Shape 39"/>
+          <p:cNvSpPr/>
+          <p:nvPr/>
+        </p:nvSpPr>
+        <p:spPr>
+          <a:xfrm flipV="1">
+            <a:off x="3931920" y="3858768"/>
+            <a:ext cx="1069848" cy="649224"/>
+          </a:xfrm>
+          <a:prstGeom prst="line">
+            <a:avLst/>
+          </a:prstGeom>
+          <a:noFill/>
+          <a:ln w="26861">
+            <a:solidFill>
+              <a:srgbClr val="0071E3">
+                <a:alpha val="64000"/>
+              </a:srgbClr>
+            </a:solidFill>
+            <a:prstDash val="solid"/>
+          </a:ln>
+        </p:spPr>
+      </p:sp>
+      <p:sp>
+        <p:nvSpPr>
+          <p:cNvPr id="42" name="Shape 40"/>
+          <p:cNvSpPr/>
+          <p:nvPr/>
+        </p:nvSpPr>
+        <p:spPr>
+          <a:xfrm>
+            <a:off x="1280160" y="3264408"/>
+            <a:ext cx="274320" cy="274320"/>
+          </a:xfrm>
+          <a:prstGeom prst="ellipse">
+            <a:avLst/>
+          </a:prstGeom>
+          <a:solidFill>
+            <a:srgbClr val="FFFFFF"/>
+          </a:solidFill>
+          <a:ln w="19050">
             <a:solidFill>
               <a:srgbClr val="A9A9AF"/>
             </a:solidFill>
@@ -4994,20 +6137,22 @@
       </p:sp>
       <p:sp>
         <p:nvSpPr>
-          <p:cNvPr id="9" name="Shape 7"/>
-          <p:cNvSpPr/>
-          <p:nvPr/>
-        </p:nvSpPr>
-        <p:spPr>
-          <a:xfrm>
-            <a:off x="1527048" y="3246120"/>
-            <a:ext cx="1060704" cy="685800"/>
-          </a:xfrm>
-          <a:prstGeom prst="line">
-            <a:avLst/>
-          </a:prstGeom>
-          <a:noFill/>
-          <a:ln w="12700">
+          <p:cNvPr id="43" name="Shape 41"/>
+          <p:cNvSpPr/>
+          <p:nvPr/>
+        </p:nvSpPr>
+        <p:spPr>
+          <a:xfrm>
+            <a:off x="1280160" y="3813048"/>
+            <a:ext cx="274320" cy="274320"/>
+          </a:xfrm>
+          <a:prstGeom prst="ellipse">
+            <a:avLst/>
+          </a:prstGeom>
+          <a:solidFill>
+            <a:srgbClr val="FFFFFF"/>
+          </a:solidFill>
+          <a:ln w="19050">
             <a:solidFill>
               <a:srgbClr val="A9A9AF"/>
             </a:solidFill>
@@ -5017,20 +6162,22 @@
       </p:sp>
       <p:sp>
         <p:nvSpPr>
-          <p:cNvPr id="10" name="Shape 8"/>
-          <p:cNvSpPr/>
-          <p:nvPr/>
-        </p:nvSpPr>
-        <p:spPr>
-          <a:xfrm>
-            <a:off x="1527048" y="3246120"/>
-            <a:ext cx="1060704" cy="1371600"/>
-          </a:xfrm>
-          <a:prstGeom prst="line">
-            <a:avLst/>
-          </a:prstGeom>
-          <a:noFill/>
-          <a:ln w="12700">
+          <p:cNvPr id="44" name="Shape 42"/>
+          <p:cNvSpPr/>
+          <p:nvPr/>
+        </p:nvSpPr>
+        <p:spPr>
+          <a:xfrm>
+            <a:off x="1280160" y="4361688"/>
+            <a:ext cx="274320" cy="274320"/>
+          </a:xfrm>
+          <a:prstGeom prst="ellipse">
+            <a:avLst/>
+          </a:prstGeom>
+          <a:solidFill>
+            <a:srgbClr val="FFFFFF"/>
+          </a:solidFill>
+          <a:ln w="19050">
             <a:solidFill>
               <a:srgbClr val="A9A9AF"/>
             </a:solidFill>
@@ -5040,22 +6187,24 @@
       </p:sp>
       <p:sp>
         <p:nvSpPr>
-          <p:cNvPr id="11" name="Shape 9"/>
-          <p:cNvSpPr/>
-          <p:nvPr/>
-        </p:nvSpPr>
-        <p:spPr>
-          <a:xfrm flipV="1">
-            <a:off x="1527048" y="3246120"/>
-            <a:ext cx="1060704" cy="685800"/>
-          </a:xfrm>
-          <a:prstGeom prst="line">
-            <a:avLst/>
-          </a:prstGeom>
-          <a:noFill/>
-          <a:ln w="12700">
+          <p:cNvPr id="45" name="Shape 43"/>
+          <p:cNvSpPr/>
+          <p:nvPr/>
+        </p:nvSpPr>
+        <p:spPr>
+          <a:xfrm>
+            <a:off x="2651760" y="3081528"/>
+            <a:ext cx="274320" cy="274320"/>
+          </a:xfrm>
+          <a:prstGeom prst="ellipse">
+            <a:avLst/>
+          </a:prstGeom>
+          <a:solidFill>
+            <a:srgbClr val="FFFFFF"/>
+          </a:solidFill>
+          <a:ln w="19050">
             <a:solidFill>
-              <a:srgbClr val="A9A9AF"/>
+              <a:srgbClr val="C9DCF3"/>
             </a:solidFill>
             <a:prstDash val="solid"/>
           </a:ln>
@@ -5063,22 +6212,24 @@
       </p:sp>
       <p:sp>
         <p:nvSpPr>
-          <p:cNvPr id="12" name="Shape 10"/>
-          <p:cNvSpPr/>
-          <p:nvPr/>
-        </p:nvSpPr>
-        <p:spPr>
-          <a:xfrm>
-            <a:off x="1527048" y="3931920"/>
-            <a:ext cx="1060704" cy="0"/>
-          </a:xfrm>
-          <a:prstGeom prst="line">
-            <a:avLst/>
-          </a:prstGeom>
-          <a:noFill/>
-          <a:ln w="12700">
+          <p:cNvPr id="46" name="Shape 44"/>
+          <p:cNvSpPr/>
+          <p:nvPr/>
+        </p:nvSpPr>
+        <p:spPr>
+          <a:xfrm>
+            <a:off x="2651760" y="3511296"/>
+            <a:ext cx="274320" cy="274320"/>
+          </a:xfrm>
+          <a:prstGeom prst="ellipse">
+            <a:avLst/>
+          </a:prstGeom>
+          <a:solidFill>
+            <a:srgbClr val="FFFFFF"/>
+          </a:solidFill>
+          <a:ln w="19050">
             <a:solidFill>
-              <a:srgbClr val="A9A9AF"/>
+              <a:srgbClr val="C9DCF3"/>
             </a:solidFill>
             <a:prstDash val="solid"/>
           </a:ln>
@@ -5086,22 +6237,24 @@
       </p:sp>
       <p:sp>
         <p:nvSpPr>
-          <p:cNvPr id="13" name="Shape 11"/>
-          <p:cNvSpPr/>
-          <p:nvPr/>
-        </p:nvSpPr>
-        <p:spPr>
-          <a:xfrm>
-            <a:off x="1527048" y="3931920"/>
-            <a:ext cx="1060704" cy="685800"/>
-          </a:xfrm>
-          <a:prstGeom prst="line">
-            <a:avLst/>
-          </a:prstGeom>
-          <a:noFill/>
-          <a:ln w="12700">
+          <p:cNvPr id="47" name="Shape 45"/>
+          <p:cNvSpPr/>
+          <p:nvPr/>
+        </p:nvSpPr>
+        <p:spPr>
+          <a:xfrm>
+            <a:off x="2651760" y="3941064"/>
+            <a:ext cx="274320" cy="274320"/>
+          </a:xfrm>
+          <a:prstGeom prst="ellipse">
+            <a:avLst/>
+          </a:prstGeom>
+          <a:solidFill>
+            <a:srgbClr val="FFFFFF"/>
+          </a:solidFill>
+          <a:ln w="19050">
             <a:solidFill>
-              <a:srgbClr val="A9A9AF"/>
+              <a:srgbClr val="C9DCF3"/>
             </a:solidFill>
             <a:prstDash val="solid"/>
           </a:ln>
@@ -5109,22 +6262,24 @@
       </p:sp>
       <p:sp>
         <p:nvSpPr>
-          <p:cNvPr id="14" name="Shape 12"/>
-          <p:cNvSpPr/>
-          <p:nvPr/>
-        </p:nvSpPr>
-        <p:spPr>
-          <a:xfrm flipV="1">
-            <a:off x="1527048" y="3246120"/>
-            <a:ext cx="1060704" cy="1371600"/>
-          </a:xfrm>
-          <a:prstGeom prst="line">
-            <a:avLst/>
-          </a:prstGeom>
-          <a:noFill/>
-          <a:ln w="12700">
+          <p:cNvPr id="48" name="Shape 46"/>
+          <p:cNvSpPr/>
+          <p:nvPr/>
+        </p:nvSpPr>
+        <p:spPr>
+          <a:xfrm>
+            <a:off x="2651760" y="4370832"/>
+            <a:ext cx="274320" cy="274320"/>
+          </a:xfrm>
+          <a:prstGeom prst="ellipse">
+            <a:avLst/>
+          </a:prstGeom>
+          <a:solidFill>
+            <a:srgbClr val="FFFFFF"/>
+          </a:solidFill>
+          <a:ln w="19050">
             <a:solidFill>
-              <a:srgbClr val="A9A9AF"/>
+              <a:srgbClr val="C9DCF3"/>
             </a:solidFill>
             <a:prstDash val="solid"/>
           </a:ln>
@@ -5132,22 +6287,24 @@
       </p:sp>
       <p:sp>
         <p:nvSpPr>
-          <p:cNvPr id="15" name="Shape 13"/>
-          <p:cNvSpPr/>
-          <p:nvPr/>
-        </p:nvSpPr>
-        <p:spPr>
-          <a:xfrm flipV="1">
-            <a:off x="1527048" y="3931920"/>
-            <a:ext cx="1060704" cy="685800"/>
-          </a:xfrm>
-          <a:prstGeom prst="line">
-            <a:avLst/>
-          </a:prstGeom>
-          <a:noFill/>
-          <a:ln w="12700">
+          <p:cNvPr id="49" name="Shape 47"/>
+          <p:cNvSpPr/>
+          <p:nvPr/>
+        </p:nvSpPr>
+        <p:spPr>
+          <a:xfrm>
+            <a:off x="3657600" y="3081528"/>
+            <a:ext cx="274320" cy="274320"/>
+          </a:xfrm>
+          <a:prstGeom prst="ellipse">
+            <a:avLst/>
+          </a:prstGeom>
+          <a:solidFill>
+            <a:srgbClr val="FFFFFF"/>
+          </a:solidFill>
+          <a:ln w="19050">
             <a:solidFill>
-              <a:srgbClr val="A9A9AF"/>
+              <a:srgbClr val="C9DCF3"/>
             </a:solidFill>
             <a:prstDash val="solid"/>
           </a:ln>
@@ -5155,22 +6312,24 @@
       </p:sp>
       <p:sp>
         <p:nvSpPr>
-          <p:cNvPr id="16" name="Shape 14"/>
-          <p:cNvSpPr/>
-          <p:nvPr/>
-        </p:nvSpPr>
-        <p:spPr>
-          <a:xfrm>
-            <a:off x="1527048" y="4617720"/>
-            <a:ext cx="1060704" cy="0"/>
-          </a:xfrm>
-          <a:prstGeom prst="line">
-            <a:avLst/>
-          </a:prstGeom>
-          <a:noFill/>
-          <a:ln w="12700">
+          <p:cNvPr id="50" name="Shape 48"/>
+          <p:cNvSpPr/>
+          <p:nvPr/>
+        </p:nvSpPr>
+        <p:spPr>
+          <a:xfrm>
+            <a:off x="3657600" y="3511296"/>
+            <a:ext cx="274320" cy="274320"/>
+          </a:xfrm>
+          <a:prstGeom prst="ellipse">
+            <a:avLst/>
+          </a:prstGeom>
+          <a:solidFill>
+            <a:srgbClr val="FFFFFF"/>
+          </a:solidFill>
+          <a:ln w="19050">
             <a:solidFill>
-              <a:srgbClr val="A9A9AF"/>
+              <a:srgbClr val="C9DCF3"/>
             </a:solidFill>
             <a:prstDash val="solid"/>
           </a:ln>
@@ -5178,22 +6337,24 @@
       </p:sp>
       <p:sp>
         <p:nvSpPr>
-          <p:cNvPr id="17" name="Shape 15"/>
-          <p:cNvSpPr/>
-          <p:nvPr/>
-        </p:nvSpPr>
-        <p:spPr>
-          <a:xfrm>
-            <a:off x="2898648" y="3246120"/>
-            <a:ext cx="1060704" cy="0"/>
-          </a:xfrm>
-          <a:prstGeom prst="line">
-            <a:avLst/>
-          </a:prstGeom>
-          <a:noFill/>
-          <a:ln w="12700">
+          <p:cNvPr id="51" name="Shape 49"/>
+          <p:cNvSpPr/>
+          <p:nvPr/>
+        </p:nvSpPr>
+        <p:spPr>
+          <a:xfrm>
+            <a:off x="3657600" y="3941064"/>
+            <a:ext cx="274320" cy="274320"/>
+          </a:xfrm>
+          <a:prstGeom prst="ellipse">
+            <a:avLst/>
+          </a:prstGeom>
+          <a:solidFill>
+            <a:srgbClr val="FFFFFF"/>
+          </a:solidFill>
+          <a:ln w="19050">
             <a:solidFill>
-              <a:srgbClr val="A9A9AF"/>
+              <a:srgbClr val="C9DCF3"/>
             </a:solidFill>
             <a:prstDash val="solid"/>
           </a:ln>
@@ -5201,22 +6362,24 @@
       </p:sp>
       <p:sp>
         <p:nvSpPr>
-          <p:cNvPr id="18" name="Shape 16"/>
-          <p:cNvSpPr/>
-          <p:nvPr/>
-        </p:nvSpPr>
-        <p:spPr>
-          <a:xfrm>
-            <a:off x="2898648" y="3246120"/>
-            <a:ext cx="1060704" cy="685800"/>
-          </a:xfrm>
-          <a:prstGeom prst="line">
-            <a:avLst/>
-          </a:prstGeom>
-          <a:noFill/>
-          <a:ln w="12700">
+          <p:cNvPr id="52" name="Shape 50"/>
+          <p:cNvSpPr/>
+          <p:nvPr/>
+        </p:nvSpPr>
+        <p:spPr>
+          <a:xfrm>
+            <a:off x="3657600" y="4370832"/>
+            <a:ext cx="274320" cy="274320"/>
+          </a:xfrm>
+          <a:prstGeom prst="ellipse">
+            <a:avLst/>
+          </a:prstGeom>
+          <a:solidFill>
+            <a:srgbClr val="FFFFFF"/>
+          </a:solidFill>
+          <a:ln w="19050">
             <a:solidFill>
-              <a:srgbClr val="A9A9AF"/>
+              <a:srgbClr val="C9DCF3"/>
             </a:solidFill>
             <a:prstDash val="solid"/>
           </a:ln>
@@ -5224,327 +6387,22 @@
       </p:sp>
       <p:sp>
         <p:nvSpPr>
-          <p:cNvPr id="19" name="Shape 17"/>
-          <p:cNvSpPr/>
-          <p:nvPr/>
-        </p:nvSpPr>
-        <p:spPr>
-          <a:xfrm>
-            <a:off x="2898648" y="3246120"/>
-            <a:ext cx="1060704" cy="1371600"/>
-          </a:xfrm>
-          <a:prstGeom prst="line">
-            <a:avLst/>
-          </a:prstGeom>
-          <a:noFill/>
+          <p:cNvPr id="53" name="Shape 51"/>
+          <p:cNvSpPr/>
+          <p:nvPr/>
+        </p:nvSpPr>
+        <p:spPr>
+          <a:xfrm>
+            <a:off x="4928616" y="3648456"/>
+            <a:ext cx="420624" cy="420624"/>
+          </a:xfrm>
+          <a:prstGeom prst="ellipse">
+            <a:avLst/>
+          </a:prstGeom>
+          <a:solidFill>
+            <a:srgbClr val="0071E3"/>
+          </a:solidFill>
           <a:ln w="12700">
-            <a:solidFill>
-              <a:srgbClr val="A9A9AF"/>
-            </a:solidFill>
-            <a:prstDash val="solid"/>
-          </a:ln>
-        </p:spPr>
-      </p:sp>
-      <p:sp>
-        <p:nvSpPr>
-          <p:cNvPr id="20" name="Shape 18"/>
-          <p:cNvSpPr/>
-          <p:nvPr/>
-        </p:nvSpPr>
-        <p:spPr>
-          <a:xfrm flipV="1">
-            <a:off x="2898648" y="3246120"/>
-            <a:ext cx="1060704" cy="685800"/>
-          </a:xfrm>
-          <a:prstGeom prst="line">
-            <a:avLst/>
-          </a:prstGeom>
-          <a:noFill/>
-          <a:ln w="12700">
-            <a:solidFill>
-              <a:srgbClr val="A9A9AF"/>
-            </a:solidFill>
-            <a:prstDash val="solid"/>
-          </a:ln>
-        </p:spPr>
-      </p:sp>
-      <p:sp>
-        <p:nvSpPr>
-          <p:cNvPr id="21" name="Shape 19"/>
-          <p:cNvSpPr/>
-          <p:nvPr/>
-        </p:nvSpPr>
-        <p:spPr>
-          <a:xfrm>
-            <a:off x="2898648" y="3931920"/>
-            <a:ext cx="1060704" cy="0"/>
-          </a:xfrm>
-          <a:prstGeom prst="line">
-            <a:avLst/>
-          </a:prstGeom>
-          <a:noFill/>
-          <a:ln w="12700">
-            <a:solidFill>
-              <a:srgbClr val="A9A9AF"/>
-            </a:solidFill>
-            <a:prstDash val="solid"/>
-          </a:ln>
-        </p:spPr>
-      </p:sp>
-      <p:sp>
-        <p:nvSpPr>
-          <p:cNvPr id="22" name="Shape 20"/>
-          <p:cNvSpPr/>
-          <p:nvPr/>
-        </p:nvSpPr>
-        <p:spPr>
-          <a:xfrm>
-            <a:off x="2898648" y="3931920"/>
-            <a:ext cx="1060704" cy="685800"/>
-          </a:xfrm>
-          <a:prstGeom prst="line">
-            <a:avLst/>
-          </a:prstGeom>
-          <a:noFill/>
-          <a:ln w="12700">
-            <a:solidFill>
-              <a:srgbClr val="A9A9AF"/>
-            </a:solidFill>
-            <a:prstDash val="solid"/>
-          </a:ln>
-        </p:spPr>
-      </p:sp>
-      <p:sp>
-        <p:nvSpPr>
-          <p:cNvPr id="23" name="Shape 21"/>
-          <p:cNvSpPr/>
-          <p:nvPr/>
-        </p:nvSpPr>
-        <p:spPr>
-          <a:xfrm flipV="1">
-            <a:off x="2898648" y="3246120"/>
-            <a:ext cx="1060704" cy="1371600"/>
-          </a:xfrm>
-          <a:prstGeom prst="line">
-            <a:avLst/>
-          </a:prstGeom>
-          <a:noFill/>
-          <a:ln w="12700">
-            <a:solidFill>
-              <a:srgbClr val="A9A9AF"/>
-            </a:solidFill>
-            <a:prstDash val="solid"/>
-          </a:ln>
-        </p:spPr>
-      </p:sp>
-      <p:sp>
-        <p:nvSpPr>
-          <p:cNvPr id="24" name="Shape 22"/>
-          <p:cNvSpPr/>
-          <p:nvPr/>
-        </p:nvSpPr>
-        <p:spPr>
-          <a:xfrm flipV="1">
-            <a:off x="2898648" y="3931920"/>
-            <a:ext cx="1060704" cy="685800"/>
-          </a:xfrm>
-          <a:prstGeom prst="line">
-            <a:avLst/>
-          </a:prstGeom>
-          <a:noFill/>
-          <a:ln w="12700">
-            <a:solidFill>
-              <a:srgbClr val="A9A9AF"/>
-            </a:solidFill>
-            <a:prstDash val="solid"/>
-          </a:ln>
-        </p:spPr>
-      </p:sp>
-      <p:sp>
-        <p:nvSpPr>
-          <p:cNvPr id="25" name="Shape 23"/>
-          <p:cNvSpPr/>
-          <p:nvPr/>
-        </p:nvSpPr>
-        <p:spPr>
-          <a:xfrm>
-            <a:off x="2898648" y="4617720"/>
-            <a:ext cx="1060704" cy="0"/>
-          </a:xfrm>
-          <a:prstGeom prst="line">
-            <a:avLst/>
-          </a:prstGeom>
-          <a:noFill/>
-          <a:ln w="12700">
-            <a:solidFill>
-              <a:srgbClr val="A9A9AF"/>
-            </a:solidFill>
-            <a:prstDash val="solid"/>
-          </a:ln>
-        </p:spPr>
-      </p:sp>
-      <p:sp>
-        <p:nvSpPr>
-          <p:cNvPr id="26" name="Shape 24"/>
-          <p:cNvSpPr/>
-          <p:nvPr/>
-        </p:nvSpPr>
-        <p:spPr>
-          <a:xfrm>
-            <a:off x="4270248" y="3246120"/>
-            <a:ext cx="1060704" cy="685800"/>
-          </a:xfrm>
-          <a:prstGeom prst="line">
-            <a:avLst/>
-          </a:prstGeom>
-          <a:noFill/>
-          <a:ln w="12700">
-            <a:solidFill>
-              <a:srgbClr val="A9A9AF"/>
-            </a:solidFill>
-            <a:prstDash val="solid"/>
-          </a:ln>
-        </p:spPr>
-      </p:sp>
-      <p:sp>
-        <p:nvSpPr>
-          <p:cNvPr id="27" name="Shape 25"/>
-          <p:cNvSpPr/>
-          <p:nvPr/>
-        </p:nvSpPr>
-        <p:spPr>
-          <a:xfrm>
-            <a:off x="4270248" y="3931920"/>
-            <a:ext cx="1060704" cy="0"/>
-          </a:xfrm>
-          <a:prstGeom prst="line">
-            <a:avLst/>
-          </a:prstGeom>
-          <a:noFill/>
-          <a:ln w="12700">
-            <a:solidFill>
-              <a:srgbClr val="A9A9AF"/>
-            </a:solidFill>
-            <a:prstDash val="solid"/>
-          </a:ln>
-        </p:spPr>
-      </p:sp>
-      <p:sp>
-        <p:nvSpPr>
-          <p:cNvPr id="28" name="Shape 26"/>
-          <p:cNvSpPr/>
-          <p:nvPr/>
-        </p:nvSpPr>
-        <p:spPr>
-          <a:xfrm flipV="1">
-            <a:off x="4270248" y="3931920"/>
-            <a:ext cx="1060704" cy="685800"/>
-          </a:xfrm>
-          <a:prstGeom prst="line">
-            <a:avLst/>
-          </a:prstGeom>
-          <a:noFill/>
-          <a:ln w="12700">
-            <a:solidFill>
-              <a:srgbClr val="A9A9AF"/>
-            </a:solidFill>
-            <a:prstDash val="solid"/>
-          </a:ln>
-        </p:spPr>
-      </p:sp>
-      <p:sp>
-        <p:nvSpPr>
-          <p:cNvPr id="29" name="Shape 27"/>
-          <p:cNvSpPr/>
-          <p:nvPr/>
-        </p:nvSpPr>
-        <p:spPr>
-          <a:xfrm>
-            <a:off x="1216152" y="3090672"/>
-            <a:ext cx="310896" cy="310896"/>
-          </a:xfrm>
-          <a:prstGeom prst="ellipse">
-            <a:avLst/>
-          </a:prstGeom>
-          <a:solidFill>
-            <a:srgbClr val="FFFFFF"/>
-          </a:solidFill>
-          <a:ln w="25400">
-            <a:solidFill>
-              <a:srgbClr val="6E6E73"/>
-            </a:solidFill>
-            <a:prstDash val="solid"/>
-          </a:ln>
-        </p:spPr>
-      </p:sp>
-      <p:sp>
-        <p:nvSpPr>
-          <p:cNvPr id="30" name="Shape 28"/>
-          <p:cNvSpPr/>
-          <p:nvPr/>
-        </p:nvSpPr>
-        <p:spPr>
-          <a:xfrm>
-            <a:off x="1216152" y="3776472"/>
-            <a:ext cx="310896" cy="310896"/>
-          </a:xfrm>
-          <a:prstGeom prst="ellipse">
-            <a:avLst/>
-          </a:prstGeom>
-          <a:solidFill>
-            <a:srgbClr val="FFFFFF"/>
-          </a:solidFill>
-          <a:ln w="25400">
-            <a:solidFill>
-              <a:srgbClr val="6E6E73"/>
-            </a:solidFill>
-            <a:prstDash val="solid"/>
-          </a:ln>
-        </p:spPr>
-      </p:sp>
-      <p:sp>
-        <p:nvSpPr>
-          <p:cNvPr id="31" name="Shape 29"/>
-          <p:cNvSpPr/>
-          <p:nvPr/>
-        </p:nvSpPr>
-        <p:spPr>
-          <a:xfrm>
-            <a:off x="1216152" y="4462272"/>
-            <a:ext cx="310896" cy="310896"/>
-          </a:xfrm>
-          <a:prstGeom prst="ellipse">
-            <a:avLst/>
-          </a:prstGeom>
-          <a:solidFill>
-            <a:srgbClr val="FFFFFF"/>
-          </a:solidFill>
-          <a:ln w="25400">
-            <a:solidFill>
-              <a:srgbClr val="6E6E73"/>
-            </a:solidFill>
-            <a:prstDash val="solid"/>
-          </a:ln>
-        </p:spPr>
-      </p:sp>
-      <p:sp>
-        <p:nvSpPr>
-          <p:cNvPr id="32" name="Shape 30"/>
-          <p:cNvSpPr/>
-          <p:nvPr/>
-        </p:nvSpPr>
-        <p:spPr>
-          <a:xfrm>
-            <a:off x="2587752" y="3090672"/>
-            <a:ext cx="310896" cy="310896"/>
-          </a:xfrm>
-          <a:prstGeom prst="ellipse">
-            <a:avLst/>
-          </a:prstGeom>
-          <a:solidFill>
-            <a:srgbClr val="FFFFFF"/>
-          </a:solidFill>
-          <a:ln w="25400">
             <a:solidFill>
               <a:srgbClr val="0071E3"/>
             </a:solidFill>
@@ -5554,24 +6412,219 @@
       </p:sp>
       <p:sp>
         <p:nvSpPr>
-          <p:cNvPr id="33" name="Shape 31"/>
-          <p:cNvSpPr/>
-          <p:nvPr/>
-        </p:nvSpPr>
-        <p:spPr>
-          <a:xfrm>
-            <a:off x="2587752" y="3776472"/>
-            <a:ext cx="310896" cy="310896"/>
-          </a:xfrm>
-          <a:prstGeom prst="ellipse">
-            <a:avLst/>
-          </a:prstGeom>
-          <a:solidFill>
-            <a:srgbClr val="FFFFFF"/>
-          </a:solidFill>
-          <a:ln w="25400">
+          <p:cNvPr id="54" name="Text 52"/>
+          <p:cNvSpPr/>
+          <p:nvPr/>
+        </p:nvSpPr>
+        <p:spPr>
+          <a:xfrm>
+            <a:off x="4928616" y="3648456"/>
+            <a:ext cx="420624" cy="420624"/>
+          </a:xfrm>
+          <a:prstGeom prst="rect">
+            <a:avLst/>
+          </a:prstGeom>
+          <a:noFill/>
+          <a:ln/>
+        </p:spPr>
+        <p:txBody>
+          <a:bodyPr wrap="square" lIns="0" tIns="0" rIns="0" bIns="0" rtlCol="0" anchor="ctr"/>
+          <a:lstStyle/>
+          <a:p>
+            <a:pPr algn="ctr" indent="0" marL="0">
+              <a:buNone/>
+            </a:pPr>
+            <a:r>
+              <a:rPr lang="en-US" sz="1000" b="1" dirty="0">
+                <a:solidFill>
+                  <a:srgbClr val="FFFFFF"/>
+                </a:solidFill>
+                <a:latin typeface="Calibri" pitchFamily="34" charset="0"/>
+                <a:ea typeface="Calibri" pitchFamily="34" charset="-122"/>
+                <a:cs typeface="Calibri" pitchFamily="34" charset="-120"/>
+              </a:rPr>
+              <a:t>0,82</a:t>
+            </a:r>
+            <a:endParaRPr lang="en-US" sz="1000" dirty="0"/>
+          </a:p>
+        </p:txBody>
+      </p:sp>
+      <p:sp>
+        <p:nvSpPr>
+          <p:cNvPr id="55" name="Text 53"/>
+          <p:cNvSpPr/>
+          <p:nvPr/>
+        </p:nvSpPr>
+        <p:spPr>
+          <a:xfrm>
+            <a:off x="868680" y="4882896"/>
+            <a:ext cx="1097280" cy="237744"/>
+          </a:xfrm>
+          <a:prstGeom prst="rect">
+            <a:avLst/>
+          </a:prstGeom>
+          <a:noFill/>
+          <a:ln/>
+        </p:spPr>
+        <p:txBody>
+          <a:bodyPr wrap="square" lIns="0" tIns="0" rIns="0" bIns="0" rtlCol="0" anchor="ctr"/>
+          <a:lstStyle/>
+          <a:p>
+            <a:pPr algn="ctr" indent="0" marL="0">
+              <a:buNone/>
+            </a:pPr>
+            <a:r>
+              <a:rPr lang="en-US" sz="1150" b="1" dirty="0">
+                <a:solidFill>
+                  <a:srgbClr val="1D1D1F"/>
+                </a:solidFill>
+                <a:latin typeface="Calibri" pitchFamily="34" charset="0"/>
+                <a:ea typeface="Calibri" pitchFamily="34" charset="-122"/>
+                <a:cs typeface="Calibri" pitchFamily="34" charset="-120"/>
+              </a:rPr>
+              <a:t>Entrées</a:t>
+            </a:r>
+            <a:endParaRPr lang="en-US" sz="1150" dirty="0"/>
+          </a:p>
+        </p:txBody>
+      </p:sp>
+      <p:sp>
+        <p:nvSpPr>
+          <p:cNvPr id="56" name="Text 54"/>
+          <p:cNvSpPr/>
+          <p:nvPr/>
+        </p:nvSpPr>
+        <p:spPr>
+          <a:xfrm>
+            <a:off x="1554480" y="4882896"/>
+            <a:ext cx="1097280" cy="237744"/>
+          </a:xfrm>
+          <a:prstGeom prst="rect">
+            <a:avLst/>
+          </a:prstGeom>
+          <a:noFill/>
+          <a:ln/>
+        </p:spPr>
+        <p:txBody>
+          <a:bodyPr wrap="square" lIns="0" tIns="0" rIns="0" bIns="0" rtlCol="0" anchor="ctr"/>
+          <a:lstStyle/>
+          <a:p>
+            <a:pPr algn="ctr" indent="0" marL="0">
+              <a:buNone/>
+            </a:pPr>
+            <a:r>
+              <a:rPr lang="en-US" sz="1150" b="1" dirty="0">
+                <a:solidFill>
+                  <a:srgbClr val="1D1D1F"/>
+                </a:solidFill>
+                <a:latin typeface="Calibri" pitchFamily="34" charset="0"/>
+                <a:ea typeface="Calibri" pitchFamily="34" charset="-122"/>
+                <a:cs typeface="Calibri" pitchFamily="34" charset="-120"/>
+              </a:rPr>
+              <a:t>Poids</a:t>
+            </a:r>
+            <a:endParaRPr lang="en-US" sz="1150" dirty="0"/>
+          </a:p>
+        </p:txBody>
+      </p:sp>
+      <p:sp>
+        <p:nvSpPr>
+          <p:cNvPr id="57" name="Text 55"/>
+          <p:cNvSpPr/>
+          <p:nvPr/>
+        </p:nvSpPr>
+        <p:spPr>
+          <a:xfrm>
+            <a:off x="4590288" y="4882896"/>
+            <a:ext cx="1097280" cy="237744"/>
+          </a:xfrm>
+          <a:prstGeom prst="rect">
+            <a:avLst/>
+          </a:prstGeom>
+          <a:noFill/>
+          <a:ln/>
+        </p:spPr>
+        <p:txBody>
+          <a:bodyPr wrap="square" lIns="0" tIns="0" rIns="0" bIns="0" rtlCol="0" anchor="ctr"/>
+          <a:lstStyle/>
+          <a:p>
+            <a:pPr algn="ctr" indent="0" marL="0">
+              <a:buNone/>
+            </a:pPr>
+            <a:r>
+              <a:rPr lang="en-US" sz="1150" b="1" dirty="0">
+                <a:solidFill>
+                  <a:srgbClr val="1D1D1F"/>
+                </a:solidFill>
+                <a:latin typeface="Calibri" pitchFamily="34" charset="0"/>
+                <a:ea typeface="Calibri" pitchFamily="34" charset="-122"/>
+                <a:cs typeface="Calibri" pitchFamily="34" charset="-120"/>
+              </a:rPr>
+              <a:t>Sortie</a:t>
+            </a:r>
+            <a:endParaRPr lang="en-US" sz="1150" dirty="0"/>
+          </a:p>
+        </p:txBody>
+      </p:sp>
+      <p:sp>
+        <p:nvSpPr>
+          <p:cNvPr id="58" name="Text 56"/>
+          <p:cNvSpPr/>
+          <p:nvPr/>
+        </p:nvSpPr>
+        <p:spPr>
+          <a:xfrm>
+            <a:off x="4453128" y="5102352"/>
+            <a:ext cx="1371600" cy="219456"/>
+          </a:xfrm>
+          <a:prstGeom prst="rect">
+            <a:avLst/>
+          </a:prstGeom>
+          <a:noFill/>
+          <a:ln/>
+        </p:spPr>
+        <p:txBody>
+          <a:bodyPr wrap="square" lIns="0" tIns="0" rIns="0" bIns="0" rtlCol="0" anchor="ctr"/>
+          <a:lstStyle/>
+          <a:p>
+            <a:pPr algn="ctr" indent="0" marL="0">
+              <a:buNone/>
+            </a:pPr>
+            <a:r>
+              <a:rPr lang="en-US" sz="1000" dirty="0">
+                <a:solidFill>
+                  <a:srgbClr val="6E6E73"/>
+                </a:solidFill>
+                <a:latin typeface="Calibri Light" pitchFamily="34" charset="0"/>
+                <a:ea typeface="Calibri Light" pitchFamily="34" charset="-122"/>
+                <a:cs typeface="Calibri Light" pitchFamily="34" charset="-120"/>
+              </a:rPr>
+              <a:t>une probabilité</a:t>
+            </a:r>
+            <a:endParaRPr lang="en-US" sz="1000" dirty="0"/>
+          </a:p>
+        </p:txBody>
+      </p:sp>
+      <p:sp>
+        <p:nvSpPr>
+          <p:cNvPr id="59" name="Shape 57"/>
+          <p:cNvSpPr/>
+          <p:nvPr/>
+        </p:nvSpPr>
+        <p:spPr>
+          <a:xfrm>
+            <a:off x="914400" y="5422392"/>
+            <a:ext cx="274320" cy="0"/>
+          </a:xfrm>
+          <a:prstGeom prst="line">
+            <a:avLst/>
+          </a:prstGeom>
+          <a:noFill/>
+          <a:ln w="33020">
             <a:solidFill>
-              <a:srgbClr val="0071E3"/>
+              <a:srgbClr val="0071E3">
+                <a:alpha val="65000"/>
+              </a:srgbClr>
             </a:solidFill>
             <a:prstDash val="solid"/>
           </a:ln>
@@ -5579,311 +6632,30 @@
       </p:sp>
       <p:sp>
         <p:nvSpPr>
-          <p:cNvPr id="34" name="Shape 32"/>
-          <p:cNvSpPr/>
-          <p:nvPr/>
-        </p:nvSpPr>
-        <p:spPr>
-          <a:xfrm>
-            <a:off x="2587752" y="4462272"/>
-            <a:ext cx="310896" cy="310896"/>
-          </a:xfrm>
-          <a:prstGeom prst="ellipse">
-            <a:avLst/>
-          </a:prstGeom>
-          <a:solidFill>
-            <a:srgbClr val="FFFFFF"/>
-          </a:solidFill>
-          <a:ln w="25400">
-            <a:solidFill>
-              <a:srgbClr val="0071E3"/>
-            </a:solidFill>
-            <a:prstDash val="solid"/>
-          </a:ln>
-        </p:spPr>
-      </p:sp>
-      <p:sp>
-        <p:nvSpPr>
-          <p:cNvPr id="35" name="Shape 33"/>
-          <p:cNvSpPr/>
-          <p:nvPr/>
-        </p:nvSpPr>
-        <p:spPr>
-          <a:xfrm>
-            <a:off x="3959352" y="3090672"/>
-            <a:ext cx="310896" cy="310896"/>
-          </a:xfrm>
-          <a:prstGeom prst="ellipse">
-            <a:avLst/>
-          </a:prstGeom>
-          <a:solidFill>
-            <a:srgbClr val="FFFFFF"/>
-          </a:solidFill>
-          <a:ln w="25400">
-            <a:solidFill>
-              <a:srgbClr val="0071E3"/>
-            </a:solidFill>
-            <a:prstDash val="solid"/>
-          </a:ln>
-        </p:spPr>
-      </p:sp>
-      <p:sp>
-        <p:nvSpPr>
-          <p:cNvPr id="36" name="Shape 34"/>
-          <p:cNvSpPr/>
-          <p:nvPr/>
-        </p:nvSpPr>
-        <p:spPr>
-          <a:xfrm>
-            <a:off x="3959352" y="3776472"/>
-            <a:ext cx="310896" cy="310896"/>
-          </a:xfrm>
-          <a:prstGeom prst="ellipse">
-            <a:avLst/>
-          </a:prstGeom>
-          <a:solidFill>
-            <a:srgbClr val="FFFFFF"/>
-          </a:solidFill>
-          <a:ln w="25400">
-            <a:solidFill>
-              <a:srgbClr val="0071E3"/>
-            </a:solidFill>
-            <a:prstDash val="solid"/>
-          </a:ln>
-        </p:spPr>
-      </p:sp>
-      <p:sp>
-        <p:nvSpPr>
-          <p:cNvPr id="37" name="Shape 35"/>
-          <p:cNvSpPr/>
-          <p:nvPr/>
-        </p:nvSpPr>
-        <p:spPr>
-          <a:xfrm>
-            <a:off x="3959352" y="4462272"/>
-            <a:ext cx="310896" cy="310896"/>
-          </a:xfrm>
-          <a:prstGeom prst="ellipse">
-            <a:avLst/>
-          </a:prstGeom>
-          <a:solidFill>
-            <a:srgbClr val="FFFFFF"/>
-          </a:solidFill>
-          <a:ln w="25400">
-            <a:solidFill>
-              <a:srgbClr val="0071E3"/>
-            </a:solidFill>
-            <a:prstDash val="solid"/>
-          </a:ln>
-        </p:spPr>
-      </p:sp>
-      <p:sp>
-        <p:nvSpPr>
-          <p:cNvPr id="38" name="Shape 36"/>
-          <p:cNvSpPr/>
-          <p:nvPr/>
-        </p:nvSpPr>
-        <p:spPr>
-          <a:xfrm>
-            <a:off x="5330952" y="3776472"/>
-            <a:ext cx="310896" cy="310896"/>
-          </a:xfrm>
-          <a:prstGeom prst="ellipse">
-            <a:avLst/>
-          </a:prstGeom>
-          <a:solidFill>
-            <a:srgbClr val="E8F1FD"/>
-          </a:solidFill>
-          <a:ln w="25400">
-            <a:solidFill>
-              <a:srgbClr val="0071E3"/>
-            </a:solidFill>
-            <a:prstDash val="solid"/>
-          </a:ln>
-        </p:spPr>
-      </p:sp>
-      <p:sp>
-        <p:nvSpPr>
-          <p:cNvPr id="39" name="Text 37"/>
-          <p:cNvSpPr/>
-          <p:nvPr/>
-        </p:nvSpPr>
-        <p:spPr>
-          <a:xfrm>
-            <a:off x="713232" y="4956048"/>
-            <a:ext cx="1316736" cy="256032"/>
-          </a:xfrm>
-          <a:prstGeom prst="rect">
-            <a:avLst/>
-          </a:prstGeom>
-          <a:noFill/>
-          <a:ln/>
-        </p:spPr>
-        <p:txBody>
-          <a:bodyPr wrap="square" lIns="0" tIns="0" rIns="0" bIns="0" rtlCol="0" anchor="ctr"/>
-          <a:lstStyle/>
-          <a:p>
-            <a:pPr algn="ctr" indent="0" marL="0">
-              <a:buNone/>
-            </a:pPr>
-            <a:r>
-              <a:rPr lang="en-US" sz="1150" b="1" dirty="0">
-                <a:solidFill>
-                  <a:srgbClr val="6E6E73"/>
-                </a:solidFill>
-                <a:latin typeface="Calibri" pitchFamily="34" charset="0"/>
-                <a:ea typeface="Calibri" pitchFamily="34" charset="-122"/>
-                <a:cs typeface="Calibri" pitchFamily="34" charset="-120"/>
-              </a:rPr>
-              <a:t>Entrées</a:t>
-            </a:r>
-            <a:endParaRPr lang="en-US" sz="1150" dirty="0"/>
-          </a:p>
-        </p:txBody>
-      </p:sp>
-      <p:sp>
-        <p:nvSpPr>
-          <p:cNvPr id="40" name="Text 38"/>
-          <p:cNvSpPr/>
-          <p:nvPr/>
-        </p:nvSpPr>
-        <p:spPr>
-          <a:xfrm>
-            <a:off x="2084832" y="4956048"/>
-            <a:ext cx="1316736" cy="256032"/>
-          </a:xfrm>
-          <a:prstGeom prst="rect">
-            <a:avLst/>
-          </a:prstGeom>
-          <a:noFill/>
-          <a:ln/>
-        </p:spPr>
-        <p:txBody>
-          <a:bodyPr wrap="square" lIns="0" tIns="0" rIns="0" bIns="0" rtlCol="0" anchor="ctr"/>
-          <a:lstStyle/>
-          <a:p>
-            <a:pPr algn="ctr" indent="0" marL="0">
-              <a:buNone/>
-            </a:pPr>
-            <a:r>
-              <a:rPr lang="en-US" sz="1150" b="1" dirty="0">
-                <a:solidFill>
-                  <a:srgbClr val="6E6E73"/>
-                </a:solidFill>
-                <a:latin typeface="Calibri" pitchFamily="34" charset="0"/>
-                <a:ea typeface="Calibri" pitchFamily="34" charset="-122"/>
-                <a:cs typeface="Calibri" pitchFamily="34" charset="-120"/>
-              </a:rPr>
-              <a:t>Couche 1</a:t>
-            </a:r>
-            <a:endParaRPr lang="en-US" sz="1150" dirty="0"/>
-          </a:p>
-        </p:txBody>
-      </p:sp>
-      <p:sp>
-        <p:nvSpPr>
-          <p:cNvPr id="41" name="Text 39"/>
-          <p:cNvSpPr/>
-          <p:nvPr/>
-        </p:nvSpPr>
-        <p:spPr>
-          <a:xfrm>
-            <a:off x="3456432" y="4956048"/>
-            <a:ext cx="1316736" cy="256032"/>
-          </a:xfrm>
-          <a:prstGeom prst="rect">
-            <a:avLst/>
-          </a:prstGeom>
-          <a:noFill/>
-          <a:ln/>
-        </p:spPr>
-        <p:txBody>
-          <a:bodyPr wrap="square" lIns="0" tIns="0" rIns="0" bIns="0" rtlCol="0" anchor="ctr"/>
-          <a:lstStyle/>
-          <a:p>
-            <a:pPr algn="ctr" indent="0" marL="0">
-              <a:buNone/>
-            </a:pPr>
-            <a:r>
-              <a:rPr lang="en-US" sz="1150" b="1" dirty="0">
-                <a:solidFill>
-                  <a:srgbClr val="6E6E73"/>
-                </a:solidFill>
-                <a:latin typeface="Calibri" pitchFamily="34" charset="0"/>
-                <a:ea typeface="Calibri" pitchFamily="34" charset="-122"/>
-                <a:cs typeface="Calibri" pitchFamily="34" charset="-120"/>
-              </a:rPr>
-              <a:t>Couche 2</a:t>
-            </a:r>
-            <a:endParaRPr lang="en-US" sz="1150" dirty="0"/>
-          </a:p>
-        </p:txBody>
-      </p:sp>
-      <p:sp>
-        <p:nvSpPr>
-          <p:cNvPr id="42" name="Text 40"/>
-          <p:cNvSpPr/>
-          <p:nvPr/>
-        </p:nvSpPr>
-        <p:spPr>
-          <a:xfrm>
-            <a:off x="4828032" y="4956048"/>
-            <a:ext cx="1316736" cy="256032"/>
-          </a:xfrm>
-          <a:prstGeom prst="rect">
-            <a:avLst/>
-          </a:prstGeom>
-          <a:noFill/>
-          <a:ln/>
-        </p:spPr>
-        <p:txBody>
-          <a:bodyPr wrap="square" lIns="0" tIns="0" rIns="0" bIns="0" rtlCol="0" anchor="ctr"/>
-          <a:lstStyle/>
-          <a:p>
-            <a:pPr algn="ctr" indent="0" marL="0">
-              <a:buNone/>
-            </a:pPr>
-            <a:r>
-              <a:rPr lang="en-US" sz="1150" b="1" dirty="0">
-                <a:solidFill>
-                  <a:srgbClr val="6E6E73"/>
-                </a:solidFill>
-                <a:latin typeface="Calibri" pitchFamily="34" charset="0"/>
-                <a:ea typeface="Calibri" pitchFamily="34" charset="-122"/>
-                <a:cs typeface="Calibri" pitchFamily="34" charset="-120"/>
-              </a:rPr>
-              <a:t>Sortie</a:t>
-            </a:r>
-            <a:endParaRPr lang="en-US" sz="1150" dirty="0"/>
-          </a:p>
-        </p:txBody>
-      </p:sp>
-      <p:sp>
-        <p:nvSpPr>
-          <p:cNvPr id="43" name="Text 41"/>
-          <p:cNvSpPr/>
-          <p:nvPr/>
-        </p:nvSpPr>
-        <p:spPr>
-          <a:xfrm>
-            <a:off x="914400" y="5212080"/>
-            <a:ext cx="4937760" cy="457200"/>
-          </a:xfrm>
-          <a:prstGeom prst="rect">
-            <a:avLst/>
-          </a:prstGeom>
-          <a:noFill/>
-          <a:ln/>
-        </p:spPr>
-        <p:txBody>
-          <a:bodyPr wrap="square" lIns="0" tIns="0" rIns="0" bIns="0" rtlCol="0" anchor="ctr"/>
-          <a:lstStyle/>
-          <a:p>
-            <a:pPr indent="0" marL="0">
-              <a:buNone/>
-            </a:pPr>
-            <a:r>
-              <a:rPr lang="en-US" sz="1150" dirty="0">
+          <p:cNvPr id="60" name="Text 58"/>
+          <p:cNvSpPr/>
+          <p:nvPr/>
+        </p:nvSpPr>
+        <p:spPr>
+          <a:xfrm>
+            <a:off x="1261872" y="5312664"/>
+            <a:ext cx="2743200" cy="219456"/>
+          </a:xfrm>
+          <a:prstGeom prst="rect">
+            <a:avLst/>
+          </a:prstGeom>
+          <a:noFill/>
+          <a:ln/>
+        </p:spPr>
+        <p:txBody>
+          <a:bodyPr wrap="square" lIns="0" tIns="0" rIns="0" bIns="0" rtlCol="0" anchor="ctr"/>
+          <a:lstStyle/>
+          <a:p>
+            <a:pPr indent="0" marL="0">
+              <a:buNone/>
+            </a:pPr>
+            <a:r>
+              <a:rPr lang="en-US" sz="1000" dirty="0">
                 <a:solidFill>
                   <a:srgbClr val="6E6E73"/>
                 </a:solidFill>
@@ -5891,15 +6663,54 @@
                 <a:ea typeface="Calibri Light" pitchFamily="34" charset="-122"/>
                 <a:cs typeface="Calibri Light" pitchFamily="34" charset="-120"/>
               </a:rPr>
-              <a:t>Un modèle, ce sont ces poids : des centaines de milliards de nombres, figés à la fin de l'entraînement.</a:t>
-            </a:r>
-            <a:endParaRPr lang="en-US" sz="1150" dirty="0"/>
-          </a:p>
-        </p:txBody>
-      </p:sp>
-      <p:sp>
-        <p:nvSpPr>
-          <p:cNvPr id="44" name="Shape 42"/>
+              <a:t>épaisseur du trait = poids appris</a:t>
+            </a:r>
+            <a:endParaRPr lang="en-US" sz="1000" dirty="0"/>
+          </a:p>
+        </p:txBody>
+      </p:sp>
+      <p:sp>
+        <p:nvSpPr>
+          <p:cNvPr id="61" name="Text 59"/>
+          <p:cNvSpPr/>
+          <p:nvPr/>
+        </p:nvSpPr>
+        <p:spPr>
+          <a:xfrm>
+            <a:off x="914400" y="5504688"/>
+            <a:ext cx="4937760" cy="201168"/>
+          </a:xfrm>
+          <a:prstGeom prst="rect">
+            <a:avLst/>
+          </a:prstGeom>
+          <a:noFill/>
+          <a:ln/>
+        </p:spPr>
+        <p:txBody>
+          <a:bodyPr wrap="square" lIns="0" tIns="0" rIns="0" bIns="0" rtlCol="0" anchor="ctr"/>
+          <a:lstStyle/>
+          <a:p>
+            <a:pPr indent="0" marL="0">
+              <a:buNone/>
+            </a:pPr>
+            <a:r>
+              <a:rPr lang="en-US" sz="1050" dirty="0">
+                <a:solidFill>
+                  <a:srgbClr val="6E6E73"/>
+                </a:solidFill>
+                <a:latin typeface="Calibri Light" pitchFamily="34" charset="0"/>
+                <a:ea typeface="Calibri Light" pitchFamily="34" charset="-122"/>
+                <a:cs typeface="Calibri Light" pitchFamily="34" charset="-120"/>
+              </a:rPr>
+              <a:t>Un modèle, ce sont ces poids : des milliards de nombres figés après l'entraînement.</a:t>
+            </a:r>
+            <a:endParaRPr lang="en-US" sz="1050" dirty="0"/>
+          </a:p>
+        </p:txBody>
+      </p:sp>
+      <p:sp>
+        <p:nvSpPr>
+          <p:cNvPr id="62" name="Shape 60"/>
           <p:cNvSpPr/>
           <p:nvPr/>
         </p:nvSpPr>
@@ -5926,7 +6737,7 @@
       </p:sp>
       <p:sp>
         <p:nvSpPr>
-          <p:cNvPr id="45" name="Text 43"/>
+          <p:cNvPr id="63" name="Text 61"/>
           <p:cNvSpPr/>
           <p:nvPr/>
         </p:nvSpPr>
@@ -5965,7 +6776,7 @@
       </p:sp>
       <p:sp>
         <p:nvSpPr>
-          <p:cNvPr id="46" name="Text 44"/>
+          <p:cNvPr id="64" name="Text 62"/>
           <p:cNvSpPr/>
           <p:nvPr/>
         </p:nvSpPr>
@@ -6004,7 +6815,7 @@
       </p:sp>
       <p:sp>
         <p:nvSpPr>
-          <p:cNvPr id="47" name="Text 45"/>
+          <p:cNvPr id="65" name="Text 63"/>
           <p:cNvSpPr/>
           <p:nvPr/>
         </p:nvSpPr>
@@ -6043,7 +6854,7 @@
       </p:sp>
       <p:sp>
         <p:nvSpPr>
-          <p:cNvPr id="48" name="Shape 46"/>
+          <p:cNvPr id="66" name="Shape 64"/>
           <p:cNvSpPr/>
           <p:nvPr/>
         </p:nvSpPr>
@@ -6063,7 +6874,7 @@
       </p:sp>
       <p:sp>
         <p:nvSpPr>
-          <p:cNvPr id="49" name="Shape 47"/>
+          <p:cNvPr id="67" name="Shape 65"/>
           <p:cNvSpPr/>
           <p:nvPr/>
         </p:nvSpPr>
@@ -6083,7 +6894,7 @@
       </p:sp>
       <p:sp>
         <p:nvSpPr>
-          <p:cNvPr id="50" name="Text 48"/>
+          <p:cNvPr id="68" name="Text 66"/>
           <p:cNvSpPr/>
           <p:nvPr/>
         </p:nvSpPr>
@@ -6122,7 +6933,7 @@
       </p:sp>
       <p:sp>
         <p:nvSpPr>
-          <p:cNvPr id="51" name="Text 49"/>
+          <p:cNvPr id="69" name="Text 67"/>
           <p:cNvSpPr/>
           <p:nvPr/>
         </p:nvSpPr>
@@ -6161,7 +6972,7 @@
       </p:sp>
       <p:sp>
         <p:nvSpPr>
-          <p:cNvPr id="52" name="Shape 50"/>
+          <p:cNvPr id="70" name="Shape 68"/>
           <p:cNvSpPr/>
           <p:nvPr/>
         </p:nvSpPr>
@@ -6181,7 +6992,7 @@
       </p:sp>
       <p:sp>
         <p:nvSpPr>
-          <p:cNvPr id="53" name="Shape 51"/>
+          <p:cNvPr id="71" name="Shape 69"/>
           <p:cNvSpPr/>
           <p:nvPr/>
         </p:nvSpPr>
@@ -6201,7 +7012,7 @@
       </p:sp>
       <p:sp>
         <p:nvSpPr>
-          <p:cNvPr id="54" name="Text 52"/>
+          <p:cNvPr id="72" name="Text 70"/>
           <p:cNvSpPr/>
           <p:nvPr/>
         </p:nvSpPr>
@@ -6240,7 +7051,7 @@
       </p:sp>
       <p:sp>
         <p:nvSpPr>
-          <p:cNvPr id="55" name="Text 53"/>
+          <p:cNvPr id="73" name="Text 71"/>
           <p:cNvSpPr/>
           <p:nvPr/>
         </p:nvSpPr>
@@ -6279,7 +7090,7 @@
       </p:sp>
       <p:sp>
         <p:nvSpPr>
-          <p:cNvPr id="56" name="Shape 54"/>
+          <p:cNvPr id="74" name="Shape 72"/>
           <p:cNvSpPr/>
           <p:nvPr/>
         </p:nvSpPr>
@@ -6299,7 +7110,7 @@
       </p:sp>
       <p:sp>
         <p:nvSpPr>
-          <p:cNvPr id="57" name="Shape 55"/>
+          <p:cNvPr id="75" name="Shape 73"/>
           <p:cNvSpPr/>
           <p:nvPr/>
         </p:nvSpPr>
@@ -6319,7 +7130,7 @@
       </p:sp>
       <p:sp>
         <p:nvSpPr>
-          <p:cNvPr id="58" name="Text 56"/>
+          <p:cNvPr id="76" name="Text 74"/>
           <p:cNvSpPr/>
           <p:nvPr/>
         </p:nvSpPr>
@@ -6358,7 +7169,7 @@
       </p:sp>
       <p:sp>
         <p:nvSpPr>
-          <p:cNvPr id="59" name="Text 57"/>
+          <p:cNvPr id="77" name="Text 75"/>
           <p:cNvSpPr/>
           <p:nvPr/>
         </p:nvSpPr>
@@ -6397,7 +7208,7 @@
       </p:sp>
       <p:sp>
         <p:nvSpPr>
-          <p:cNvPr id="60" name="Text 58"/>
+          <p:cNvPr id="78" name="Text 76"/>
           <p:cNvSpPr/>
           <p:nvPr/>
         </p:nvSpPr>
@@ -6436,7 +7247,7 @@
       </p:sp>
       <p:sp>
         <p:nvSpPr>
-          <p:cNvPr id="61" name="Shape 59"/>
+          <p:cNvPr id="79" name="Shape 77"/>
           <p:cNvSpPr/>
           <p:nvPr/>
         </p:nvSpPr>
@@ -6456,7 +7267,7 @@
       </p:sp>
       <p:sp>
         <p:nvSpPr>
-          <p:cNvPr id="62" name="Shape 60"/>
+          <p:cNvPr id="80" name="Shape 78"/>
           <p:cNvSpPr/>
           <p:nvPr/>
         </p:nvSpPr>
@@ -6476,7 +7287,7 @@
       </p:sp>
       <p:sp>
         <p:nvSpPr>
-          <p:cNvPr id="63" name="Text 61"/>
+          <p:cNvPr id="81" name="Text 79"/>
           <p:cNvSpPr/>
           <p:nvPr/>
         </p:nvSpPr>
@@ -6515,7 +7326,7 @@
       </p:sp>
       <p:sp>
         <p:nvSpPr>
-          <p:cNvPr id="64" name="Text 62"/>
+          <p:cNvPr id="82" name="Text 80"/>
           <p:cNvSpPr/>
           <p:nvPr/>
         </p:nvSpPr>
@@ -6554,7 +7365,7 @@
       </p:sp>
       <p:sp>
         <p:nvSpPr>
-          <p:cNvPr id="65" name="Shape 63"/>
+          <p:cNvPr id="83" name="Shape 81"/>
           <p:cNvSpPr/>
           <p:nvPr/>
         </p:nvSpPr>
@@ -6574,7 +7385,7 @@
       </p:sp>
       <p:sp>
         <p:nvSpPr>
-          <p:cNvPr id="66" name="Shape 64"/>
+          <p:cNvPr id="84" name="Shape 82"/>
           <p:cNvSpPr/>
           <p:nvPr/>
         </p:nvSpPr>
@@ -6594,7 +7405,7 @@
       </p:sp>
       <p:sp>
         <p:nvSpPr>
-          <p:cNvPr id="67" name="Text 65"/>
+          <p:cNvPr id="85" name="Text 83"/>
           <p:cNvSpPr/>
           <p:nvPr/>
         </p:nvSpPr>
@@ -6633,7 +7444,7 @@
       </p:sp>
       <p:sp>
         <p:nvSpPr>
-          <p:cNvPr id="68" name="Text 66"/>
+          <p:cNvPr id="86" name="Text 84"/>
           <p:cNvSpPr/>
           <p:nvPr/>
         </p:nvSpPr>
@@ -6672,7 +7483,7 @@
       </p:sp>
       <p:sp>
         <p:nvSpPr>
-          <p:cNvPr id="69" name="Shape 67"/>
+          <p:cNvPr id="87" name="Shape 85"/>
           <p:cNvSpPr/>
           <p:nvPr/>
         </p:nvSpPr>
@@ -6692,7 +7503,7 @@
       </p:sp>
       <p:sp>
         <p:nvSpPr>
-          <p:cNvPr id="70" name="Shape 68"/>
+          <p:cNvPr id="88" name="Shape 86"/>
           <p:cNvSpPr/>
           <p:nvPr/>
         </p:nvSpPr>
@@ -6712,7 +7523,7 @@
       </p:sp>
       <p:sp>
         <p:nvSpPr>
-          <p:cNvPr id="71" name="Text 69"/>
+          <p:cNvPr id="89" name="Text 87"/>
           <p:cNvSpPr/>
           <p:nvPr/>
         </p:nvSpPr>
@@ -6751,7 +7562,7 @@
       </p:sp>
       <p:sp>
         <p:nvSpPr>
-          <p:cNvPr id="72" name="Shape 70"/>
+          <p:cNvPr id="90" name="Shape 88"/>
           <p:cNvSpPr/>
           <p:nvPr/>
         </p:nvSpPr>
@@ -6771,7 +7582,7 @@
       </p:sp>
       <p:sp>
         <p:nvSpPr>
-          <p:cNvPr id="73" name="Text 71"/>
+          <p:cNvPr id="91" name="Text 89"/>
           <p:cNvSpPr/>
           <p:nvPr/>
         </p:nvSpPr>
@@ -6810,7 +7621,7 @@
       </p:sp>
       <p:sp>
         <p:nvSpPr>
-          <p:cNvPr id="74" name="Text 72"/>
+          <p:cNvPr id="92" name="Text 90"/>
           <p:cNvSpPr/>
           <p:nvPr/>
         </p:nvSpPr>

</xml_diff>

<commit_message>
RN devient NN (neural network) : RN est deja pris en francais
Co-Authored-By: Claude Opus 5 <noreply@anthropic.com>
</commit_message>
<xml_diff>
--- a/slides/Genese-de-l-IA.pptx
+++ b/slides/Genese-de-l-IA.pptx
@@ -3408,7 +3408,7 @@
                 <a:ea typeface="Calibri" pitchFamily="34" charset="-122"/>
                 <a:cs typeface="Calibri" pitchFamily="34" charset="-120"/>
               </a:rPr>
-              <a:t>RN</a:t>
+              <a:t>NN</a:t>
             </a:r>
             <a:endParaRPr lang="en-US" sz="650" dirty="0"/>
           </a:p>
@@ -3931,7 +3931,7 @@
                 <a:ea typeface="Calibri" pitchFamily="34" charset="-122"/>
                 <a:cs typeface="Calibri" pitchFamily="34" charset="-120"/>
               </a:rPr>
-              <a:t>RN</a:t>
+              <a:t>NN</a:t>
             </a:r>
             <a:endParaRPr lang="en-US" sz="650" dirty="0"/>
           </a:p>
@@ -4290,7 +4290,7 @@
                 <a:ea typeface="Calibri" pitchFamily="34" charset="-122"/>
                 <a:cs typeface="Calibri" pitchFamily="34" charset="-120"/>
               </a:rPr>
-              <a:t>RN</a:t>
+              <a:t>NN</a:t>
             </a:r>
             <a:endParaRPr lang="en-US" sz="650" dirty="0"/>
           </a:p>
@@ -4852,7 +4852,7 @@
                 <a:ea typeface="Calibri" pitchFamily="34" charset="-122"/>
                 <a:cs typeface="Calibri" pitchFamily="34" charset="-120"/>
               </a:rPr>
-              <a:t>RN</a:t>
+              <a:t>NN</a:t>
             </a:r>
             <a:endParaRPr lang="en-US" sz="600" dirty="0"/>
           </a:p>
@@ -4891,7 +4891,7 @@
                 <a:ea typeface="Calibri Light" pitchFamily="34" charset="-122"/>
                 <a:cs typeface="Calibri Light" pitchFamily="34" charset="-120"/>
               </a:rPr>
-              <a:t>réseau de neurones — les trois seules étapes qui en sont un</a:t>
+              <a:t>neural network — les trois seules étapes qui en sont un</a:t>
             </a:r>
             <a:endParaRPr lang="en-US" sz="1050" dirty="0"/>
           </a:p>

</xml_diff>